<commit_message>
Update requirements and refresh presentations
- requirements/pyproject: drop unused Markdown dependency (reports build
  Markdown by hand); clarify that security.txt, disclosure email, and the LLM
  client use only the standard library
- product walkthrough deck: add Responsible Disclosure usage + code slides
  (24 slides), refresh test count 88 -> 111, renumber footers
- proposal deck (PPTX) + slide plan (DOCX): 88 -> 111 tests, mention the
  responsible-disclosure feature in solution and functional requirements
</commit_message>
<xml_diff>
--- a/SecurityOps-Assistant-Proposal.pptx
+++ b/SecurityOps-Assistant-Proposal.pptx
@@ -605,7 +605,7 @@
           <a:p>
             <a:r>
               <a:rPr lang="en-US" dirty="0"/>
-              <a:t>I followed an Agile, iterative methodology, building the system one module at a time rather than attempting everything at once. Each short sprint took a single component — for example the database layer, then the workflow engine, then the bug bounty module — through the same cycle: plan, design, build, test, integrate, and review. This meant that at the end of every sprint I had a working, tested piece of the system rather than a large untested whole. The testing strategy has three parts: automated unit tests written with pytest that now number 88 and cover the non-visual logic; headless testing of the core, which is possible because the core does not depend on the interface; and manual verification of the graphical interface. New modules were continuously integrated into the shared platform — the same database, engine, and reporting system — so the application always remained runnable.</a:t>
+              <a:t>I followed an Agile, iterative methodology, building the system one module at a time rather than attempting everything at once. Each short sprint took a single component — for example the database layer, then the workflow engine, then the bug bounty module — through the same cycle: plan, design, build, test, integrate, and review. This meant that at the end of every sprint I had a working, tested piece of the system rather than a large untested whole. The testing strategy has three parts: automated unit tests written with pytest that now number 111 and cover the non-visual logic; headless testing of the core, which is possible because the core does not depend on the interface; and manual verification of the graphical interface. New modules were continuously integrated into the shared platform — the same database, engine, and reporting system — so the application always remained runnable.</a:t>
             </a:r>
             <a:endParaRPr lang="en-US" dirty="0"/>
           </a:p>
@@ -957,7 +957,7 @@
           <a:p>
             <a:r>
               <a:rPr lang="en-US" dirty="0"/>
-              <a:t>The expected outcomes fall into three groups. Technically, the project delivers a working, fully offline assessment platform with a modular, extensible, and well-tested codebase — currently 88 automated tests — plus a reusable AI workflow and reporting engine that other tools could build on. For the user, the outcomes are practical: assessments are faster and guided, requiring less manual effort; privacy is strong and authorization is enforced; and the reports produced are consistent and professional. From a business and academic standpoint, the platform lowers the skill barrier for security testing, provides a reproducible and auditable methodology, and serves as a foundation for further research — for example into automated finding correlation. In short, the project produces both a usable tool and a base for future work.</a:t>
+              <a:t>The expected outcomes fall into three groups. Technically, the project delivers a working, fully offline assessment platform with a modular, extensible, and well-tested codebase — currently 111 automated tests — plus a reusable AI workflow and reporting engine that other tools could build on. For the user, the outcomes are practical: assessments are faster and guided, requiring less manual effort; privacy is strong and authorization is enforced; and the reports produced are consistent and professional. From a business and academic standpoint, the platform lowers the skill barrier for security testing, provides a reproducible and auditable methodology, and serves as a foundation for further research — for example into automated finding correlation. In short, the project produces both a usable tool and a base for future work.</a:t>
             </a:r>
             <a:endParaRPr lang="en-US" dirty="0"/>
           </a:p>
@@ -1749,7 +1749,7 @@
           <a:p>
             <a:r>
               <a:rPr lang="en-US" dirty="0"/>
-              <a:t>The architecture is layered, and dependencies point in one direction only. At the top is the PySide6 graphical interface. Below it are plugins — each feature is a self-contained plugin tab. Plugins use the mid-layer services: the workflow engine, the AI planner and local model, and the reporting system. At the bottom sit the core services — configuration, logging, the SQLite database, background threading, and the tool catalog — plus the data models. Now the component flow, step by step: the user's goal goes to the planner, which produces a plan; the plan passes through an approval gate where the human selects which steps to run; approved steps go to the execution engine, which launches the real tools as background processes; the tools' output is captured and passed to parsers that extract findings; and everything is written to the project database. The data flow, therefore, is: raw tool output becomes structured findings, which are stored in the project, and finally rendered into a report. Because the core never imports the interface, it can be tested headlessly — which is how the project reached 88 automated tests.</a:t>
+              <a:t>The architecture is layered, and dependencies point in one direction only. At the top is the PySide6 graphical interface. Below it are plugins — each feature is a self-contained plugin tab. Plugins use the mid-layer services: the workflow engine, the AI planner and local model, and the reporting system. At the bottom sit the core services — configuration, logging, the SQLite database, background threading, and the tool catalog — plus the data models. Now the component flow, step by step: the user's goal goes to the planner, which produces a plan; the plan passes through an approval gate where the human selects which steps to run; approved steps go to the execution engine, which launches the real tools as background processes; the tools' output is captured and passed to parsers that extract findings; and everything is written to the project database. The data flow, therefore, is: raw tool output becomes structured findings, which are stored in the project, and finally rendered into a report. Because the core never imports the interface, it can be tested headlessly — which is how the project reached 111 automated tests.</a:t>
             </a:r>
             <a:endParaRPr lang="en-US" dirty="0"/>
           </a:p>
@@ -3860,7 +3860,7 @@
                 <a:ea typeface="Calibri" pitchFamily="34" charset="-122"/>
                 <a:cs typeface="Calibri" pitchFamily="34" charset="-120"/>
               </a:rPr>
-              <a:t>Unit tests with pytest (88 passing) covering all non-UI logic</a:t>
+              <a:t>Unit tests with pytest (111 passing) covering all non-UI logic</a:t>
             </a:r>
             <a:endParaRPr lang="en-US" sz="1250" dirty="0"/>
           </a:p>
@@ -5210,11 +5210,11 @@
         <p:spPr>
           <a:xfrm>
             <a:off x="502920" y="1600200"/>
-            <a:ext cx="11201400" cy="521208"/>
+            <a:ext cx="11201400" cy="437769"/>
           </a:xfrm>
           <a:prstGeom prst="roundRect">
             <a:avLst>
-              <a:gd name="adj" fmla="val 14035"/>
+              <a:gd name="adj" fmla="val 16710"/>
             </a:avLst>
           </a:prstGeom>
           <a:solidFill>
@@ -5243,7 +5243,7 @@
         </p:nvSpPr>
         <p:spPr>
           <a:xfrm>
-            <a:off x="731520" y="1632204"/>
+            <a:off x="731520" y="1590485"/>
             <a:ext cx="457200" cy="457200"/>
           </a:xfrm>
           <a:prstGeom prst="ellipse">
@@ -5263,7 +5263,7 @@
         </p:nvSpPr>
         <p:spPr>
           <a:xfrm>
-            <a:off x="731520" y="1632204"/>
+            <a:off x="731520" y="1590485"/>
             <a:ext cx="457200" cy="457200"/>
           </a:xfrm>
           <a:prstGeom prst="rect">
@@ -5303,7 +5303,7 @@
         <p:spPr>
           <a:xfrm>
             <a:off x="1417320" y="1600200"/>
-            <a:ext cx="10058400" cy="521208"/>
+            <a:ext cx="10058400" cy="437769"/>
           </a:xfrm>
           <a:prstGeom prst="rect">
             <a:avLst/>
@@ -5341,12 +5341,12 @@
         </p:nvSpPr>
         <p:spPr>
           <a:xfrm>
-            <a:off x="502920" y="2267712"/>
-            <a:ext cx="11201400" cy="521208"/>
+            <a:off x="502920" y="2184273"/>
+            <a:ext cx="11201400" cy="437769"/>
           </a:xfrm>
           <a:prstGeom prst="roundRect">
             <a:avLst>
-              <a:gd name="adj" fmla="val 14035"/>
+              <a:gd name="adj" fmla="val 16710"/>
             </a:avLst>
           </a:prstGeom>
           <a:solidFill>
@@ -5375,7 +5375,7 @@
         </p:nvSpPr>
         <p:spPr>
           <a:xfrm>
-            <a:off x="731520" y="2299716"/>
+            <a:off x="731520" y="2174558"/>
             <a:ext cx="457200" cy="457200"/>
           </a:xfrm>
           <a:prstGeom prst="ellipse">
@@ -5395,7 +5395,7 @@
         </p:nvSpPr>
         <p:spPr>
           <a:xfrm>
-            <a:off x="731520" y="2299716"/>
+            <a:off x="731520" y="2174558"/>
             <a:ext cx="457200" cy="457200"/>
           </a:xfrm>
           <a:prstGeom prst="rect">
@@ -5434,8 +5434,8 @@
         </p:nvSpPr>
         <p:spPr>
           <a:xfrm>
-            <a:off x="1417320" y="2267712"/>
-            <a:ext cx="10058400" cy="521208"/>
+            <a:off x="1417320" y="2184273"/>
+            <a:ext cx="10058400" cy="437769"/>
           </a:xfrm>
           <a:prstGeom prst="rect">
             <a:avLst/>
@@ -5473,12 +5473,12 @@
         </p:nvSpPr>
         <p:spPr>
           <a:xfrm>
-            <a:off x="502920" y="2935224"/>
-            <a:ext cx="11201400" cy="521208"/>
+            <a:off x="502920" y="2768346"/>
+            <a:ext cx="11201400" cy="437769"/>
           </a:xfrm>
           <a:prstGeom prst="roundRect">
             <a:avLst>
-              <a:gd name="adj" fmla="val 14035"/>
+              <a:gd name="adj" fmla="val 16710"/>
             </a:avLst>
           </a:prstGeom>
           <a:solidFill>
@@ -5507,7 +5507,7 @@
         </p:nvSpPr>
         <p:spPr>
           <a:xfrm>
-            <a:off x="731520" y="2967228"/>
+            <a:off x="731520" y="2758631"/>
             <a:ext cx="457200" cy="457200"/>
           </a:xfrm>
           <a:prstGeom prst="ellipse">
@@ -5527,7 +5527,7 @@
         </p:nvSpPr>
         <p:spPr>
           <a:xfrm>
-            <a:off x="731520" y="2967228"/>
+            <a:off x="731520" y="2758631"/>
             <a:ext cx="457200" cy="457200"/>
           </a:xfrm>
           <a:prstGeom prst="rect">
@@ -5566,8 +5566,8 @@
         </p:nvSpPr>
         <p:spPr>
           <a:xfrm>
-            <a:off x="1417320" y="2935224"/>
-            <a:ext cx="10058400" cy="521208"/>
+            <a:off x="1417320" y="2768346"/>
+            <a:ext cx="10058400" cy="437769"/>
           </a:xfrm>
           <a:prstGeom prst="rect">
             <a:avLst/>
@@ -5605,12 +5605,12 @@
         </p:nvSpPr>
         <p:spPr>
           <a:xfrm>
-            <a:off x="502920" y="3602736"/>
-            <a:ext cx="11201400" cy="521208"/>
+            <a:off x="502920" y="3352419"/>
+            <a:ext cx="11201400" cy="437769"/>
           </a:xfrm>
           <a:prstGeom prst="roundRect">
             <a:avLst>
-              <a:gd name="adj" fmla="val 14035"/>
+              <a:gd name="adj" fmla="val 16710"/>
             </a:avLst>
           </a:prstGeom>
           <a:solidFill>
@@ -5639,7 +5639,7 @@
         </p:nvSpPr>
         <p:spPr>
           <a:xfrm>
-            <a:off x="731520" y="3634740"/>
+            <a:off x="731520" y="3342703"/>
             <a:ext cx="457200" cy="457200"/>
           </a:xfrm>
           <a:prstGeom prst="ellipse">
@@ -5659,7 +5659,7 @@
         </p:nvSpPr>
         <p:spPr>
           <a:xfrm>
-            <a:off x="731520" y="3634740"/>
+            <a:off x="731520" y="3342703"/>
             <a:ext cx="457200" cy="457200"/>
           </a:xfrm>
           <a:prstGeom prst="rect">
@@ -5698,8 +5698,8 @@
         </p:nvSpPr>
         <p:spPr>
           <a:xfrm>
-            <a:off x="1417320" y="3602736"/>
-            <a:ext cx="10058400" cy="521208"/>
+            <a:off x="1417320" y="3352419"/>
+            <a:ext cx="10058400" cy="437769"/>
           </a:xfrm>
           <a:prstGeom prst="rect">
             <a:avLst/>
@@ -5737,12 +5737,12 @@
         </p:nvSpPr>
         <p:spPr>
           <a:xfrm>
-            <a:off x="502920" y="4270248"/>
-            <a:ext cx="11201400" cy="521208"/>
+            <a:off x="502920" y="3936492"/>
+            <a:ext cx="11201400" cy="437769"/>
           </a:xfrm>
           <a:prstGeom prst="roundRect">
             <a:avLst>
-              <a:gd name="adj" fmla="val 14035"/>
+              <a:gd name="adj" fmla="val 16710"/>
             </a:avLst>
           </a:prstGeom>
           <a:solidFill>
@@ -5771,7 +5771,7 @@
         </p:nvSpPr>
         <p:spPr>
           <a:xfrm>
-            <a:off x="731520" y="4302252"/>
+            <a:off x="731520" y="3926776"/>
             <a:ext cx="457200" cy="457200"/>
           </a:xfrm>
           <a:prstGeom prst="ellipse">
@@ -5791,7 +5791,7 @@
         </p:nvSpPr>
         <p:spPr>
           <a:xfrm>
-            <a:off x="731520" y="4302252"/>
+            <a:off x="731520" y="3926776"/>
             <a:ext cx="457200" cy="457200"/>
           </a:xfrm>
           <a:prstGeom prst="rect">
@@ -5830,8 +5830,8 @@
         </p:nvSpPr>
         <p:spPr>
           <a:xfrm>
-            <a:off x="1417320" y="4270248"/>
-            <a:ext cx="10058400" cy="521208"/>
+            <a:off x="1417320" y="3936492"/>
+            <a:ext cx="10058400" cy="437769"/>
           </a:xfrm>
           <a:prstGeom prst="rect">
             <a:avLst/>
@@ -5869,12 +5869,12 @@
         </p:nvSpPr>
         <p:spPr>
           <a:xfrm>
-            <a:off x="502920" y="4937760"/>
-            <a:ext cx="11201400" cy="521208"/>
+            <a:off x="502920" y="4520565"/>
+            <a:ext cx="11201400" cy="437769"/>
           </a:xfrm>
           <a:prstGeom prst="roundRect">
             <a:avLst>
-              <a:gd name="adj" fmla="val 14035"/>
+              <a:gd name="adj" fmla="val 16710"/>
             </a:avLst>
           </a:prstGeom>
           <a:solidFill>
@@ -5903,7 +5903,7 @@
         </p:nvSpPr>
         <p:spPr>
           <a:xfrm>
-            <a:off x="731520" y="4969764"/>
+            <a:off x="731520" y="4510850"/>
             <a:ext cx="457200" cy="457200"/>
           </a:xfrm>
           <a:prstGeom prst="ellipse">
@@ -5923,7 +5923,7 @@
         </p:nvSpPr>
         <p:spPr>
           <a:xfrm>
-            <a:off x="731520" y="4969764"/>
+            <a:off x="731520" y="4510850"/>
             <a:ext cx="457200" cy="457200"/>
           </a:xfrm>
           <a:prstGeom prst="rect">
@@ -5962,8 +5962,8 @@
         </p:nvSpPr>
         <p:spPr>
           <a:xfrm>
-            <a:off x="1417320" y="4937760"/>
-            <a:ext cx="10058400" cy="521208"/>
+            <a:off x="1417320" y="4520565"/>
+            <a:ext cx="10058400" cy="437769"/>
           </a:xfrm>
           <a:prstGeom prst="rect">
             <a:avLst/>
@@ -6001,12 +6001,12 @@
         </p:nvSpPr>
         <p:spPr>
           <a:xfrm>
-            <a:off x="502920" y="5605272"/>
-            <a:ext cx="11201400" cy="521208"/>
+            <a:off x="502920" y="5104638"/>
+            <a:ext cx="11201400" cy="437769"/>
           </a:xfrm>
           <a:prstGeom prst="roundRect">
             <a:avLst>
-              <a:gd name="adj" fmla="val 14035"/>
+              <a:gd name="adj" fmla="val 16710"/>
             </a:avLst>
           </a:prstGeom>
           <a:solidFill>
@@ -6035,7 +6035,7 @@
         </p:nvSpPr>
         <p:spPr>
           <a:xfrm>
-            <a:off x="731520" y="5637276"/>
+            <a:off x="731520" y="5094922"/>
             <a:ext cx="457200" cy="457200"/>
           </a:xfrm>
           <a:prstGeom prst="ellipse">
@@ -6055,7 +6055,7 @@
         </p:nvSpPr>
         <p:spPr>
           <a:xfrm>
-            <a:off x="731520" y="5637276"/>
+            <a:off x="731520" y="5094922"/>
             <a:ext cx="457200" cy="457200"/>
           </a:xfrm>
           <a:prstGeom prst="rect">
@@ -6094,8 +6094,8 @@
         </p:nvSpPr>
         <p:spPr>
           <a:xfrm>
-            <a:off x="1417320" y="5605272"/>
-            <a:ext cx="10058400" cy="521208"/>
+            <a:off x="1417320" y="5104638"/>
+            <a:ext cx="10058400" cy="437769"/>
           </a:xfrm>
           <a:prstGeom prst="rect">
             <a:avLst/>
@@ -6120,6 +6120,138 @@
                 <a:cs typeface="Calibri" pitchFamily="34" charset="-120"/>
               </a:rPr>
               <a:t>Generate HTML / PDF / Markdown assessment reports</a:t>
+            </a:r>
+            <a:endParaRPr lang="en-US" sz="1500" dirty="0"/>
+          </a:p>
+        </p:txBody>
+      </p:sp>
+      <p:sp>
+        <p:nvSpPr>
+          <p:cNvPr id="33" name="Shape 31"/>
+          <p:cNvSpPr/>
+          <p:nvPr/>
+        </p:nvSpPr>
+        <p:spPr>
+          <a:xfrm>
+            <a:off x="502920" y="5688711"/>
+            <a:ext cx="11201400" cy="437769"/>
+          </a:xfrm>
+          <a:prstGeom prst="roundRect">
+            <a:avLst>
+              <a:gd name="adj" fmla="val 16710"/>
+            </a:avLst>
+          </a:prstGeom>
+          <a:solidFill>
+            <a:srgbClr val="F3F6FB"/>
+          </a:solidFill>
+          <a:ln w="12700">
+            <a:solidFill>
+              <a:srgbClr val="D9E1EC"/>
+            </a:solidFill>
+            <a:prstDash val="solid"/>
+          </a:ln>
+          <a:effectLst>
+            <a:outerShdw sx="100000" sy="100000" kx="0" ky="0" algn="bl" rotWithShape="0" blurRad="88900" dist="38100" dir="5400000">
+              <a:srgbClr val="8494A8">
+                <a:alpha val="28000"/>
+              </a:srgbClr>
+            </a:outerShdw>
+          </a:effectLst>
+        </p:spPr>
+      </p:sp>
+      <p:sp>
+        <p:nvSpPr>
+          <p:cNvPr id="34" name="Shape 32"/>
+          <p:cNvSpPr/>
+          <p:nvPr/>
+        </p:nvSpPr>
+        <p:spPr>
+          <a:xfrm>
+            <a:off x="731520" y="5678995"/>
+            <a:ext cx="457200" cy="457200"/>
+          </a:xfrm>
+          <a:prstGeom prst="ellipse">
+            <a:avLst/>
+          </a:prstGeom>
+          <a:solidFill>
+            <a:srgbClr val="2C9CA6"/>
+          </a:solidFill>
+          <a:ln/>
+        </p:spPr>
+      </p:sp>
+      <p:sp>
+        <p:nvSpPr>
+          <p:cNvPr id="35" name="Text 33"/>
+          <p:cNvSpPr/>
+          <p:nvPr/>
+        </p:nvSpPr>
+        <p:spPr>
+          <a:xfrm>
+            <a:off x="731520" y="5678995"/>
+            <a:ext cx="457200" cy="457200"/>
+          </a:xfrm>
+          <a:prstGeom prst="rect">
+            <a:avLst/>
+          </a:prstGeom>
+          <a:noFill/>
+          <a:ln/>
+        </p:spPr>
+        <p:txBody>
+          <a:bodyPr wrap="square" rtlCol="0" anchor="ctr"/>
+          <a:lstStyle/>
+          <a:p>
+            <a:pPr algn="ctr" indent="0" marL="0">
+              <a:buNone/>
+            </a:pPr>
+            <a:r>
+              <a:rPr lang="en-US" sz="1500" b="1" dirty="0">
+                <a:solidFill>
+                  <a:srgbClr val="FFFFFF"/>
+                </a:solidFill>
+                <a:latin typeface="Calibri" pitchFamily="34" charset="0"/>
+                <a:ea typeface="Calibri" pitchFamily="34" charset="-122"/>
+                <a:cs typeface="Calibri" pitchFamily="34" charset="-120"/>
+              </a:rPr>
+              <a:t>8</a:t>
+            </a:r>
+            <a:endParaRPr lang="en-US" sz="1500" dirty="0"/>
+          </a:p>
+        </p:txBody>
+      </p:sp>
+      <p:sp>
+        <p:nvSpPr>
+          <p:cNvPr id="36" name="Text 34"/>
+          <p:cNvSpPr/>
+          <p:nvPr/>
+        </p:nvSpPr>
+        <p:spPr>
+          <a:xfrm>
+            <a:off x="1417320" y="5688711"/>
+            <a:ext cx="10058400" cy="437769"/>
+          </a:xfrm>
+          <a:prstGeom prst="rect">
+            <a:avLst/>
+          </a:prstGeom>
+          <a:noFill/>
+          <a:ln/>
+        </p:spPr>
+        <p:txBody>
+          <a:bodyPr wrap="square" rtlCol="0" anchor="ctr"/>
+          <a:lstStyle/>
+          <a:p>
+            <a:pPr indent="0" marL="0">
+              <a:buNone/>
+            </a:pPr>
+            <a:r>
+              <a:rPr lang="en-US" sz="1500" dirty="0">
+                <a:solidFill>
+                  <a:srgbClr val="1B2430"/>
+                </a:solidFill>
+                <a:latin typeface="Calibri" pitchFamily="34" charset="0"/>
+                <a:ea typeface="Calibri" pitchFamily="34" charset="-122"/>
+                <a:cs typeface="Calibri" pitchFamily="34" charset="-120"/>
+              </a:rPr>
+              <a:t>Draft, review, and record responsible-disclosure reports (never auto-sent)</a:t>
             </a:r>
             <a:endParaRPr lang="en-US" sz="1500" dirty="0"/>
           </a:p>
@@ -7459,7 +7591,7 @@
                 <a:ea typeface="Calibri" pitchFamily="34" charset="-122"/>
                 <a:cs typeface="Calibri" pitchFamily="34" charset="-120"/>
               </a:rPr>
-              <a:t>Modular, extensible, well-tested codebase (88 tests)</a:t>
+              <a:t>Modular, extensible, well-tested codebase (111 tests)</a:t>
             </a:r>
             <a:endParaRPr lang="en-US" sz="1250" dirty="0"/>
           </a:p>
@@ -13171,11 +13303,11 @@
         <p:spPr>
           <a:xfrm>
             <a:off x="502920" y="1600200"/>
-            <a:ext cx="11201400" cy="788213"/>
+            <a:ext cx="11201400" cy="632460"/>
           </a:xfrm>
           <a:prstGeom prst="roundRect">
             <a:avLst>
-              <a:gd name="adj" fmla="val 9281"/>
+              <a:gd name="adj" fmla="val 11566"/>
             </a:avLst>
           </a:prstGeom>
           <a:solidFill>
@@ -13204,7 +13336,7 @@
         </p:nvSpPr>
         <p:spPr>
           <a:xfrm>
-            <a:off x="731520" y="1765706"/>
+            <a:off x="731520" y="1687830"/>
             <a:ext cx="457200" cy="457200"/>
           </a:xfrm>
           <a:prstGeom prst="ellipse">
@@ -13224,7 +13356,7 @@
         </p:nvSpPr>
         <p:spPr>
           <a:xfrm>
-            <a:off x="731520" y="1765706"/>
+            <a:off x="731520" y="1687830"/>
             <a:ext cx="457200" cy="457200"/>
           </a:xfrm>
           <a:prstGeom prst="rect">
@@ -13264,7 +13396,7 @@
         <p:spPr>
           <a:xfrm>
             <a:off x="1417320" y="1600200"/>
-            <a:ext cx="10058400" cy="788213"/>
+            <a:ext cx="10058400" cy="632460"/>
           </a:xfrm>
           <a:prstGeom prst="rect">
             <a:avLst/>
@@ -13302,12 +13434,12 @@
         </p:nvSpPr>
         <p:spPr>
           <a:xfrm>
-            <a:off x="502920" y="2534717"/>
-            <a:ext cx="11201400" cy="788213"/>
+            <a:off x="502920" y="2378964"/>
+            <a:ext cx="11201400" cy="632460"/>
           </a:xfrm>
           <a:prstGeom prst="roundRect">
             <a:avLst>
-              <a:gd name="adj" fmla="val 9281"/>
+              <a:gd name="adj" fmla="val 11566"/>
             </a:avLst>
           </a:prstGeom>
           <a:solidFill>
@@ -13336,7 +13468,7 @@
         </p:nvSpPr>
         <p:spPr>
           <a:xfrm>
-            <a:off x="731520" y="2700223"/>
+            <a:off x="731520" y="2466594"/>
             <a:ext cx="457200" cy="457200"/>
           </a:xfrm>
           <a:prstGeom prst="ellipse">
@@ -13356,7 +13488,7 @@
         </p:nvSpPr>
         <p:spPr>
           <a:xfrm>
-            <a:off x="731520" y="2700223"/>
+            <a:off x="731520" y="2466594"/>
             <a:ext cx="457200" cy="457200"/>
           </a:xfrm>
           <a:prstGeom prst="rect">
@@ -13395,8 +13527,8 @@
         </p:nvSpPr>
         <p:spPr>
           <a:xfrm>
-            <a:off x="1417320" y="2534717"/>
-            <a:ext cx="10058400" cy="788213"/>
+            <a:off x="1417320" y="2378964"/>
+            <a:ext cx="10058400" cy="632460"/>
           </a:xfrm>
           <a:prstGeom prst="rect">
             <a:avLst/>
@@ -13434,12 +13566,12 @@
         </p:nvSpPr>
         <p:spPr>
           <a:xfrm>
-            <a:off x="502920" y="3469234"/>
-            <a:ext cx="11201400" cy="788213"/>
+            <a:off x="502920" y="3157728"/>
+            <a:ext cx="11201400" cy="632460"/>
           </a:xfrm>
           <a:prstGeom prst="roundRect">
             <a:avLst>
-              <a:gd name="adj" fmla="val 9281"/>
+              <a:gd name="adj" fmla="val 11566"/>
             </a:avLst>
           </a:prstGeom>
           <a:solidFill>
@@ -13468,7 +13600,7 @@
         </p:nvSpPr>
         <p:spPr>
           <a:xfrm>
-            <a:off x="731520" y="3634740"/>
+            <a:off x="731520" y="3245358"/>
             <a:ext cx="457200" cy="457200"/>
           </a:xfrm>
           <a:prstGeom prst="ellipse">
@@ -13488,7 +13620,7 @@
         </p:nvSpPr>
         <p:spPr>
           <a:xfrm>
-            <a:off x="731520" y="3634740"/>
+            <a:off x="731520" y="3245358"/>
             <a:ext cx="457200" cy="457200"/>
           </a:xfrm>
           <a:prstGeom prst="rect">
@@ -13527,8 +13659,8 @@
         </p:nvSpPr>
         <p:spPr>
           <a:xfrm>
-            <a:off x="1417320" y="3469234"/>
-            <a:ext cx="10058400" cy="788213"/>
+            <a:off x="1417320" y="3157728"/>
+            <a:ext cx="10058400" cy="632460"/>
           </a:xfrm>
           <a:prstGeom prst="rect">
             <a:avLst/>
@@ -13566,12 +13698,12 @@
         </p:nvSpPr>
         <p:spPr>
           <a:xfrm>
-            <a:off x="502920" y="4403750"/>
-            <a:ext cx="11201400" cy="788213"/>
+            <a:off x="502920" y="3936492"/>
+            <a:ext cx="11201400" cy="632460"/>
           </a:xfrm>
           <a:prstGeom prst="roundRect">
             <a:avLst>
-              <a:gd name="adj" fmla="val 9281"/>
+              <a:gd name="adj" fmla="val 11566"/>
             </a:avLst>
           </a:prstGeom>
           <a:solidFill>
@@ -13600,7 +13732,7 @@
         </p:nvSpPr>
         <p:spPr>
           <a:xfrm>
-            <a:off x="731520" y="4569257"/>
+            <a:off x="731520" y="4024122"/>
             <a:ext cx="457200" cy="457200"/>
           </a:xfrm>
           <a:prstGeom prst="ellipse">
@@ -13620,7 +13752,7 @@
         </p:nvSpPr>
         <p:spPr>
           <a:xfrm>
-            <a:off x="731520" y="4569257"/>
+            <a:off x="731520" y="4024122"/>
             <a:ext cx="457200" cy="457200"/>
           </a:xfrm>
           <a:prstGeom prst="rect">
@@ -13659,8 +13791,8 @@
         </p:nvSpPr>
         <p:spPr>
           <a:xfrm>
-            <a:off x="1417320" y="4403750"/>
-            <a:ext cx="10058400" cy="788213"/>
+            <a:off x="1417320" y="3936492"/>
+            <a:ext cx="10058400" cy="632460"/>
           </a:xfrm>
           <a:prstGeom prst="rect">
             <a:avLst/>
@@ -13684,7 +13816,7 @@
                 <a:ea typeface="Calibri" pitchFamily="34" charset="-122"/>
                 <a:cs typeface="Calibri" pitchFamily="34" charset="-120"/>
               </a:rPr>
-              <a:t>Feature: auto tool launcher, findings dashboard, and report generator</a:t>
+              <a:t>Feature: responsible disclosure — curate findings, draft &amp; record vendor reports</a:t>
             </a:r>
             <a:endParaRPr lang="en-US" sz="1500" dirty="0"/>
           </a:p>
@@ -13698,12 +13830,12 @@
         </p:nvSpPr>
         <p:spPr>
           <a:xfrm>
-            <a:off x="502920" y="5338267"/>
-            <a:ext cx="11201400" cy="788213"/>
+            <a:off x="502920" y="4715256"/>
+            <a:ext cx="11201400" cy="632460"/>
           </a:xfrm>
           <a:prstGeom prst="roundRect">
             <a:avLst>
-              <a:gd name="adj" fmla="val 9281"/>
+              <a:gd name="adj" fmla="val 11566"/>
             </a:avLst>
           </a:prstGeom>
           <a:solidFill>
@@ -13732,7 +13864,7 @@
         </p:nvSpPr>
         <p:spPr>
           <a:xfrm>
-            <a:off x="731520" y="5503774"/>
+            <a:off x="731520" y="4802886"/>
             <a:ext cx="457200" cy="457200"/>
           </a:xfrm>
           <a:prstGeom prst="ellipse">
@@ -13752,7 +13884,7 @@
         </p:nvSpPr>
         <p:spPr>
           <a:xfrm>
-            <a:off x="731520" y="5503774"/>
+            <a:off x="731520" y="4802886"/>
             <a:ext cx="457200" cy="457200"/>
           </a:xfrm>
           <a:prstGeom prst="rect">
@@ -13791,8 +13923,140 @@
         </p:nvSpPr>
         <p:spPr>
           <a:xfrm>
-            <a:off x="1417320" y="5338267"/>
-            <a:ext cx="10058400" cy="788213"/>
+            <a:off x="1417320" y="4715256"/>
+            <a:ext cx="10058400" cy="632460"/>
+          </a:xfrm>
+          <a:prstGeom prst="rect">
+            <a:avLst/>
+          </a:prstGeom>
+          <a:noFill/>
+          <a:ln/>
+        </p:spPr>
+        <p:txBody>
+          <a:bodyPr wrap="square" rtlCol="0" anchor="ctr"/>
+          <a:lstStyle/>
+          <a:p>
+            <a:pPr indent="0" marL="0">
+              <a:buNone/>
+            </a:pPr>
+            <a:r>
+              <a:rPr lang="en-US" sz="1500" dirty="0">
+                <a:solidFill>
+                  <a:srgbClr val="1B2430"/>
+                </a:solidFill>
+                <a:latin typeface="Calibri" pitchFamily="34" charset="0"/>
+                <a:ea typeface="Calibri" pitchFamily="34" charset="-122"/>
+                <a:cs typeface="Calibri" pitchFamily="34" charset="-120"/>
+              </a:rPr>
+              <a:t>Feature: auto tool launcher, findings dashboard, and report generator</a:t>
+            </a:r>
+            <a:endParaRPr lang="en-US" sz="1500" dirty="0"/>
+          </a:p>
+        </p:txBody>
+      </p:sp>
+      <p:sp>
+        <p:nvSpPr>
+          <p:cNvPr id="25" name="Shape 23"/>
+          <p:cNvSpPr/>
+          <p:nvPr/>
+        </p:nvSpPr>
+        <p:spPr>
+          <a:xfrm>
+            <a:off x="502920" y="5494020"/>
+            <a:ext cx="11201400" cy="632460"/>
+          </a:xfrm>
+          <a:prstGeom prst="roundRect">
+            <a:avLst>
+              <a:gd name="adj" fmla="val 11566"/>
+            </a:avLst>
+          </a:prstGeom>
+          <a:solidFill>
+            <a:srgbClr val="F3F6FB"/>
+          </a:solidFill>
+          <a:ln w="12700">
+            <a:solidFill>
+              <a:srgbClr val="D9E1EC"/>
+            </a:solidFill>
+            <a:prstDash val="solid"/>
+          </a:ln>
+          <a:effectLst>
+            <a:outerShdw sx="100000" sy="100000" kx="0" ky="0" algn="bl" rotWithShape="0" blurRad="88900" dist="38100" dir="5400000">
+              <a:srgbClr val="8494A8">
+                <a:alpha val="28000"/>
+              </a:srgbClr>
+            </a:outerShdw>
+          </a:effectLst>
+        </p:spPr>
+      </p:sp>
+      <p:sp>
+        <p:nvSpPr>
+          <p:cNvPr id="26" name="Shape 24"/>
+          <p:cNvSpPr/>
+          <p:nvPr/>
+        </p:nvSpPr>
+        <p:spPr>
+          <a:xfrm>
+            <a:off x="731520" y="5581650"/>
+            <a:ext cx="457200" cy="457200"/>
+          </a:xfrm>
+          <a:prstGeom prst="ellipse">
+            <a:avLst/>
+          </a:prstGeom>
+          <a:solidFill>
+            <a:srgbClr val="C0392B"/>
+          </a:solidFill>
+          <a:ln/>
+        </p:spPr>
+      </p:sp>
+      <p:sp>
+        <p:nvSpPr>
+          <p:cNvPr id="27" name="Text 25"/>
+          <p:cNvSpPr/>
+          <p:nvPr/>
+        </p:nvSpPr>
+        <p:spPr>
+          <a:xfrm>
+            <a:off x="731520" y="5581650"/>
+            <a:ext cx="457200" cy="457200"/>
+          </a:xfrm>
+          <a:prstGeom prst="rect">
+            <a:avLst/>
+          </a:prstGeom>
+          <a:noFill/>
+          <a:ln/>
+        </p:spPr>
+        <p:txBody>
+          <a:bodyPr wrap="square" rtlCol="0" anchor="ctr"/>
+          <a:lstStyle/>
+          <a:p>
+            <a:pPr algn="ctr" indent="0" marL="0">
+              <a:buNone/>
+            </a:pPr>
+            <a:r>
+              <a:rPr lang="en-US" sz="1500" b="1" dirty="0">
+                <a:solidFill>
+                  <a:srgbClr val="FFFFFF"/>
+                </a:solidFill>
+                <a:latin typeface="Calibri" pitchFamily="34" charset="0"/>
+                <a:ea typeface="Calibri" pitchFamily="34" charset="-122"/>
+                <a:cs typeface="Calibri" pitchFamily="34" charset="-120"/>
+              </a:rPr>
+              <a:t>6</a:t>
+            </a:r>
+            <a:endParaRPr lang="en-US" sz="1500" dirty="0"/>
+          </a:p>
+        </p:txBody>
+      </p:sp>
+      <p:sp>
+        <p:nvSpPr>
+          <p:cNvPr id="28" name="Text 26"/>
+          <p:cNvSpPr/>
+          <p:nvPr/>
+        </p:nvSpPr>
+        <p:spPr>
+          <a:xfrm>
+            <a:off x="1417320" y="5494020"/>
+            <a:ext cx="10058400" cy="632460"/>
           </a:xfrm>
           <a:prstGeom prst="rect">
             <a:avLst/>

</xml_diff>

<commit_message>
docs: update proposal and presentation documents
</commit_message>
<xml_diff>
--- a/SecurityOps-Assistant-Proposal.pptx
+++ b/SecurityOps-Assistant-Proposal.pptx
@@ -4,6 +4,9 @@
   <p:sldMasterIdLst>
     <p:sldMasterId id="2147483648" r:id="rId1"/>
   </p:sldMasterIdLst>
+  <p:notesMasterIdLst>
+    <p:notesMasterId r:id="rId18"/>
+  </p:notesMasterIdLst>
   <p:sldIdLst>
     <p:sldId id="256" r:id="rId2"/>
     <p:sldId id="257" r:id="rId3"/>
@@ -22,9 +25,6 @@
     <p:sldId id="270" r:id="rId16"/>
     <p:sldId id="271" r:id="rId17"/>
   </p:sldIdLst>
-  <p:notesMasterIdLst>
-    <p:notesMasterId r:id="rId18"/>
-  </p:notesMasterIdLst>
   <p:sldSz cx="12192000" cy="6858000"/>
   <p:notesSz cx="6858000" cy="12192000"/>
   <p:defaultTextStyle>
@@ -119,6 +119,11 @@
       </a:defRPr>
     </a:lvl9pPr>
   </p:defaultTextStyle>
+  <p:extLst>
+    <p:ext uri="{EFAFB233-063F-42B5-8137-9DF3F51BA10A}">
+      <p15:sldGuideLst xmlns:p15="http://schemas.microsoft.com/office/powerpoint/2012/main"/>
+    </p:ext>
+  </p:extLst>
 </p:presentation>
 </file>
 
@@ -144,234 +149,10 @@
           <a:chExt cx="0" cy="0"/>
         </a:xfrm>
       </p:grpSpPr>
-      <p:sp>
-        <p:nvSpPr>
-          <p:cNvPr id="2" name="Header Placeholder 1"/>
-          <p:cNvSpPr>
-            <a:spLocks noGrp="1"/>
-          </p:cNvSpPr>
-          <p:nvPr>
-            <p:ph type="hdr" sz="quarter"/>
-          </p:nvPr>
-        </p:nvSpPr>
-        <p:spPr>
-          <a:xfrm>
-            <a:off x="0" y="0"/>
-            <a:ext cx="2971800" cy="458788"/>
-          </a:xfrm>
-          <a:prstGeom prst="rect">
-            <a:avLst/>
-          </a:prstGeom>
-        </p:spPr>
-        <p:txBody>
-          <a:bodyPr vert="horz" lIns="91440" tIns="45720" rIns="91440" bIns="45720" rtlCol="0"/>
-          <a:lstStyle>
-            <a:lvl1pPr algn="l">
-              <a:defRPr sz="1200"/>
-            </a:lvl1pPr>
-          </a:lstStyle>
-          <a:p>
-            <a:endParaRPr lang="en-US"/>
-          </a:p>
-        </p:txBody>
-      </p:sp>
-      <p:sp>
-        <p:nvSpPr>
-          <p:cNvPr id="3" name="Date Placeholder 2"/>
-          <p:cNvSpPr>
-            <a:spLocks noGrp="1"/>
-          </p:cNvSpPr>
-          <p:nvPr>
-            <p:ph type="dt" idx="1"/>
-          </p:nvPr>
-        </p:nvSpPr>
-        <p:spPr>
-          <a:xfrm>
-            <a:off x="3884613" y="0"/>
-            <a:ext cx="2971800" cy="458788"/>
-          </a:xfrm>
-          <a:prstGeom prst="rect">
-            <a:avLst/>
-          </a:prstGeom>
-        </p:spPr>
-        <p:txBody>
-          <a:bodyPr vert="horz" lIns="91440" tIns="45720" rIns="91440" bIns="45720" rtlCol="0"/>
-          <a:lstStyle>
-            <a:lvl1pPr algn="r">
-              <a:defRPr sz="1200"/>
-            </a:lvl1pPr>
-          </a:lstStyle>
-          <a:p>
-            <a:fld id="{5282F153-3F37-0F45-9E97-73ACFA13230C}" type="datetimeFigureOut">
-              <a:rPr lang="en-US"/>
-              <a:t>7/23/19</a:t>
-            </a:fld>
-            <a:endParaRPr lang="en-US"/>
-          </a:p>
-        </p:txBody>
-      </p:sp>
-      <p:sp>
-        <p:nvSpPr>
-          <p:cNvPr id="4" name="Slide Image Placeholder 3"/>
-          <p:cNvSpPr>
-            <a:spLocks noGrp="1" noRot="1" noChangeAspect="1"/>
-          </p:cNvSpPr>
-          <p:nvPr>
-            <p:ph type="sldImg" idx="2"/>
-          </p:nvPr>
-        </p:nvSpPr>
-        <p:spPr>
-          <a:xfrm>
-            <a:off x="685800" y="1143000"/>
-            <a:ext cx="5486400" cy="3086100"/>
-          </a:xfrm>
-          <a:prstGeom prst="rect">
-            <a:avLst/>
-          </a:prstGeom>
-          <a:noFill/>
-          <a:ln w="12700">
-            <a:solidFill>
-              <a:prstClr val="black"/>
-            </a:solidFill>
-          </a:ln>
-        </p:spPr>
-        <p:txBody>
-          <a:bodyPr vert="horz" lIns="91440" tIns="45720" rIns="91440" bIns="45720" rtlCol="0" anchor="ctr"/>
-          <a:lstStyle/>
-          <a:p>
-            <a:endParaRPr lang="en-US"/>
-          </a:p>
-        </p:txBody>
-      </p:sp>
-      <p:sp>
-        <p:nvSpPr>
-          <p:cNvPr id="5" name="Notes Placeholder 4"/>
-          <p:cNvSpPr>
-            <a:spLocks noGrp="1"/>
-          </p:cNvSpPr>
-          <p:nvPr>
-            <p:ph type="body" sz="quarter" idx="3"/>
-          </p:nvPr>
-        </p:nvSpPr>
-        <p:spPr>
-          <a:xfrm>
-            <a:off x="685800" y="4400550"/>
-            <a:ext cx="5486400" cy="3600450"/>
-          </a:xfrm>
-          <a:prstGeom prst="rect">
-            <a:avLst/>
-          </a:prstGeom>
-        </p:spPr>
-        <p:txBody>
-          <a:bodyPr vert="horz" lIns="91440" tIns="45720" rIns="91440" bIns="45720" rtlCol="0"/>
-          <a:lstStyle/>
-          <a:p>
-            <a:pPr lvl="0"/>
-            <a:r>
-              <a:rPr lang="en-US"/>
-              <a:t>Click to edit Master text styles</a:t>
-            </a:r>
-          </a:p>
-          <a:p>
-            <a:pPr lvl="1"/>
-            <a:r>
-              <a:rPr lang="en-US"/>
-              <a:t>Second level</a:t>
-            </a:r>
-          </a:p>
-          <a:p>
-            <a:pPr lvl="2"/>
-            <a:r>
-              <a:rPr lang="en-US"/>
-              <a:t>Third level</a:t>
-            </a:r>
-          </a:p>
-          <a:p>
-            <a:pPr lvl="3"/>
-            <a:r>
-              <a:rPr lang="en-US"/>
-              <a:t>Fourth level</a:t>
-            </a:r>
-          </a:p>
-          <a:p>
-            <a:pPr lvl="4"/>
-            <a:r>
-              <a:rPr lang="en-US"/>
-              <a:t>Fifth level</a:t>
-            </a:r>
-          </a:p>
-        </p:txBody>
-      </p:sp>
-      <p:sp>
-        <p:nvSpPr>
-          <p:cNvPr id="6" name="Footer Placeholder 5"/>
-          <p:cNvSpPr>
-            <a:spLocks noGrp="1"/>
-          </p:cNvSpPr>
-          <p:nvPr>
-            <p:ph type="ftr" sz="quarter" idx="4"/>
-          </p:nvPr>
-        </p:nvSpPr>
-        <p:spPr>
-          <a:xfrm>
-            <a:off x="0" y="8685213"/>
-            <a:ext cx="2971800" cy="458787"/>
-          </a:xfrm>
-          <a:prstGeom prst="rect">
-            <a:avLst/>
-          </a:prstGeom>
-        </p:spPr>
-        <p:txBody>
-          <a:bodyPr vert="horz" lIns="91440" tIns="45720" rIns="91440" bIns="45720" rtlCol="0" anchor="b"/>
-          <a:lstStyle>
-            <a:lvl1pPr algn="l">
-              <a:defRPr sz="1200"/>
-            </a:lvl1pPr>
-          </a:lstStyle>
-          <a:p>
-            <a:endParaRPr lang="en-US"/>
-          </a:p>
-        </p:txBody>
-      </p:sp>
-      <p:sp>
-        <p:nvSpPr>
-          <p:cNvPr id="7" name="Slide Number Placeholder 6"/>
-          <p:cNvSpPr>
-            <a:spLocks noGrp="1"/>
-          </p:cNvSpPr>
-          <p:nvPr>
-            <p:ph type="sldNum" sz="quarter" idx="5"/>
-          </p:nvPr>
-        </p:nvSpPr>
-        <p:spPr>
-          <a:xfrm>
-            <a:off x="3884613" y="8685213"/>
-            <a:ext cx="2971800" cy="458787"/>
-          </a:xfrm>
-          <a:prstGeom prst="rect">
-            <a:avLst/>
-          </a:prstGeom>
-        </p:spPr>
-        <p:txBody>
-          <a:bodyPr vert="horz" lIns="91440" tIns="45720" rIns="91440" bIns="45720" rtlCol="0" anchor="b"/>
-          <a:lstStyle>
-            <a:lvl1pPr algn="r">
-              <a:defRPr sz="1200"/>
-            </a:lvl1pPr>
-          </a:lstStyle>
-          <a:p>
-            <a:fld id="{CE5E9CC1-C706-0F49-92D6-E571CC5EEA8F}" type="slidenum">
-              <a:rPr lang="en-US"/>
-              <a:t>‹#›</a:t>
-            </a:fld>
-            <a:endParaRPr lang="en-US"/>
-          </a:p>
-        </p:txBody>
-      </p:sp>
     </p:spTree>
     <p:extLst>
       <p:ext uri="{BB962C8B-B14F-4D97-AF65-F5344CB8AC3E}">
-        <p14:creationId xmlns:p14="http://schemas.microsoft.com/office/powerpoint/2010/main" val="1024086991"/>
+        <p14:creationId xmlns:p14="http://schemas.microsoft.com/office/powerpoint/2010/main" val="1967568747"/>
       </p:ext>
     </p:extLst>
   </p:cSld>
@@ -519,7 +300,6 @@
               <a:rPr lang="en-US" dirty="0"/>
               <a:t>Good morning. I am [Your Name], and I will be presenting my project titled 'SecurityOps Assistant — a local-first, AI-assisted cybersecurity assessment platform for authorized security testing.' This project is carried out under the guidance of [Guide Name] at [Institute Name]. Over the next few minutes I will walk you through the problem it addresses, the objectives, the proposed solution and its architecture, the technology stack, my development methodology and timeline, and the outcomes I expect. The core idea is simple: give a security analyst a single, fully offline desktop assistant that turns a plain-English goal into a safe, approval-gated assessment workflow, and produces a professional report — without sending any data to the cloud.</a:t>
             </a:r>
-            <a:endParaRPr lang="en-US" dirty="0"/>
           </a:p>
         </p:txBody>
       </p:sp>
@@ -607,7 +387,6 @@
               <a:rPr lang="en-US" dirty="0"/>
               <a:t>I followed an Agile, iterative methodology, building the system one module at a time rather than attempting everything at once. Each short sprint took a single component — for example the database layer, then the workflow engine, then the bug bounty module — through the same cycle: plan, design, build, test, integrate, and review. This meant that at the end of every sprint I had a working, tested piece of the system rather than a large untested whole. The testing strategy has three parts: automated unit tests written with pytest that now number 111 and cover the non-visual logic; headless testing of the core, which is possible because the core does not depend on the interface; and manual verification of the graphical interface. New modules were continuously integrated into the shared platform — the same database, engine, and reporting system — so the application always remained runnable.</a:t>
             </a:r>
-            <a:endParaRPr lang="en-US" dirty="0"/>
           </a:p>
         </p:txBody>
       </p:sp>
@@ -695,7 +474,6 @@
               <a:rPr lang="en-US" dirty="0"/>
               <a:t>This slide shows the project timeline as a simple Gantt chart across roughly eight months. The first month covered the proposal and background research. The second month built the foundation — the core services and the database. Months three and four were the largest phase: the workflow engine and the AI planning and explanation components. Month five delivered the bug bounty module with scope validation. Month six built the reporting system, and testing and hardening ran in parallel across months six and seven. The final phase, in month eight, is documentation and preparation for the viva. The key milestones — marked on the chart — are: proposal approved, core platform working, AI workflow functional, bug bounty module integrated, reporting complete, and final submission. As of now the core, workflow, bug bounty, and reporting modules are implemented and tested.</a:t>
             </a:r>
-            <a:endParaRPr lang="en-US" dirty="0"/>
           </a:p>
         </p:txBody>
       </p:sp>
@@ -783,7 +561,6 @@
               <a:rPr lang="en-US" dirty="0"/>
               <a:t>The functional requirements describe what the system must do. It must accept a natural-language objective and build an assessment plan from it. It must import an engagement's scope and validate targets against it. Before anything runs, it must present the generated commands for the user's explicit approval. Once approved, it must execute the tools in the background and capture their output live. It must then extract, correlate, and highlight the important findings from that output. Throughout, it must manage projects, assets, findings, and evidence — all stored locally. And finally it must generate professional assessment reports in HTML, PDF, and Markdown. Each of these requirements maps directly to a module in the implemented system, and each is covered by tests.</a:t>
             </a:r>
-            <a:endParaRPr lang="en-US" dirty="0"/>
           </a:p>
         </p:txBody>
       </p:sp>
@@ -871,7 +648,6 @@
               <a:rPr lang="en-US" dirty="0"/>
               <a:t>Non-functional requirements describe how well the system behaves. Security is first: authorization is enforced through gates, the assistant refuses harmful or out-of-scope actions, and it never auto-exploits — commands are built only from vetted templates. Performance: long-running scans execute on background threads using Qt's thread pool, so the interface stays responsive. Reliability: the system has robust error handling, and every executed command and its output is written to an audit trail. Scalability: the modular plugin architecture means new features are added by dropping in a plugin, without modifying the core, and new tools by adding a catalog entry. Privacy is a first-class requirement: the application is fully offline, sends no telemetry, and keeps all data on the local machine. These qualities are not aspirations — they are enforced in the design and verified by the test suite.</a:t>
             </a:r>
-            <a:endParaRPr lang="en-US" dirty="0"/>
           </a:p>
         </p:txBody>
       </p:sp>
@@ -959,7 +735,6 @@
               <a:rPr lang="en-US" dirty="0"/>
               <a:t>The expected outcomes fall into three groups. Technically, the project delivers a working, fully offline assessment platform with a modular, extensible, and well-tested codebase — currently 111 automated tests — plus a reusable AI workflow and reporting engine that other tools could build on. For the user, the outcomes are practical: assessments are faster and guided, requiring less manual effort; privacy is strong and authorization is enforced; and the reports produced are consistent and professional. From a business and academic standpoint, the platform lowers the skill barrier for security testing, provides a reproducible and auditable methodology, and serves as a foundation for further research — for example into automated finding correlation. In short, the project produces both a usable tool and a base for future work.</a:t>
             </a:r>
-            <a:endParaRPr lang="en-US" dirty="0"/>
           </a:p>
         </p:txBody>
       </p:sp>
@@ -1047,7 +822,6 @@
               <a:rPr lang="en-US" dirty="0"/>
               <a:t>There are several promising directions for future work. On enhancements, the tool catalog can be broadened, the output parsers made richer to extract more structured findings, and assessments could be scheduled to run automatically. The local language model could be used more deeply — for instance to draft full report narratives and to guide the analyst through verifying findings. On the research side, a compelling direction is machine-learning-based correlation of findings across tools, together with automatic reduction of false positives, which is one of the biggest time sinks in real assessments. The application could grow a team mode with shared projects and role-based collaboration. And for scalability, the execution engine could be extended to distribute scans across multiple machines, supported by a community plugin ecosystem so others can contribute new capabilities. The plugin architecture I built is specifically designed to make these extensions straightforward.</a:t>
             </a:r>
-            <a:endParaRPr lang="en-US" dirty="0"/>
           </a:p>
         </p:txBody>
       </p:sp>
@@ -1135,7 +909,6 @@
               <a:rPr lang="en-US" dirty="0"/>
               <a:t>That brings me to the end of my presentation. To summarize: SecurityOps Assistant is a local-first, AI-assisted, safety-gated platform that takes an authorized analyst from a plain-English goal all the way to a professional report — entirely offline. Thank you for your time and attention. I would be happy to answer any questions and discuss the project further.</a:t>
             </a:r>
-            <a:endParaRPr lang="en-US" dirty="0"/>
           </a:p>
         </p:txBody>
       </p:sp>
@@ -1223,7 +996,6 @@
               <a:rPr lang="en-US" dirty="0"/>
               <a:t>SecurityOps Assistant sits in the cybersecurity domain, specifically AI-assisted security assessment. It is a local-first desktop application built for Kali Linux, the standard operating system used by security professionals. In one sentence: the application lets an authorized analyst describe an objective in plain English — for example, 'assess this web application for common issues' — and it responds with a structured plan of security tools, runs the approved steps in the background, extracts the important findings, and compiles a professional report. Everything runs on the local machine. The system is built in Python 3.12 with a PySide6 desktop interface, an embedded SQLite database, an optional local AI model served by Ollama, and a modular plugin architecture that makes each feature independent and extensible. The guiding principles throughout are privacy, safety, and auditability.</a:t>
             </a:r>
-            <a:endParaRPr lang="en-US" dirty="0"/>
           </a:p>
         </p:txBody>
       </p:sp>
@@ -1311,7 +1083,6 @@
               <a:rPr lang="en-US" dirty="0"/>
               <a:t>Today a security assessment involves juggling a dozen or more separate command-line tools — Nmap, Nikto, Gobuster, sqlmap, and many others. The analyst has to remember each tool's syntax, manually craft commands, keep track of what is in scope, and copy results into notes by hand. This is slow, error-prone, and has a steep learning curve for newcomers. Evidence ends up scattered across terminals and text files, and writing the final report is a tedious manual step done long after the testing. A newer option is to ask a cloud AI assistant for help, but that means sending potentially sensitive target information to a third-party server, which is often unacceptable for security work. The research gap this project addresses is the absence of a single tool that is simultaneously offline, safety-gated, AI-assisted, and integrated from planning all the way through to reporting.</a:t>
             </a:r>
-            <a:endParaRPr lang="en-US" dirty="0"/>
           </a:p>
         </p:txBody>
       </p:sp>
@@ -1399,7 +1170,6 @@
               <a:rPr lang="en-US" dirty="0"/>
               <a:t>I chose this project because the convergence of artificial intelligence and cybersecurity is one of the most active and impactful areas in computing today. On the industry side, demand for security testing is growing quickly — organizations increasingly rely on penetration testing and public bug bounty programs to find vulnerabilities before attackers do. At the same time there is a well-documented shortage of skilled security professionals, which creates a real need for tools that guide and assist analysts rather than assuming deep expertise. From the user's perspective, three needs stand out: faster, guided workflows; strict enforcement of what is authorized to be tested; and complete data privacy. Finally, on a personal level, I wanted to build something production-quality and safety-first — a tool that is genuinely useful while refusing to enable misuse.</a:t>
             </a:r>
-            <a:endParaRPr lang="en-US" dirty="0"/>
           </a:p>
         </p:txBody>
       </p:sp>
@@ -1487,7 +1257,6 @@
               <a:rPr lang="en-US" dirty="0"/>
               <a:t>The project has six primary objectives. First, to convert a natural-language goal into a structured, reviewable assessment plan. Second, and most importantly, to enforce safety — every step is approval-gated, and the assistant refuses harmful or out-of-scope requests. Third, to automatically detect the security tools installed on the machine and coordinate them from a single interface. Fourth, to collect the raw output of those tools, extract the important findings, and organize them with CVSS severity ratings and attached evidence. Fifth, to generate professional reports in HTML, PDF, and Markdown formats. And sixth, to do all of this fully offline — with an optional local AI model for fluency — while keeping the system extensible through a plugin architecture so new capabilities can be added without touching the core.</a:t>
             </a:r>
-            <a:endParaRPr lang="en-US" dirty="0"/>
           </a:p>
         </p:txBody>
       </p:sp>
@@ -1575,7 +1344,6 @@
               <a:rPr lang="en-US" dirty="0"/>
               <a:t>It is important to be precise about scope, both for the project and because this is a security tool. In scope: the application supports authorized assessment of assets the user owns or is explicitly permitted to test, across web applications, APIs, mobile backends, desktop applications, and networks. It covers the reconnaissance, enumeration, and vulnerability-assessment phases; it validates bug bounty scope; it manages findings; and it produces professional reports — all offline. Equally important is what is deliberately out of scope. The tool does not automate exploitation or attacks; it will not perform malware, ransomware, phishing, or denial-of-service actions; it refuses unauthorized targets; it uses no cloud services; it does not reverse-engineer mobile binaries; and it never runs fully autonomously — a human must approve every action. These boundaries are enforced in code, not just stated on a slide.</a:t>
             </a:r>
-            <a:endParaRPr lang="en-US" dirty="0"/>
           </a:p>
         </p:txBody>
       </p:sp>
@@ -1663,7 +1431,6 @@
               <a:rPr lang="en-US" dirty="0"/>
               <a:t>The proposed solution is a local AI assistant that plans and coordinates Kali security tools, always with the human in control. The workflow is: the analyst states a goal, the assistant builds a plan, the analyst approves the specific steps, the tools run in the background, and the assistant explains the results in plain language. On top of this core loop sits a dedicated bug bounty module that imports and validates an engagement's scope and builds a methodology tailored to the target type — web, API, mobile backend, and so on. The platform also includes an automatic tool launcher that detects installed tools, a findings dashboard that highlights important results, and a report generator. The benefits to the user are concrete: assessments become faster because commands are generated, guided because the assistant recommends next steps, private because nothing leaves the machine, and auditable because every action is logged.</a:t>
             </a:r>
-            <a:endParaRPr lang="en-US" dirty="0"/>
           </a:p>
         </p:txBody>
       </p:sp>
@@ -1751,7 +1518,6 @@
               <a:rPr lang="en-US" dirty="0"/>
               <a:t>The architecture is layered, and dependencies point in one direction only. At the top is the PySide6 graphical interface. Below it are plugins — each feature is a self-contained plugin tab. Plugins use the mid-layer services: the workflow engine, the AI planner and local model, and the reporting system. At the bottom sit the core services — configuration, logging, the SQLite database, background threading, and the tool catalog — plus the data models. Now the component flow, step by step: the user's goal goes to the planner, which produces a plan; the plan passes through an approval gate where the human selects which steps to run; approved steps go to the execution engine, which launches the real tools as background processes; the tools' output is captured and passed to parsers that extract findings; and everything is written to the project database. The data flow, therefore, is: raw tool output becomes structured findings, which are stored in the project, and finally rendered into a report. Because the core never imports the interface, it can be tested headlessly — which is how the project reached 111 automated tests.</a:t>
             </a:r>
-            <a:endParaRPr lang="en-US" dirty="0"/>
           </a:p>
         </p:txBody>
       </p:sp>
@@ -1839,7 +1605,6 @@
               <a:rPr lang="en-US" dirty="0"/>
               <a:t>Each technology was chosen deliberately. For the frontend I used PySide6, the official Qt binding for Python, because it produces a native, responsive desktop interface and is mature and cross-platform; it also let me build a clean dark theme suited to security work. The backend is Python 3.12, chosen for its unrivalled security-tooling ecosystem, fast development cycle, and modern type hints. The database is SQLite — embedded and zero-configuration, so it needs no server and stores everything in a single local file, which fits a local-first application perfectly. For AI, I integrated a local large language model through Ollama; this gives fluent planning and explanations while guaranteeing that no data ever leaves the machine, and the app falls back to deterministic rules if no model is present. Integration happens through Ollama's local REST endpoint and Qt's QProcess for safely running external tools. Finally, the development toolchain — pytest, mypy, ruff, and Git — supports automated testing, type checking, linting, and version control.</a:t>
             </a:r>
-            <a:endParaRPr lang="en-US" dirty="0"/>
           </a:p>
         </p:txBody>
       </p:sp>
@@ -1912,6 +1677,11 @@
 <file path=ppt/slideMasters/slideMaster1.xml><?xml version="1.0" encoding="utf-8"?>
 <p:sldMaster xmlns:a="http://schemas.openxmlformats.org/drawingml/2006/main" xmlns:r="http://schemas.openxmlformats.org/officeDocument/2006/relationships" xmlns:p="http://schemas.openxmlformats.org/presentationml/2006/main">
   <p:cSld>
+    <p:bg>
+      <p:bgRef idx="1001">
+        <a:schemeClr val="bg1"/>
+      </p:bgRef>
+    </p:bg>
     <p:spTree>
       <p:nvGrpSpPr>
         <p:cNvPr id="1" name=""/>
@@ -2194,6 +1964,7 @@
         <a:solidFill>
           <a:srgbClr val="16233A"/>
         </a:solidFill>
+        <a:effectLst/>
       </p:bgPr>
     </p:bg>
     <p:spTree>
@@ -2253,7 +2024,7 @@
           <a:bodyPr wrap="square" rtlCol="0" anchor="ctr"/>
           <a:lstStyle/>
           <a:p>
-            <a:pPr algn="ctr" indent="0" marL="0">
+            <a:pPr marL="0" indent="0" algn="ctr">
               <a:buNone/>
             </a:pPr>
             <a:r>
@@ -2292,7 +2063,7 @@
           <a:bodyPr wrap="square" rtlCol="0" anchor="ctr"/>
           <a:lstStyle/>
           <a:p>
-            <a:pPr indent="0" marL="0">
+            <a:pPr marL="0" indent="0">
               <a:buNone/>
             </a:pPr>
             <a:r>
@@ -2331,7 +2102,7 @@
           <a:bodyPr wrap="square" rtlCol="0" anchor="ctr"/>
           <a:lstStyle/>
           <a:p>
-            <a:pPr indent="0" marL="0">
+            <a:pPr marL="0" indent="0">
               <a:buNone/>
             </a:pPr>
             <a:r>
@@ -2370,7 +2141,7 @@
           <a:bodyPr wrap="square" rtlCol="0" anchor="ctr"/>
           <a:lstStyle/>
           <a:p>
-            <a:pPr indent="0" marL="0">
+            <a:pPr marL="0" indent="0">
               <a:buNone/>
             </a:pPr>
             <a:r>
@@ -2382,21 +2153,7 @@
                 <a:ea typeface="Calibri" pitchFamily="34" charset="-122"/>
                 <a:cs typeface="Calibri" pitchFamily="34" charset="-120"/>
               </a:rPr>
-              <a:t>Presented by:  </a:t>
-            </a:r>
-            <a:pPr indent="0" marL="0">
-              <a:buNone/>
-            </a:pPr>
-            <a:r>
-              <a:rPr lang="en-US" sz="1400" dirty="0">
-                <a:solidFill>
-                  <a:srgbClr val="FFFFFF"/>
-                </a:solidFill>
-                <a:latin typeface="Calibri" pitchFamily="34" charset="0"/>
-                <a:ea typeface="Calibri" pitchFamily="34" charset="-122"/>
-                <a:cs typeface="Calibri" pitchFamily="34" charset="-120"/>
-              </a:rPr>
-              <a:t>[Your Name]  ·  [Roll No / Enrollment No]</a:t>
+              <a:t>Presented by:</a:t>
             </a:r>
             <a:endParaRPr lang="en-US" sz="1400" dirty="0"/>
           </a:p>
@@ -2423,7 +2180,7 @@
           <a:bodyPr wrap="square" rtlCol="0" anchor="ctr"/>
           <a:lstStyle/>
           <a:p>
-            <a:pPr indent="0" marL="0">
+            <a:pPr marL="0" indent="0">
               <a:buNone/>
             </a:pPr>
             <a:r>
@@ -2436,20 +2193,6 @@
                 <a:cs typeface="Calibri" pitchFamily="34" charset="-120"/>
               </a:rPr>
               <a:t>Guide:  </a:t>
-            </a:r>
-            <a:pPr indent="0" marL="0">
-              <a:buNone/>
-            </a:pPr>
-            <a:r>
-              <a:rPr lang="en-US" sz="1400" dirty="0">
-                <a:solidFill>
-                  <a:srgbClr val="FFFFFF"/>
-                </a:solidFill>
-                <a:latin typeface="Calibri" pitchFamily="34" charset="0"/>
-                <a:ea typeface="Calibri" pitchFamily="34" charset="-122"/>
-                <a:cs typeface="Calibri" pitchFamily="34" charset="-120"/>
-              </a:rPr>
-              <a:t>[Guide Name]</a:t>
             </a:r>
             <a:endParaRPr lang="en-US" sz="1400" dirty="0"/>
           </a:p>
@@ -2476,7 +2219,7 @@
           <a:bodyPr wrap="square" rtlCol="0" anchor="ctr"/>
           <a:lstStyle/>
           <a:p>
-            <a:pPr indent="0" marL="0">
+            <a:pPr marL="0" indent="0">
               <a:buNone/>
             </a:pPr>
             <a:r>
@@ -2488,21 +2231,7 @@
                 <a:ea typeface="Calibri" pitchFamily="34" charset="-122"/>
                 <a:cs typeface="Calibri" pitchFamily="34" charset="-120"/>
               </a:rPr>
-              <a:t>Institute:  </a:t>
-            </a:r>
-            <a:pPr indent="0" marL="0">
-              <a:buNone/>
-            </a:pPr>
-            <a:r>
-              <a:rPr lang="en-US" sz="1400" dirty="0">
-                <a:solidFill>
-                  <a:srgbClr val="FFFFFF"/>
-                </a:solidFill>
-                <a:latin typeface="Calibri" pitchFamily="34" charset="0"/>
-                <a:ea typeface="Calibri" pitchFamily="34" charset="-122"/>
-                <a:cs typeface="Calibri" pitchFamily="34" charset="-120"/>
-              </a:rPr>
-              <a:t>[Institute / University Name]  ·  [Department of Computer Science &amp; Engineering]</a:t>
+              <a:t>Institute:</a:t>
             </a:r>
             <a:endParaRPr lang="en-US" sz="1400" dirty="0"/>
           </a:p>
@@ -2529,7 +2258,7 @@
           <a:bodyPr wrap="square" rtlCol="0" anchor="ctr"/>
           <a:lstStyle/>
           <a:p>
-            <a:pPr indent="0" marL="0">
+            <a:pPr marL="0" indent="0">
               <a:buNone/>
             </a:pPr>
             <a:r>
@@ -2541,21 +2270,7 @@
                 <a:ea typeface="Calibri" pitchFamily="34" charset="-122"/>
                 <a:cs typeface="Calibri" pitchFamily="34" charset="-120"/>
               </a:rPr>
-              <a:t>Date:  </a:t>
-            </a:r>
-            <a:pPr indent="0" marL="0">
-              <a:buNone/>
-            </a:pPr>
-            <a:r>
-              <a:rPr lang="en-US" sz="1400" dirty="0">
-                <a:solidFill>
-                  <a:srgbClr val="FFFFFF"/>
-                </a:solidFill>
-                <a:latin typeface="Calibri" pitchFamily="34" charset="0"/>
-                <a:ea typeface="Calibri" pitchFamily="34" charset="-122"/>
-                <a:cs typeface="Calibri" pitchFamily="34" charset="-120"/>
-              </a:rPr>
-              <a:t>July 2026</a:t>
+              <a:t>Date:</a:t>
             </a:r>
             <a:endParaRPr lang="en-US" sz="1400" dirty="0"/>
           </a:p>
@@ -2577,6 +2292,7 @@
         <a:solidFill>
           <a:srgbClr val="FFFFFF"/>
         </a:solidFill>
+        <a:effectLst/>
       </p:bgPr>
     </p:bg>
     <p:spTree>
@@ -2614,7 +2330,7 @@
           <a:bodyPr wrap="square" rtlCol="0" anchor="ctr"/>
           <a:lstStyle/>
           <a:p>
-            <a:pPr indent="0" marL="0">
+            <a:pPr marL="0" indent="0">
               <a:buNone/>
             </a:pPr>
             <a:r>
@@ -2628,9 +2344,6 @@
               </a:rPr>
               <a:t>SecurityOps Assistant</a:t>
             </a:r>
-            <a:pPr indent="0" marL="0">
-              <a:buNone/>
-            </a:pPr>
             <a:r>
               <a:rPr lang="en-US" sz="900" dirty="0">
                 <a:solidFill>
@@ -2667,7 +2380,7 @@
           <a:bodyPr wrap="square" rtlCol="0" anchor="ctr"/>
           <a:lstStyle/>
           <a:p>
-            <a:pPr algn="r" indent="0" marL="0">
+            <a:pPr marL="0" indent="0" algn="r">
               <a:buNone/>
             </a:pPr>
             <a:r>
@@ -2706,7 +2419,7 @@
           <a:bodyPr wrap="square" rtlCol="0" anchor="ctr"/>
           <a:lstStyle/>
           <a:p>
-            <a:pPr indent="0" marL="0">
+            <a:pPr marL="0" indent="0">
               <a:buNone/>
             </a:pPr>
             <a:r>
@@ -2750,7 +2463,7 @@
             <a:prstDash val="solid"/>
           </a:ln>
           <a:effectLst>
-            <a:outerShdw sx="100000" sy="100000" kx="0" ky="0" algn="bl" rotWithShape="0" blurRad="88900" dist="38100" dir="5400000">
+            <a:outerShdw blurRad="88900" dist="38100" dir="5400000" algn="bl" rotWithShape="0">
               <a:srgbClr val="8494A8">
                 <a:alpha val="28000"/>
               </a:srgbClr>
@@ -2799,7 +2512,7 @@
           <a:bodyPr wrap="square" rtlCol="0" anchor="ctr"/>
           <a:lstStyle/>
           <a:p>
-            <a:pPr algn="ctr" indent="0" marL="0">
+            <a:pPr marL="0" indent="0" algn="ctr">
               <a:buNone/>
             </a:pPr>
             <a:r>
@@ -2838,7 +2551,7 @@
           <a:bodyPr wrap="square" rtlCol="0" anchor="ctr"/>
           <a:lstStyle/>
           <a:p>
-            <a:pPr algn="ctr" indent="0" marL="0">
+            <a:pPr marL="0" indent="0" algn="ctr">
               <a:buNone/>
             </a:pPr>
             <a:r>
@@ -2877,7 +2590,7 @@
           <a:bodyPr wrap="square" rtlCol="0" anchor="ctr"/>
           <a:lstStyle/>
           <a:p>
-            <a:pPr algn="ctr" indent="0" marL="0">
+            <a:pPr marL="0" indent="0" algn="ctr">
               <a:buNone/>
             </a:pPr>
             <a:r>
@@ -2921,7 +2634,7 @@
             <a:prstDash val="solid"/>
           </a:ln>
           <a:effectLst>
-            <a:outerShdw sx="100000" sy="100000" kx="0" ky="0" algn="bl" rotWithShape="0" blurRad="88900" dist="38100" dir="5400000">
+            <a:outerShdw blurRad="88900" dist="38100" dir="5400000" algn="bl" rotWithShape="0">
               <a:srgbClr val="8494A8">
                 <a:alpha val="28000"/>
               </a:srgbClr>
@@ -2970,7 +2683,7 @@
           <a:bodyPr wrap="square" rtlCol="0" anchor="ctr"/>
           <a:lstStyle/>
           <a:p>
-            <a:pPr algn="ctr" indent="0" marL="0">
+            <a:pPr marL="0" indent="0" algn="ctr">
               <a:buNone/>
             </a:pPr>
             <a:r>
@@ -3009,7 +2722,7 @@
           <a:bodyPr wrap="square" rtlCol="0" anchor="ctr"/>
           <a:lstStyle/>
           <a:p>
-            <a:pPr algn="ctr" indent="0" marL="0">
+            <a:pPr marL="0" indent="0" algn="ctr">
               <a:buNone/>
             </a:pPr>
             <a:r>
@@ -3048,7 +2761,7 @@
           <a:bodyPr wrap="square" rtlCol="0" anchor="ctr"/>
           <a:lstStyle/>
           <a:p>
-            <a:pPr algn="ctr" indent="0" marL="0">
+            <a:pPr marL="0" indent="0" algn="ctr">
               <a:buNone/>
             </a:pPr>
             <a:r>
@@ -3092,7 +2805,7 @@
             <a:prstDash val="solid"/>
           </a:ln>
           <a:effectLst>
-            <a:outerShdw sx="100000" sy="100000" kx="0" ky="0" algn="bl" rotWithShape="0" blurRad="88900" dist="38100" dir="5400000">
+            <a:outerShdw blurRad="88900" dist="38100" dir="5400000" algn="bl" rotWithShape="0">
               <a:srgbClr val="8494A8">
                 <a:alpha val="28000"/>
               </a:srgbClr>
@@ -3141,7 +2854,7 @@
           <a:bodyPr wrap="square" rtlCol="0" anchor="ctr"/>
           <a:lstStyle/>
           <a:p>
-            <a:pPr algn="ctr" indent="0" marL="0">
+            <a:pPr marL="0" indent="0" algn="ctr">
               <a:buNone/>
             </a:pPr>
             <a:r>
@@ -3180,7 +2893,7 @@
           <a:bodyPr wrap="square" rtlCol="0" anchor="ctr"/>
           <a:lstStyle/>
           <a:p>
-            <a:pPr algn="ctr" indent="0" marL="0">
+            <a:pPr marL="0" indent="0" algn="ctr">
               <a:buNone/>
             </a:pPr>
             <a:r>
@@ -3219,7 +2932,7 @@
           <a:bodyPr wrap="square" rtlCol="0" anchor="ctr"/>
           <a:lstStyle/>
           <a:p>
-            <a:pPr algn="ctr" indent="0" marL="0">
+            <a:pPr marL="0" indent="0" algn="ctr">
               <a:buNone/>
             </a:pPr>
             <a:r>
@@ -3263,7 +2976,7 @@
             <a:prstDash val="solid"/>
           </a:ln>
           <a:effectLst>
-            <a:outerShdw sx="100000" sy="100000" kx="0" ky="0" algn="bl" rotWithShape="0" blurRad="88900" dist="38100" dir="5400000">
+            <a:outerShdw blurRad="88900" dist="38100" dir="5400000" algn="bl" rotWithShape="0">
               <a:srgbClr val="8494A8">
                 <a:alpha val="28000"/>
               </a:srgbClr>
@@ -3312,7 +3025,7 @@
           <a:bodyPr wrap="square" rtlCol="0" anchor="ctr"/>
           <a:lstStyle/>
           <a:p>
-            <a:pPr algn="ctr" indent="0" marL="0">
+            <a:pPr marL="0" indent="0" algn="ctr">
               <a:buNone/>
             </a:pPr>
             <a:r>
@@ -3351,7 +3064,7 @@
           <a:bodyPr wrap="square" rtlCol="0" anchor="ctr"/>
           <a:lstStyle/>
           <a:p>
-            <a:pPr algn="ctr" indent="0" marL="0">
+            <a:pPr marL="0" indent="0" algn="ctr">
               <a:buNone/>
             </a:pPr>
             <a:r>
@@ -3390,7 +3103,7 @@
           <a:bodyPr wrap="square" rtlCol="0" anchor="ctr"/>
           <a:lstStyle/>
           <a:p>
-            <a:pPr algn="ctr" indent="0" marL="0">
+            <a:pPr marL="0" indent="0" algn="ctr">
               <a:buNone/>
             </a:pPr>
             <a:r>
@@ -3434,7 +3147,7 @@
             <a:prstDash val="solid"/>
           </a:ln>
           <a:effectLst>
-            <a:outerShdw sx="100000" sy="100000" kx="0" ky="0" algn="bl" rotWithShape="0" blurRad="88900" dist="38100" dir="5400000">
+            <a:outerShdw blurRad="88900" dist="38100" dir="5400000" algn="bl" rotWithShape="0">
               <a:srgbClr val="8494A8">
                 <a:alpha val="28000"/>
               </a:srgbClr>
@@ -3483,7 +3196,7 @@
           <a:bodyPr wrap="square" rtlCol="0" anchor="ctr"/>
           <a:lstStyle/>
           <a:p>
-            <a:pPr algn="ctr" indent="0" marL="0">
+            <a:pPr marL="0" indent="0" algn="ctr">
               <a:buNone/>
             </a:pPr>
             <a:r>
@@ -3522,7 +3235,7 @@
           <a:bodyPr wrap="square" rtlCol="0" anchor="ctr"/>
           <a:lstStyle/>
           <a:p>
-            <a:pPr algn="ctr" indent="0" marL="0">
+            <a:pPr marL="0" indent="0" algn="ctr">
               <a:buNone/>
             </a:pPr>
             <a:r>
@@ -3561,7 +3274,7 @@
           <a:bodyPr wrap="square" rtlCol="0" anchor="ctr"/>
           <a:lstStyle/>
           <a:p>
-            <a:pPr algn="ctr" indent="0" marL="0">
+            <a:pPr marL="0" indent="0" algn="ctr">
               <a:buNone/>
             </a:pPr>
             <a:r>
@@ -3605,7 +3318,7 @@
             <a:prstDash val="solid"/>
           </a:ln>
           <a:effectLst>
-            <a:outerShdw sx="100000" sy="100000" kx="0" ky="0" algn="bl" rotWithShape="0" blurRad="88900" dist="38100" dir="5400000">
+            <a:outerShdw blurRad="88900" dist="38100" dir="5400000" algn="bl" rotWithShape="0">
               <a:srgbClr val="8494A8">
                 <a:alpha val="28000"/>
               </a:srgbClr>
@@ -3654,7 +3367,7 @@
           <a:bodyPr wrap="square" rtlCol="0" anchor="ctr"/>
           <a:lstStyle/>
           <a:p>
-            <a:pPr algn="ctr" indent="0" marL="0">
+            <a:pPr marL="0" indent="0" algn="ctr">
               <a:buNone/>
             </a:pPr>
             <a:r>
@@ -3693,7 +3406,7 @@
           <a:bodyPr wrap="square" rtlCol="0" anchor="ctr"/>
           <a:lstStyle/>
           <a:p>
-            <a:pPr algn="ctr" indent="0" marL="0">
+            <a:pPr marL="0" indent="0" algn="ctr">
               <a:buNone/>
             </a:pPr>
             <a:r>
@@ -3732,7 +3445,7 @@
           <a:bodyPr wrap="square" rtlCol="0" anchor="ctr"/>
           <a:lstStyle/>
           <a:p>
-            <a:pPr algn="ctr" indent="0" marL="0">
+            <a:pPr marL="0" indent="0" algn="ctr">
               <a:buNone/>
             </a:pPr>
             <a:r>
@@ -3776,7 +3489,7 @@
             <a:prstDash val="solid"/>
           </a:ln>
           <a:effectLst>
-            <a:outerShdw sx="100000" sy="100000" kx="0" ky="0" algn="bl" rotWithShape="0" blurRad="88900" dist="38100" dir="5400000">
+            <a:outerShdw blurRad="88900" dist="38100" dir="5400000" algn="bl" rotWithShape="0">
               <a:srgbClr val="8494A8">
                 <a:alpha val="28000"/>
               </a:srgbClr>
@@ -3805,7 +3518,7 @@
           <a:bodyPr wrap="square" rtlCol="0" anchor="ctr"/>
           <a:lstStyle/>
           <a:p>
-            <a:pPr indent="0" marL="0">
+            <a:pPr marL="0" indent="0">
               <a:buNone/>
             </a:pPr>
             <a:r>
@@ -3924,6 +3637,7 @@
         <a:solidFill>
           <a:srgbClr val="FFFFFF"/>
         </a:solidFill>
+        <a:effectLst/>
       </p:bgPr>
     </p:bg>
     <p:spTree>
@@ -3961,7 +3675,7 @@
           <a:bodyPr wrap="square" rtlCol="0" anchor="ctr"/>
           <a:lstStyle/>
           <a:p>
-            <a:pPr indent="0" marL="0">
+            <a:pPr marL="0" indent="0">
               <a:buNone/>
             </a:pPr>
             <a:r>
@@ -3975,9 +3689,6 @@
               </a:rPr>
               <a:t>SecurityOps Assistant</a:t>
             </a:r>
-            <a:pPr indent="0" marL="0">
-              <a:buNone/>
-            </a:pPr>
             <a:r>
               <a:rPr lang="en-US" sz="900" dirty="0">
                 <a:solidFill>
@@ -4014,7 +3725,7 @@
           <a:bodyPr wrap="square" rtlCol="0" anchor="ctr"/>
           <a:lstStyle/>
           <a:p>
-            <a:pPr algn="r" indent="0" marL="0">
+            <a:pPr marL="0" indent="0" algn="r">
               <a:buNone/>
             </a:pPr>
             <a:r>
@@ -4053,7 +3764,7 @@
           <a:bodyPr wrap="square" rtlCol="0" anchor="ctr"/>
           <a:lstStyle/>
           <a:p>
-            <a:pPr indent="0" marL="0">
+            <a:pPr marL="0" indent="0">
               <a:buNone/>
             </a:pPr>
             <a:r>
@@ -4092,7 +3803,7 @@
           <a:bodyPr wrap="square" rtlCol="0" anchor="ctr"/>
           <a:lstStyle/>
           <a:p>
-            <a:pPr algn="ctr" indent="0" marL="0">
+            <a:pPr marL="0" indent="0" algn="ctr">
               <a:buNone/>
             </a:pPr>
             <a:r>
@@ -4131,7 +3842,7 @@
           <a:bodyPr wrap="square" rtlCol="0" anchor="ctr"/>
           <a:lstStyle/>
           <a:p>
-            <a:pPr algn="ctr" indent="0" marL="0">
+            <a:pPr marL="0" indent="0" algn="ctr">
               <a:buNone/>
             </a:pPr>
             <a:r>
@@ -4170,7 +3881,7 @@
           <a:bodyPr wrap="square" rtlCol="0" anchor="ctr"/>
           <a:lstStyle/>
           <a:p>
-            <a:pPr algn="ctr" indent="0" marL="0">
+            <a:pPr marL="0" indent="0" algn="ctr">
               <a:buNone/>
             </a:pPr>
             <a:r>
@@ -4209,7 +3920,7 @@
           <a:bodyPr wrap="square" rtlCol="0" anchor="ctr"/>
           <a:lstStyle/>
           <a:p>
-            <a:pPr algn="ctr" indent="0" marL="0">
+            <a:pPr marL="0" indent="0" algn="ctr">
               <a:buNone/>
             </a:pPr>
             <a:r>
@@ -4248,7 +3959,7 @@
           <a:bodyPr wrap="square" rtlCol="0" anchor="ctr"/>
           <a:lstStyle/>
           <a:p>
-            <a:pPr algn="ctr" indent="0" marL="0">
+            <a:pPr marL="0" indent="0" algn="ctr">
               <a:buNone/>
             </a:pPr>
             <a:r>
@@ -4287,7 +3998,7 @@
           <a:bodyPr wrap="square" rtlCol="0" anchor="ctr"/>
           <a:lstStyle/>
           <a:p>
-            <a:pPr algn="ctr" indent="0" marL="0">
+            <a:pPr marL="0" indent="0" algn="ctr">
               <a:buNone/>
             </a:pPr>
             <a:r>
@@ -4326,7 +4037,7 @@
           <a:bodyPr wrap="square" rtlCol="0" anchor="ctr"/>
           <a:lstStyle/>
           <a:p>
-            <a:pPr algn="ctr" indent="0" marL="0">
+            <a:pPr marL="0" indent="0" algn="ctr">
               <a:buNone/>
             </a:pPr>
             <a:r>
@@ -4365,7 +4076,7 @@
           <a:bodyPr wrap="square" rtlCol="0" anchor="ctr"/>
           <a:lstStyle/>
           <a:p>
-            <a:pPr algn="ctr" indent="0" marL="0">
+            <a:pPr marL="0" indent="0" algn="ctr">
               <a:buNone/>
             </a:pPr>
             <a:r>
@@ -4404,7 +4115,7 @@
           <a:bodyPr wrap="square" rtlCol="0" anchor="ctr"/>
           <a:lstStyle/>
           <a:p>
-            <a:pPr indent="0" marL="0">
+            <a:pPr marL="0" indent="0">
               <a:buNone/>
             </a:pPr>
             <a:r>
@@ -4492,7 +4203,7 @@
           <a:bodyPr wrap="square" rtlCol="0" anchor="ctr"/>
           <a:lstStyle/>
           <a:p>
-            <a:pPr indent="0" marL="0">
+            <a:pPr marL="0" indent="0">
               <a:buNone/>
             </a:pPr>
             <a:r>
@@ -4580,7 +4291,7 @@
           <a:bodyPr wrap="square" rtlCol="0" anchor="ctr"/>
           <a:lstStyle/>
           <a:p>
-            <a:pPr indent="0" marL="0">
+            <a:pPr marL="0" indent="0">
               <a:buNone/>
             </a:pPr>
             <a:r>
@@ -4668,7 +4379,7 @@
           <a:bodyPr wrap="square" rtlCol="0" anchor="ctr"/>
           <a:lstStyle/>
           <a:p>
-            <a:pPr indent="0" marL="0">
+            <a:pPr marL="0" indent="0">
               <a:buNone/>
             </a:pPr>
             <a:r>
@@ -4756,7 +4467,7 @@
           <a:bodyPr wrap="square" rtlCol="0" anchor="ctr"/>
           <a:lstStyle/>
           <a:p>
-            <a:pPr indent="0" marL="0">
+            <a:pPr marL="0" indent="0">
               <a:buNone/>
             </a:pPr>
             <a:r>
@@ -4844,7 +4555,7 @@
           <a:bodyPr wrap="square" rtlCol="0" anchor="ctr"/>
           <a:lstStyle/>
           <a:p>
-            <a:pPr indent="0" marL="0">
+            <a:pPr marL="0" indent="0">
               <a:buNone/>
             </a:pPr>
             <a:r>
@@ -4932,7 +4643,7 @@
           <a:bodyPr wrap="square" rtlCol="0" anchor="ctr"/>
           <a:lstStyle/>
           <a:p>
-            <a:pPr indent="0" marL="0">
+            <a:pPr marL="0" indent="0">
               <a:buNone/>
             </a:pPr>
             <a:r>
@@ -5020,7 +4731,7 @@
           <a:bodyPr wrap="square" rtlCol="0" anchor="ctr"/>
           <a:lstStyle/>
           <a:p>
-            <a:pPr indent="0" marL="0">
+            <a:pPr marL="0" indent="0">
               <a:buNone/>
             </a:pPr>
             <a:r>
@@ -5054,6 +4765,7 @@
         <a:solidFill>
           <a:srgbClr val="FFFFFF"/>
         </a:solidFill>
+        <a:effectLst/>
       </p:bgPr>
     </p:bg>
     <p:spTree>
@@ -5091,7 +4803,7 @@
           <a:bodyPr wrap="square" rtlCol="0" anchor="ctr"/>
           <a:lstStyle/>
           <a:p>
-            <a:pPr indent="0" marL="0">
+            <a:pPr marL="0" indent="0">
               <a:buNone/>
             </a:pPr>
             <a:r>
@@ -5105,9 +4817,6 @@
               </a:rPr>
               <a:t>SecurityOps Assistant</a:t>
             </a:r>
-            <a:pPr indent="0" marL="0">
-              <a:buNone/>
-            </a:pPr>
             <a:r>
               <a:rPr lang="en-US" sz="900" dirty="0">
                 <a:solidFill>
@@ -5144,7 +4853,7 @@
           <a:bodyPr wrap="square" rtlCol="0" anchor="ctr"/>
           <a:lstStyle/>
           <a:p>
-            <a:pPr algn="r" indent="0" marL="0">
+            <a:pPr marL="0" indent="0" algn="r">
               <a:buNone/>
             </a:pPr>
             <a:r>
@@ -5183,7 +4892,7 @@
           <a:bodyPr wrap="square" rtlCol="0" anchor="ctr"/>
           <a:lstStyle/>
           <a:p>
-            <a:pPr indent="0" marL="0">
+            <a:pPr marL="0" indent="0">
               <a:buNone/>
             </a:pPr>
             <a:r>
@@ -5227,7 +4936,7 @@
             <a:prstDash val="solid"/>
           </a:ln>
           <a:effectLst>
-            <a:outerShdw sx="100000" sy="100000" kx="0" ky="0" algn="bl" rotWithShape="0" blurRad="88900" dist="38100" dir="5400000">
+            <a:outerShdw blurRad="88900" dist="38100" dir="5400000" algn="bl" rotWithShape="0">
               <a:srgbClr val="8494A8">
                 <a:alpha val="28000"/>
               </a:srgbClr>
@@ -5276,7 +4985,7 @@
           <a:bodyPr wrap="square" rtlCol="0" anchor="ctr"/>
           <a:lstStyle/>
           <a:p>
-            <a:pPr algn="ctr" indent="0" marL="0">
+            <a:pPr marL="0" indent="0" algn="ctr">
               <a:buNone/>
             </a:pPr>
             <a:r>
@@ -5315,7 +5024,7 @@
           <a:bodyPr wrap="square" rtlCol="0" anchor="ctr"/>
           <a:lstStyle/>
           <a:p>
-            <a:pPr indent="0" marL="0">
+            <a:pPr marL="0" indent="0">
               <a:buNone/>
             </a:pPr>
             <a:r>
@@ -5359,7 +5068,7 @@
             <a:prstDash val="solid"/>
           </a:ln>
           <a:effectLst>
-            <a:outerShdw sx="100000" sy="100000" kx="0" ky="0" algn="bl" rotWithShape="0" blurRad="88900" dist="38100" dir="5400000">
+            <a:outerShdw blurRad="88900" dist="38100" dir="5400000" algn="bl" rotWithShape="0">
               <a:srgbClr val="8494A8">
                 <a:alpha val="28000"/>
               </a:srgbClr>
@@ -5408,7 +5117,7 @@
           <a:bodyPr wrap="square" rtlCol="0" anchor="ctr"/>
           <a:lstStyle/>
           <a:p>
-            <a:pPr algn="ctr" indent="0" marL="0">
+            <a:pPr marL="0" indent="0" algn="ctr">
               <a:buNone/>
             </a:pPr>
             <a:r>
@@ -5447,7 +5156,7 @@
           <a:bodyPr wrap="square" rtlCol="0" anchor="ctr"/>
           <a:lstStyle/>
           <a:p>
-            <a:pPr indent="0" marL="0">
+            <a:pPr marL="0" indent="0">
               <a:buNone/>
             </a:pPr>
             <a:r>
@@ -5491,7 +5200,7 @@
             <a:prstDash val="solid"/>
           </a:ln>
           <a:effectLst>
-            <a:outerShdw sx="100000" sy="100000" kx="0" ky="0" algn="bl" rotWithShape="0" blurRad="88900" dist="38100" dir="5400000">
+            <a:outerShdw blurRad="88900" dist="38100" dir="5400000" algn="bl" rotWithShape="0">
               <a:srgbClr val="8494A8">
                 <a:alpha val="28000"/>
               </a:srgbClr>
@@ -5540,7 +5249,7 @@
           <a:bodyPr wrap="square" rtlCol="0" anchor="ctr"/>
           <a:lstStyle/>
           <a:p>
-            <a:pPr algn="ctr" indent="0" marL="0">
+            <a:pPr marL="0" indent="0" algn="ctr">
               <a:buNone/>
             </a:pPr>
             <a:r>
@@ -5579,7 +5288,7 @@
           <a:bodyPr wrap="square" rtlCol="0" anchor="ctr"/>
           <a:lstStyle/>
           <a:p>
-            <a:pPr indent="0" marL="0">
+            <a:pPr marL="0" indent="0">
               <a:buNone/>
             </a:pPr>
             <a:r>
@@ -5623,7 +5332,7 @@
             <a:prstDash val="solid"/>
           </a:ln>
           <a:effectLst>
-            <a:outerShdw sx="100000" sy="100000" kx="0" ky="0" algn="bl" rotWithShape="0" blurRad="88900" dist="38100" dir="5400000">
+            <a:outerShdw blurRad="88900" dist="38100" dir="5400000" algn="bl" rotWithShape="0">
               <a:srgbClr val="8494A8">
                 <a:alpha val="28000"/>
               </a:srgbClr>
@@ -5672,7 +5381,7 @@
           <a:bodyPr wrap="square" rtlCol="0" anchor="ctr"/>
           <a:lstStyle/>
           <a:p>
-            <a:pPr algn="ctr" indent="0" marL="0">
+            <a:pPr marL="0" indent="0" algn="ctr">
               <a:buNone/>
             </a:pPr>
             <a:r>
@@ -5711,7 +5420,7 @@
           <a:bodyPr wrap="square" rtlCol="0" anchor="ctr"/>
           <a:lstStyle/>
           <a:p>
-            <a:pPr indent="0" marL="0">
+            <a:pPr marL="0" indent="0">
               <a:buNone/>
             </a:pPr>
             <a:r>
@@ -5755,7 +5464,7 @@
             <a:prstDash val="solid"/>
           </a:ln>
           <a:effectLst>
-            <a:outerShdw sx="100000" sy="100000" kx="0" ky="0" algn="bl" rotWithShape="0" blurRad="88900" dist="38100" dir="5400000">
+            <a:outerShdw blurRad="88900" dist="38100" dir="5400000" algn="bl" rotWithShape="0">
               <a:srgbClr val="8494A8">
                 <a:alpha val="28000"/>
               </a:srgbClr>
@@ -5804,7 +5513,7 @@
           <a:bodyPr wrap="square" rtlCol="0" anchor="ctr"/>
           <a:lstStyle/>
           <a:p>
-            <a:pPr algn="ctr" indent="0" marL="0">
+            <a:pPr marL="0" indent="0" algn="ctr">
               <a:buNone/>
             </a:pPr>
             <a:r>
@@ -5843,7 +5552,7 @@
           <a:bodyPr wrap="square" rtlCol="0" anchor="ctr"/>
           <a:lstStyle/>
           <a:p>
-            <a:pPr indent="0" marL="0">
+            <a:pPr marL="0" indent="0">
               <a:buNone/>
             </a:pPr>
             <a:r>
@@ -5887,7 +5596,7 @@
             <a:prstDash val="solid"/>
           </a:ln>
           <a:effectLst>
-            <a:outerShdw sx="100000" sy="100000" kx="0" ky="0" algn="bl" rotWithShape="0" blurRad="88900" dist="38100" dir="5400000">
+            <a:outerShdw blurRad="88900" dist="38100" dir="5400000" algn="bl" rotWithShape="0">
               <a:srgbClr val="8494A8">
                 <a:alpha val="28000"/>
               </a:srgbClr>
@@ -5936,7 +5645,7 @@
           <a:bodyPr wrap="square" rtlCol="0" anchor="ctr"/>
           <a:lstStyle/>
           <a:p>
-            <a:pPr algn="ctr" indent="0" marL="0">
+            <a:pPr marL="0" indent="0" algn="ctr">
               <a:buNone/>
             </a:pPr>
             <a:r>
@@ -5975,7 +5684,7 @@
           <a:bodyPr wrap="square" rtlCol="0" anchor="ctr"/>
           <a:lstStyle/>
           <a:p>
-            <a:pPr indent="0" marL="0">
+            <a:pPr marL="0" indent="0">
               <a:buNone/>
             </a:pPr>
             <a:r>
@@ -6019,7 +5728,7 @@
             <a:prstDash val="solid"/>
           </a:ln>
           <a:effectLst>
-            <a:outerShdw sx="100000" sy="100000" kx="0" ky="0" algn="bl" rotWithShape="0" blurRad="88900" dist="38100" dir="5400000">
+            <a:outerShdw blurRad="88900" dist="38100" dir="5400000" algn="bl" rotWithShape="0">
               <a:srgbClr val="8494A8">
                 <a:alpha val="28000"/>
               </a:srgbClr>
@@ -6068,7 +5777,7 @@
           <a:bodyPr wrap="square" rtlCol="0" anchor="ctr"/>
           <a:lstStyle/>
           <a:p>
-            <a:pPr algn="ctr" indent="0" marL="0">
+            <a:pPr marL="0" indent="0" algn="ctr">
               <a:buNone/>
             </a:pPr>
             <a:r>
@@ -6107,7 +5816,7 @@
           <a:bodyPr wrap="square" rtlCol="0" anchor="ctr"/>
           <a:lstStyle/>
           <a:p>
-            <a:pPr indent="0" marL="0">
+            <a:pPr marL="0" indent="0">
               <a:buNone/>
             </a:pPr>
             <a:r>
@@ -6151,7 +5860,7 @@
             <a:prstDash val="solid"/>
           </a:ln>
           <a:effectLst>
-            <a:outerShdw sx="100000" sy="100000" kx="0" ky="0" algn="bl" rotWithShape="0" blurRad="88900" dist="38100" dir="5400000">
+            <a:outerShdw blurRad="88900" dist="38100" dir="5400000" algn="bl" rotWithShape="0">
               <a:srgbClr val="8494A8">
                 <a:alpha val="28000"/>
               </a:srgbClr>
@@ -6200,7 +5909,7 @@
           <a:bodyPr wrap="square" rtlCol="0" anchor="ctr"/>
           <a:lstStyle/>
           <a:p>
-            <a:pPr algn="ctr" indent="0" marL="0">
+            <a:pPr marL="0" indent="0" algn="ctr">
               <a:buNone/>
             </a:pPr>
             <a:r>
@@ -6239,7 +5948,7 @@
           <a:bodyPr wrap="square" rtlCol="0" anchor="ctr"/>
           <a:lstStyle/>
           <a:p>
-            <a:pPr indent="0" marL="0">
+            <a:pPr marL="0" indent="0">
               <a:buNone/>
             </a:pPr>
             <a:r>
@@ -6273,6 +5982,7 @@
         <a:solidFill>
           <a:srgbClr val="FFFFFF"/>
         </a:solidFill>
+        <a:effectLst/>
       </p:bgPr>
     </p:bg>
     <p:spTree>
@@ -6310,7 +6020,7 @@
           <a:bodyPr wrap="square" rtlCol="0" anchor="ctr"/>
           <a:lstStyle/>
           <a:p>
-            <a:pPr indent="0" marL="0">
+            <a:pPr marL="0" indent="0">
               <a:buNone/>
             </a:pPr>
             <a:r>
@@ -6324,9 +6034,6 @@
               </a:rPr>
               <a:t>SecurityOps Assistant</a:t>
             </a:r>
-            <a:pPr indent="0" marL="0">
-              <a:buNone/>
-            </a:pPr>
             <a:r>
               <a:rPr lang="en-US" sz="900" dirty="0">
                 <a:solidFill>
@@ -6363,7 +6070,7 @@
           <a:bodyPr wrap="square" rtlCol="0" anchor="ctr"/>
           <a:lstStyle/>
           <a:p>
-            <a:pPr algn="r" indent="0" marL="0">
+            <a:pPr marL="0" indent="0" algn="r">
               <a:buNone/>
             </a:pPr>
             <a:r>
@@ -6402,7 +6109,7 @@
           <a:bodyPr wrap="square" rtlCol="0" anchor="ctr"/>
           <a:lstStyle/>
           <a:p>
-            <a:pPr indent="0" marL="0">
+            <a:pPr marL="0" indent="0">
               <a:buNone/>
             </a:pPr>
             <a:r>
@@ -6446,7 +6153,7 @@
             <a:prstDash val="solid"/>
           </a:ln>
           <a:effectLst>
-            <a:outerShdw sx="100000" sy="100000" kx="0" ky="0" algn="bl" rotWithShape="0" blurRad="88900" dist="38100" dir="5400000">
+            <a:outerShdw blurRad="88900" dist="38100" dir="5400000" algn="bl" rotWithShape="0">
               <a:srgbClr val="8494A8">
                 <a:alpha val="28000"/>
               </a:srgbClr>
@@ -6495,7 +6202,7 @@
           <a:bodyPr wrap="square" rtlCol="0" anchor="ctr"/>
           <a:lstStyle/>
           <a:p>
-            <a:pPr algn="ctr" indent="0" marL="0">
+            <a:pPr marL="0" indent="0" algn="ctr">
               <a:buNone/>
             </a:pPr>
             <a:r>
@@ -6534,7 +6241,7 @@
           <a:bodyPr wrap="square" rtlCol="0" anchor="ctr"/>
           <a:lstStyle/>
           <a:p>
-            <a:pPr indent="0" marL="0">
+            <a:pPr marL="0" indent="0">
               <a:buNone/>
             </a:pPr>
             <a:r>
@@ -6573,7 +6280,7 @@
           <a:bodyPr wrap="square" rtlCol="0" anchor="t"/>
           <a:lstStyle/>
           <a:p>
-            <a:pPr indent="0" marL="0">
+            <a:pPr marL="0" indent="0">
               <a:buNone/>
             </a:pPr>
             <a:r>
@@ -6617,7 +6324,7 @@
             <a:prstDash val="solid"/>
           </a:ln>
           <a:effectLst>
-            <a:outerShdw sx="100000" sy="100000" kx="0" ky="0" algn="bl" rotWithShape="0" blurRad="88900" dist="38100" dir="5400000">
+            <a:outerShdw blurRad="88900" dist="38100" dir="5400000" algn="bl" rotWithShape="0">
               <a:srgbClr val="8494A8">
                 <a:alpha val="28000"/>
               </a:srgbClr>
@@ -6666,7 +6373,7 @@
           <a:bodyPr wrap="square" rtlCol="0" anchor="ctr"/>
           <a:lstStyle/>
           <a:p>
-            <a:pPr algn="ctr" indent="0" marL="0">
+            <a:pPr marL="0" indent="0" algn="ctr">
               <a:buNone/>
             </a:pPr>
             <a:r>
@@ -6705,7 +6412,7 @@
           <a:bodyPr wrap="square" rtlCol="0" anchor="ctr"/>
           <a:lstStyle/>
           <a:p>
-            <a:pPr indent="0" marL="0">
+            <a:pPr marL="0" indent="0">
               <a:buNone/>
             </a:pPr>
             <a:r>
@@ -6744,7 +6451,7 @@
           <a:bodyPr wrap="square" rtlCol="0" anchor="t"/>
           <a:lstStyle/>
           <a:p>
-            <a:pPr indent="0" marL="0">
+            <a:pPr marL="0" indent="0">
               <a:buNone/>
             </a:pPr>
             <a:r>
@@ -6788,7 +6495,7 @@
             <a:prstDash val="solid"/>
           </a:ln>
           <a:effectLst>
-            <a:outerShdw sx="100000" sy="100000" kx="0" ky="0" algn="bl" rotWithShape="0" blurRad="88900" dist="38100" dir="5400000">
+            <a:outerShdw blurRad="88900" dist="38100" dir="5400000" algn="bl" rotWithShape="0">
               <a:srgbClr val="8494A8">
                 <a:alpha val="28000"/>
               </a:srgbClr>
@@ -6837,7 +6544,7 @@
           <a:bodyPr wrap="square" rtlCol="0" anchor="ctr"/>
           <a:lstStyle/>
           <a:p>
-            <a:pPr algn="ctr" indent="0" marL="0">
+            <a:pPr marL="0" indent="0" algn="ctr">
               <a:buNone/>
             </a:pPr>
             <a:r>
@@ -6876,7 +6583,7 @@
           <a:bodyPr wrap="square" rtlCol="0" anchor="ctr"/>
           <a:lstStyle/>
           <a:p>
-            <a:pPr indent="0" marL="0">
+            <a:pPr marL="0" indent="0">
               <a:buNone/>
             </a:pPr>
             <a:r>
@@ -6915,7 +6622,7 @@
           <a:bodyPr wrap="square" rtlCol="0" anchor="t"/>
           <a:lstStyle/>
           <a:p>
-            <a:pPr indent="0" marL="0">
+            <a:pPr marL="0" indent="0">
               <a:buNone/>
             </a:pPr>
             <a:r>
@@ -6959,7 +6666,7 @@
             <a:prstDash val="solid"/>
           </a:ln>
           <a:effectLst>
-            <a:outerShdw sx="100000" sy="100000" kx="0" ky="0" algn="bl" rotWithShape="0" blurRad="88900" dist="38100" dir="5400000">
+            <a:outerShdw blurRad="88900" dist="38100" dir="5400000" algn="bl" rotWithShape="0">
               <a:srgbClr val="8494A8">
                 <a:alpha val="28000"/>
               </a:srgbClr>
@@ -7008,7 +6715,7 @@
           <a:bodyPr wrap="square" rtlCol="0" anchor="ctr"/>
           <a:lstStyle/>
           <a:p>
-            <a:pPr algn="ctr" indent="0" marL="0">
+            <a:pPr marL="0" indent="0" algn="ctr">
               <a:buNone/>
             </a:pPr>
             <a:r>
@@ -7047,7 +6754,7 @@
           <a:bodyPr wrap="square" rtlCol="0" anchor="ctr"/>
           <a:lstStyle/>
           <a:p>
-            <a:pPr indent="0" marL="0">
+            <a:pPr marL="0" indent="0">
               <a:buNone/>
             </a:pPr>
             <a:r>
@@ -7086,7 +6793,7 @@
           <a:bodyPr wrap="square" rtlCol="0" anchor="t"/>
           <a:lstStyle/>
           <a:p>
-            <a:pPr indent="0" marL="0">
+            <a:pPr marL="0" indent="0">
               <a:buNone/>
             </a:pPr>
             <a:r>
@@ -7130,7 +6837,7 @@
             <a:prstDash val="solid"/>
           </a:ln>
           <a:effectLst>
-            <a:outerShdw sx="100000" sy="100000" kx="0" ky="0" algn="bl" rotWithShape="0" blurRad="88900" dist="38100" dir="5400000">
+            <a:outerShdw blurRad="88900" dist="38100" dir="5400000" algn="bl" rotWithShape="0">
               <a:srgbClr val="8494A8">
                 <a:alpha val="28000"/>
               </a:srgbClr>
@@ -7179,7 +6886,7 @@
           <a:bodyPr wrap="square" rtlCol="0" anchor="ctr"/>
           <a:lstStyle/>
           <a:p>
-            <a:pPr algn="ctr" indent="0" marL="0">
+            <a:pPr marL="0" indent="0" algn="ctr">
               <a:buNone/>
             </a:pPr>
             <a:r>
@@ -7218,7 +6925,7 @@
           <a:bodyPr wrap="square" rtlCol="0" anchor="ctr"/>
           <a:lstStyle/>
           <a:p>
-            <a:pPr indent="0" marL="0">
+            <a:pPr marL="0" indent="0">
               <a:buNone/>
             </a:pPr>
             <a:r>
@@ -7257,7 +6964,7 @@
           <a:bodyPr wrap="square" rtlCol="0" anchor="t"/>
           <a:lstStyle/>
           <a:p>
-            <a:pPr indent="0" marL="0">
+            <a:pPr marL="0" indent="0">
               <a:buNone/>
             </a:pPr>
             <a:r>
@@ -7291,6 +6998,7 @@
         <a:solidFill>
           <a:srgbClr val="FFFFFF"/>
         </a:solidFill>
+        <a:effectLst/>
       </p:bgPr>
     </p:bg>
     <p:spTree>
@@ -7328,7 +7036,7 @@
           <a:bodyPr wrap="square" rtlCol="0" anchor="ctr"/>
           <a:lstStyle/>
           <a:p>
-            <a:pPr indent="0" marL="0">
+            <a:pPr marL="0" indent="0">
               <a:buNone/>
             </a:pPr>
             <a:r>
@@ -7342,9 +7050,6 @@
               </a:rPr>
               <a:t>SecurityOps Assistant</a:t>
             </a:r>
-            <a:pPr indent="0" marL="0">
-              <a:buNone/>
-            </a:pPr>
             <a:r>
               <a:rPr lang="en-US" sz="900" dirty="0">
                 <a:solidFill>
@@ -7381,7 +7086,7 @@
           <a:bodyPr wrap="square" rtlCol="0" anchor="ctr"/>
           <a:lstStyle/>
           <a:p>
-            <a:pPr algn="r" indent="0" marL="0">
+            <a:pPr marL="0" indent="0" algn="r">
               <a:buNone/>
             </a:pPr>
             <a:r>
@@ -7420,7 +7125,7 @@
           <a:bodyPr wrap="square" rtlCol="0" anchor="ctr"/>
           <a:lstStyle/>
           <a:p>
-            <a:pPr indent="0" marL="0">
+            <a:pPr marL="0" indent="0">
               <a:buNone/>
             </a:pPr>
             <a:r>
@@ -7464,7 +7169,7 @@
             <a:prstDash val="solid"/>
           </a:ln>
           <a:effectLst>
-            <a:outerShdw sx="100000" sy="100000" kx="0" ky="0" algn="bl" rotWithShape="0" blurRad="88900" dist="38100" dir="5400000">
+            <a:outerShdw blurRad="88900" dist="38100" dir="5400000" algn="bl" rotWithShape="0">
               <a:srgbClr val="8494A8">
                 <a:alpha val="28000"/>
               </a:srgbClr>
@@ -7515,7 +7220,7 @@
           <a:bodyPr wrap="square" rtlCol="0" anchor="ctr"/>
           <a:lstStyle/>
           <a:p>
-            <a:pPr algn="ctr" indent="0" marL="0">
+            <a:pPr marL="0" indent="0" algn="ctr">
               <a:buNone/>
             </a:pPr>
             <a:r>
@@ -7644,7 +7349,7 @@
             <a:prstDash val="solid"/>
           </a:ln>
           <a:effectLst>
-            <a:outerShdw sx="100000" sy="100000" kx="0" ky="0" algn="bl" rotWithShape="0" blurRad="88900" dist="38100" dir="5400000">
+            <a:outerShdw blurRad="88900" dist="38100" dir="5400000" algn="bl" rotWithShape="0">
               <a:srgbClr val="8494A8">
                 <a:alpha val="28000"/>
               </a:srgbClr>
@@ -7695,7 +7400,7 @@
           <a:bodyPr wrap="square" rtlCol="0" anchor="ctr"/>
           <a:lstStyle/>
           <a:p>
-            <a:pPr algn="ctr" indent="0" marL="0">
+            <a:pPr marL="0" indent="0" algn="ctr">
               <a:buNone/>
             </a:pPr>
             <a:r>
@@ -7824,7 +7529,7 @@
             <a:prstDash val="solid"/>
           </a:ln>
           <a:effectLst>
-            <a:outerShdw sx="100000" sy="100000" kx="0" ky="0" algn="bl" rotWithShape="0" blurRad="88900" dist="38100" dir="5400000">
+            <a:outerShdw blurRad="88900" dist="38100" dir="5400000" algn="bl" rotWithShape="0">
               <a:srgbClr val="8494A8">
                 <a:alpha val="28000"/>
               </a:srgbClr>
@@ -7875,7 +7580,7 @@
           <a:bodyPr wrap="square" rtlCol="0" anchor="ctr"/>
           <a:lstStyle/>
           <a:p>
-            <a:pPr algn="ctr" indent="0" marL="0">
+            <a:pPr marL="0" indent="0" algn="ctr">
               <a:buNone/>
             </a:pPr>
             <a:r>
@@ -7994,6 +7699,7 @@
         <a:solidFill>
           <a:srgbClr val="FFFFFF"/>
         </a:solidFill>
+        <a:effectLst/>
       </p:bgPr>
     </p:bg>
     <p:spTree>
@@ -8031,7 +7737,7 @@
           <a:bodyPr wrap="square" rtlCol="0" anchor="ctr"/>
           <a:lstStyle/>
           <a:p>
-            <a:pPr indent="0" marL="0">
+            <a:pPr marL="0" indent="0">
               <a:buNone/>
             </a:pPr>
             <a:r>
@@ -8045,9 +7751,6 @@
               </a:rPr>
               <a:t>SecurityOps Assistant</a:t>
             </a:r>
-            <a:pPr indent="0" marL="0">
-              <a:buNone/>
-            </a:pPr>
             <a:r>
               <a:rPr lang="en-US" sz="900" dirty="0">
                 <a:solidFill>
@@ -8084,7 +7787,7 @@
           <a:bodyPr wrap="square" rtlCol="0" anchor="ctr"/>
           <a:lstStyle/>
           <a:p>
-            <a:pPr algn="r" indent="0" marL="0">
+            <a:pPr marL="0" indent="0" algn="r">
               <a:buNone/>
             </a:pPr>
             <a:r>
@@ -8123,7 +7826,7 @@
           <a:bodyPr wrap="square" rtlCol="0" anchor="ctr"/>
           <a:lstStyle/>
           <a:p>
-            <a:pPr indent="0" marL="0">
+            <a:pPr marL="0" indent="0">
               <a:buNone/>
             </a:pPr>
             <a:r>
@@ -8167,7 +7870,7 @@
             <a:prstDash val="solid"/>
           </a:ln>
           <a:effectLst>
-            <a:outerShdw sx="100000" sy="100000" kx="0" ky="0" algn="bl" rotWithShape="0" blurRad="88900" dist="38100" dir="5400000">
+            <a:outerShdw blurRad="88900" dist="38100" dir="5400000" algn="bl" rotWithShape="0">
               <a:srgbClr val="8494A8">
                 <a:alpha val="28000"/>
               </a:srgbClr>
@@ -8216,7 +7919,7 @@
           <a:bodyPr wrap="square" rtlCol="0" anchor="ctr"/>
           <a:lstStyle/>
           <a:p>
-            <a:pPr algn="ctr" indent="0" marL="0">
+            <a:pPr marL="0" indent="0" algn="ctr">
               <a:buNone/>
             </a:pPr>
             <a:r>
@@ -8255,7 +7958,7 @@
           <a:bodyPr wrap="square" rtlCol="0" anchor="ctr"/>
           <a:lstStyle/>
           <a:p>
-            <a:pPr indent="0" marL="0">
+            <a:pPr marL="0" indent="0">
               <a:buNone/>
             </a:pPr>
             <a:r>
@@ -8299,7 +8002,7 @@
             <a:prstDash val="solid"/>
           </a:ln>
           <a:effectLst>
-            <a:outerShdw sx="100000" sy="100000" kx="0" ky="0" algn="bl" rotWithShape="0" blurRad="88900" dist="38100" dir="5400000">
+            <a:outerShdw blurRad="88900" dist="38100" dir="5400000" algn="bl" rotWithShape="0">
               <a:srgbClr val="8494A8">
                 <a:alpha val="28000"/>
               </a:srgbClr>
@@ -8348,7 +8051,7 @@
           <a:bodyPr wrap="square" rtlCol="0" anchor="ctr"/>
           <a:lstStyle/>
           <a:p>
-            <a:pPr algn="ctr" indent="0" marL="0">
+            <a:pPr marL="0" indent="0" algn="ctr">
               <a:buNone/>
             </a:pPr>
             <a:r>
@@ -8387,7 +8090,7 @@
           <a:bodyPr wrap="square" rtlCol="0" anchor="ctr"/>
           <a:lstStyle/>
           <a:p>
-            <a:pPr indent="0" marL="0">
+            <a:pPr marL="0" indent="0">
               <a:buNone/>
             </a:pPr>
             <a:r>
@@ -8431,7 +8134,7 @@
             <a:prstDash val="solid"/>
           </a:ln>
           <a:effectLst>
-            <a:outerShdw sx="100000" sy="100000" kx="0" ky="0" algn="bl" rotWithShape="0" blurRad="88900" dist="38100" dir="5400000">
+            <a:outerShdw blurRad="88900" dist="38100" dir="5400000" algn="bl" rotWithShape="0">
               <a:srgbClr val="8494A8">
                 <a:alpha val="28000"/>
               </a:srgbClr>
@@ -8480,7 +8183,7 @@
           <a:bodyPr wrap="square" rtlCol="0" anchor="ctr"/>
           <a:lstStyle/>
           <a:p>
-            <a:pPr algn="ctr" indent="0" marL="0">
+            <a:pPr marL="0" indent="0" algn="ctr">
               <a:buNone/>
             </a:pPr>
             <a:r>
@@ -8519,7 +8222,7 @@
           <a:bodyPr wrap="square" rtlCol="0" anchor="ctr"/>
           <a:lstStyle/>
           <a:p>
-            <a:pPr indent="0" marL="0">
+            <a:pPr marL="0" indent="0">
               <a:buNone/>
             </a:pPr>
             <a:r>
@@ -8563,7 +8266,7 @@
             <a:prstDash val="solid"/>
           </a:ln>
           <a:effectLst>
-            <a:outerShdw sx="100000" sy="100000" kx="0" ky="0" algn="bl" rotWithShape="0" blurRad="88900" dist="38100" dir="5400000">
+            <a:outerShdw blurRad="88900" dist="38100" dir="5400000" algn="bl" rotWithShape="0">
               <a:srgbClr val="8494A8">
                 <a:alpha val="28000"/>
               </a:srgbClr>
@@ -8612,7 +8315,7 @@
           <a:bodyPr wrap="square" rtlCol="0" anchor="ctr"/>
           <a:lstStyle/>
           <a:p>
-            <a:pPr algn="ctr" indent="0" marL="0">
+            <a:pPr marL="0" indent="0" algn="ctr">
               <a:buNone/>
             </a:pPr>
             <a:r>
@@ -8651,7 +8354,7 @@
           <a:bodyPr wrap="square" rtlCol="0" anchor="ctr"/>
           <a:lstStyle/>
           <a:p>
-            <a:pPr indent="0" marL="0">
+            <a:pPr marL="0" indent="0">
               <a:buNone/>
             </a:pPr>
             <a:r>
@@ -8695,7 +8398,7 @@
             <a:prstDash val="solid"/>
           </a:ln>
           <a:effectLst>
-            <a:outerShdw sx="100000" sy="100000" kx="0" ky="0" algn="bl" rotWithShape="0" blurRad="88900" dist="38100" dir="5400000">
+            <a:outerShdw blurRad="88900" dist="38100" dir="5400000" algn="bl" rotWithShape="0">
               <a:srgbClr val="8494A8">
                 <a:alpha val="28000"/>
               </a:srgbClr>
@@ -8744,7 +8447,7 @@
           <a:bodyPr wrap="square" rtlCol="0" anchor="ctr"/>
           <a:lstStyle/>
           <a:p>
-            <a:pPr algn="ctr" indent="0" marL="0">
+            <a:pPr marL="0" indent="0" algn="ctr">
               <a:buNone/>
             </a:pPr>
             <a:r>
@@ -8783,7 +8486,7 @@
           <a:bodyPr wrap="square" rtlCol="0" anchor="ctr"/>
           <a:lstStyle/>
           <a:p>
-            <a:pPr indent="0" marL="0">
+            <a:pPr marL="0" indent="0">
               <a:buNone/>
             </a:pPr>
             <a:r>
@@ -8817,6 +8520,7 @@
         <a:solidFill>
           <a:srgbClr val="16233A"/>
         </a:solidFill>
+        <a:effectLst/>
       </p:bgPr>
     </p:bg>
     <p:spTree>
@@ -8854,7 +8558,7 @@
           <a:bodyPr wrap="square" rtlCol="0" anchor="ctr"/>
           <a:lstStyle/>
           <a:p>
-            <a:pPr indent="0" marL="0">
+            <a:pPr marL="0" indent="0">
               <a:buNone/>
             </a:pPr>
             <a:r>
@@ -8893,7 +8597,7 @@
           <a:bodyPr wrap="square" rtlCol="0" anchor="ctr"/>
           <a:lstStyle/>
           <a:p>
-            <a:pPr indent="0" marL="0">
+            <a:pPr marL="0" indent="0">
               <a:buNone/>
             </a:pPr>
             <a:r>
@@ -8954,7 +8658,7 @@
           <a:bodyPr wrap="square" rtlCol="0" anchor="ctr"/>
           <a:lstStyle/>
           <a:p>
-            <a:pPr algn="ctr" indent="0" marL="0">
+            <a:pPr marL="0" indent="0" algn="ctr">
               <a:buNone/>
             </a:pPr>
             <a:r>
@@ -8993,7 +8697,7 @@
           <a:bodyPr wrap="square" rtlCol="0" anchor="ctr"/>
           <a:lstStyle/>
           <a:p>
-            <a:pPr indent="0" marL="0">
+            <a:pPr marL="0" indent="0">
               <a:buNone/>
             </a:pPr>
             <a:r>
@@ -9005,21 +8709,7 @@
                 <a:ea typeface="Calibri" pitchFamily="34" charset="-122"/>
                 <a:cs typeface="Calibri" pitchFamily="34" charset="-120"/>
               </a:rPr>
-              <a:t>Contact:  </a:t>
-            </a:r>
-            <a:pPr indent="0" marL="0">
-              <a:buNone/>
-            </a:pPr>
-            <a:r>
-              <a:rPr lang="en-US" sz="1400" dirty="0">
-                <a:solidFill>
-                  <a:srgbClr val="FFFFFF"/>
-                </a:solidFill>
-                <a:latin typeface="Calibri" pitchFamily="34" charset="0"/>
-                <a:ea typeface="Calibri" pitchFamily="34" charset="-122"/>
-                <a:cs typeface="Calibri" pitchFamily="34" charset="-120"/>
-              </a:rPr>
-              <a:t>[your.email@example.com]</a:t>
+              <a:t>Contact: </a:t>
             </a:r>
             <a:endParaRPr lang="en-US" sz="1400" dirty="0"/>
           </a:p>
@@ -9046,7 +8736,7 @@
           <a:bodyPr wrap="square" rtlCol="0" anchor="ctr"/>
           <a:lstStyle/>
           <a:p>
-            <a:pPr indent="0" marL="0">
+            <a:pPr marL="0" indent="0">
               <a:buNone/>
             </a:pPr>
             <a:r>
@@ -9060,9 +8750,6 @@
               </a:rPr>
               <a:t>Repository:  </a:t>
             </a:r>
-            <a:pPr indent="0" marL="0">
-              <a:buNone/>
-            </a:pPr>
             <a:r>
               <a:rPr lang="en-US" sz="1400" dirty="0">
                 <a:solidFill>
@@ -9094,6 +8781,7 @@
         <a:solidFill>
           <a:srgbClr val="FFFFFF"/>
         </a:solidFill>
+        <a:effectLst/>
       </p:bgPr>
     </p:bg>
     <p:spTree>
@@ -9131,7 +8819,7 @@
           <a:bodyPr wrap="square" rtlCol="0" anchor="ctr"/>
           <a:lstStyle/>
           <a:p>
-            <a:pPr indent="0" marL="0">
+            <a:pPr marL="0" indent="0">
               <a:buNone/>
             </a:pPr>
             <a:r>
@@ -9145,9 +8833,6 @@
               </a:rPr>
               <a:t>SecurityOps Assistant</a:t>
             </a:r>
-            <a:pPr indent="0" marL="0">
-              <a:buNone/>
-            </a:pPr>
             <a:r>
               <a:rPr lang="en-US" sz="900" dirty="0">
                 <a:solidFill>
@@ -9184,7 +8869,7 @@
           <a:bodyPr wrap="square" rtlCol="0" anchor="ctr"/>
           <a:lstStyle/>
           <a:p>
-            <a:pPr algn="r" indent="0" marL="0">
+            <a:pPr marL="0" indent="0" algn="r">
               <a:buNone/>
             </a:pPr>
             <a:r>
@@ -9223,7 +8908,7 @@
           <a:bodyPr wrap="square" rtlCol="0" anchor="ctr"/>
           <a:lstStyle/>
           <a:p>
-            <a:pPr indent="0" marL="0">
+            <a:pPr marL="0" indent="0">
               <a:buNone/>
             </a:pPr>
             <a:r>
@@ -9267,7 +8952,7 @@
             <a:prstDash val="solid"/>
           </a:ln>
           <a:effectLst>
-            <a:outerShdw sx="100000" sy="100000" kx="0" ky="0" algn="bl" rotWithShape="0" blurRad="88900" dist="38100" dir="5400000">
+            <a:outerShdw blurRad="88900" dist="38100" dir="5400000" algn="bl" rotWithShape="0">
               <a:srgbClr val="8494A8">
                 <a:alpha val="28000"/>
               </a:srgbClr>
@@ -9316,7 +9001,7 @@
           <a:bodyPr wrap="square" rtlCol="0" anchor="ctr"/>
           <a:lstStyle/>
           <a:p>
-            <a:pPr algn="ctr" indent="0" marL="0">
+            <a:pPr marL="0" indent="0" algn="ctr">
               <a:buNone/>
             </a:pPr>
             <a:r>
@@ -9355,7 +9040,7 @@
           <a:bodyPr wrap="square" rtlCol="0" anchor="ctr"/>
           <a:lstStyle/>
           <a:p>
-            <a:pPr indent="0" marL="0">
+            <a:pPr marL="0" indent="0">
               <a:buNone/>
             </a:pPr>
             <a:r>
@@ -9394,7 +9079,7 @@
           <a:bodyPr wrap="square" rtlCol="0" anchor="t"/>
           <a:lstStyle/>
           <a:p>
-            <a:pPr indent="0" marL="0">
+            <a:pPr marL="0" indent="0">
               <a:buNone/>
             </a:pPr>
             <a:r>
@@ -9438,7 +9123,7 @@
             <a:prstDash val="solid"/>
           </a:ln>
           <a:effectLst>
-            <a:outerShdw sx="100000" sy="100000" kx="0" ky="0" algn="bl" rotWithShape="0" blurRad="88900" dist="38100" dir="5400000">
+            <a:outerShdw blurRad="88900" dist="38100" dir="5400000" algn="bl" rotWithShape="0">
               <a:srgbClr val="8494A8">
                 <a:alpha val="28000"/>
               </a:srgbClr>
@@ -9487,7 +9172,7 @@
           <a:bodyPr wrap="square" rtlCol="0" anchor="ctr"/>
           <a:lstStyle/>
           <a:p>
-            <a:pPr algn="ctr" indent="0" marL="0">
+            <a:pPr marL="0" indent="0" algn="ctr">
               <a:buNone/>
             </a:pPr>
             <a:r>
@@ -9526,7 +9211,7 @@
           <a:bodyPr wrap="square" rtlCol="0" anchor="ctr"/>
           <a:lstStyle/>
           <a:p>
-            <a:pPr indent="0" marL="0">
+            <a:pPr marL="0" indent="0">
               <a:buNone/>
             </a:pPr>
             <a:r>
@@ -9565,7 +9250,7 @@
           <a:bodyPr wrap="square" rtlCol="0" anchor="t"/>
           <a:lstStyle/>
           <a:p>
-            <a:pPr indent="0" marL="0">
+            <a:pPr marL="0" indent="0">
               <a:buNone/>
             </a:pPr>
             <a:r>
@@ -9609,7 +9294,7 @@
             <a:prstDash val="solid"/>
           </a:ln>
           <a:effectLst>
-            <a:outerShdw sx="100000" sy="100000" kx="0" ky="0" algn="bl" rotWithShape="0" blurRad="88900" dist="38100" dir="5400000">
+            <a:outerShdw blurRad="88900" dist="38100" dir="5400000" algn="bl" rotWithShape="0">
               <a:srgbClr val="8494A8">
                 <a:alpha val="28000"/>
               </a:srgbClr>
@@ -9658,7 +9343,7 @@
           <a:bodyPr wrap="square" rtlCol="0" anchor="ctr"/>
           <a:lstStyle/>
           <a:p>
-            <a:pPr algn="ctr" indent="0" marL="0">
+            <a:pPr marL="0" indent="0" algn="ctr">
               <a:buNone/>
             </a:pPr>
             <a:r>
@@ -9697,7 +9382,7 @@
           <a:bodyPr wrap="square" rtlCol="0" anchor="ctr"/>
           <a:lstStyle/>
           <a:p>
-            <a:pPr indent="0" marL="0">
+            <a:pPr marL="0" indent="0">
               <a:buNone/>
             </a:pPr>
             <a:r>
@@ -9736,7 +9421,7 @@
           <a:bodyPr wrap="square" rtlCol="0" anchor="t"/>
           <a:lstStyle/>
           <a:p>
-            <a:pPr indent="0" marL="0">
+            <a:pPr marL="0" indent="0">
               <a:buNone/>
             </a:pPr>
             <a:r>
@@ -9780,7 +9465,7 @@
             <a:prstDash val="solid"/>
           </a:ln>
           <a:effectLst>
-            <a:outerShdw sx="100000" sy="100000" kx="0" ky="0" algn="bl" rotWithShape="0" blurRad="88900" dist="38100" dir="5400000">
+            <a:outerShdw blurRad="88900" dist="38100" dir="5400000" algn="bl" rotWithShape="0">
               <a:srgbClr val="8494A8">
                 <a:alpha val="28000"/>
               </a:srgbClr>
@@ -9829,7 +9514,7 @@
           <a:bodyPr wrap="square" rtlCol="0" anchor="ctr"/>
           <a:lstStyle/>
           <a:p>
-            <a:pPr algn="ctr" indent="0" marL="0">
+            <a:pPr marL="0" indent="0" algn="ctr">
               <a:buNone/>
             </a:pPr>
             <a:r>
@@ -9868,7 +9553,7 @@
           <a:bodyPr wrap="square" rtlCol="0" anchor="ctr"/>
           <a:lstStyle/>
           <a:p>
-            <a:pPr indent="0" marL="0">
+            <a:pPr marL="0" indent="0">
               <a:buNone/>
             </a:pPr>
             <a:r>
@@ -9907,7 +9592,7 @@
           <a:bodyPr wrap="square" rtlCol="0" anchor="t"/>
           <a:lstStyle/>
           <a:p>
-            <a:pPr indent="0" marL="0">
+            <a:pPr marL="0" indent="0">
               <a:buNone/>
             </a:pPr>
             <a:r>
@@ -9941,6 +9626,7 @@
         <a:solidFill>
           <a:srgbClr val="FFFFFF"/>
         </a:solidFill>
+        <a:effectLst/>
       </p:bgPr>
     </p:bg>
     <p:spTree>
@@ -9978,7 +9664,7 @@
           <a:bodyPr wrap="square" rtlCol="0" anchor="ctr"/>
           <a:lstStyle/>
           <a:p>
-            <a:pPr indent="0" marL="0">
+            <a:pPr marL="0" indent="0">
               <a:buNone/>
             </a:pPr>
             <a:r>
@@ -9992,9 +9678,6 @@
               </a:rPr>
               <a:t>SecurityOps Assistant</a:t>
             </a:r>
-            <a:pPr indent="0" marL="0">
-              <a:buNone/>
-            </a:pPr>
             <a:r>
               <a:rPr lang="en-US" sz="900" dirty="0">
                 <a:solidFill>
@@ -10031,7 +9714,7 @@
           <a:bodyPr wrap="square" rtlCol="0" anchor="ctr"/>
           <a:lstStyle/>
           <a:p>
-            <a:pPr algn="r" indent="0" marL="0">
+            <a:pPr marL="0" indent="0" algn="r">
               <a:buNone/>
             </a:pPr>
             <a:r>
@@ -10070,7 +9753,7 @@
           <a:bodyPr wrap="square" rtlCol="0" anchor="ctr"/>
           <a:lstStyle/>
           <a:p>
-            <a:pPr indent="0" marL="0">
+            <a:pPr marL="0" indent="0">
               <a:buNone/>
             </a:pPr>
             <a:r>
@@ -10114,7 +9797,7 @@
             <a:prstDash val="solid"/>
           </a:ln>
           <a:effectLst>
-            <a:outerShdw sx="100000" sy="100000" kx="0" ky="0" algn="bl" rotWithShape="0" blurRad="88900" dist="38100" dir="5400000">
+            <a:outerShdw blurRad="88900" dist="38100" dir="5400000" algn="bl" rotWithShape="0">
               <a:srgbClr val="8494A8">
                 <a:alpha val="28000"/>
               </a:srgbClr>
@@ -10163,7 +9846,7 @@
           <a:bodyPr wrap="square" rtlCol="0" anchor="ctr"/>
           <a:lstStyle/>
           <a:p>
-            <a:pPr algn="ctr" indent="0" marL="0">
+            <a:pPr marL="0" indent="0" algn="ctr">
               <a:buNone/>
             </a:pPr>
             <a:r>
@@ -10202,7 +9885,7 @@
           <a:bodyPr wrap="square" rtlCol="0" anchor="ctr"/>
           <a:lstStyle/>
           <a:p>
-            <a:pPr indent="0" marL="0">
+            <a:pPr marL="0" indent="0">
               <a:buNone/>
             </a:pPr>
             <a:r>
@@ -10246,7 +9929,7 @@
             <a:prstDash val="solid"/>
           </a:ln>
           <a:effectLst>
-            <a:outerShdw sx="100000" sy="100000" kx="0" ky="0" algn="bl" rotWithShape="0" blurRad="88900" dist="38100" dir="5400000">
+            <a:outerShdw blurRad="88900" dist="38100" dir="5400000" algn="bl" rotWithShape="0">
               <a:srgbClr val="8494A8">
                 <a:alpha val="28000"/>
               </a:srgbClr>
@@ -10295,7 +9978,7 @@
           <a:bodyPr wrap="square" rtlCol="0" anchor="ctr"/>
           <a:lstStyle/>
           <a:p>
-            <a:pPr algn="ctr" indent="0" marL="0">
+            <a:pPr marL="0" indent="0" algn="ctr">
               <a:buNone/>
             </a:pPr>
             <a:r>
@@ -10334,7 +10017,7 @@
           <a:bodyPr wrap="square" rtlCol="0" anchor="ctr"/>
           <a:lstStyle/>
           <a:p>
-            <a:pPr indent="0" marL="0">
+            <a:pPr marL="0" indent="0">
               <a:buNone/>
             </a:pPr>
             <a:r>
@@ -10378,7 +10061,7 @@
             <a:prstDash val="solid"/>
           </a:ln>
           <a:effectLst>
-            <a:outerShdw sx="100000" sy="100000" kx="0" ky="0" algn="bl" rotWithShape="0" blurRad="88900" dist="38100" dir="5400000">
+            <a:outerShdw blurRad="88900" dist="38100" dir="5400000" algn="bl" rotWithShape="0">
               <a:srgbClr val="8494A8">
                 <a:alpha val="28000"/>
               </a:srgbClr>
@@ -10427,7 +10110,7 @@
           <a:bodyPr wrap="square" rtlCol="0" anchor="ctr"/>
           <a:lstStyle/>
           <a:p>
-            <a:pPr algn="ctr" indent="0" marL="0">
+            <a:pPr marL="0" indent="0" algn="ctr">
               <a:buNone/>
             </a:pPr>
             <a:r>
@@ -10466,7 +10149,7 @@
           <a:bodyPr wrap="square" rtlCol="0" anchor="ctr"/>
           <a:lstStyle/>
           <a:p>
-            <a:pPr indent="0" marL="0">
+            <a:pPr marL="0" indent="0">
               <a:buNone/>
             </a:pPr>
             <a:r>
@@ -10510,7 +10193,7 @@
             <a:prstDash val="solid"/>
           </a:ln>
           <a:effectLst>
-            <a:outerShdw sx="100000" sy="100000" kx="0" ky="0" algn="bl" rotWithShape="0" blurRad="88900" dist="38100" dir="5400000">
+            <a:outerShdw blurRad="88900" dist="38100" dir="5400000" algn="bl" rotWithShape="0">
               <a:srgbClr val="8494A8">
                 <a:alpha val="28000"/>
               </a:srgbClr>
@@ -10559,7 +10242,7 @@
           <a:bodyPr wrap="square" rtlCol="0" anchor="ctr"/>
           <a:lstStyle/>
           <a:p>
-            <a:pPr algn="ctr" indent="0" marL="0">
+            <a:pPr marL="0" indent="0" algn="ctr">
               <a:buNone/>
             </a:pPr>
             <a:r>
@@ -10598,7 +10281,7 @@
           <a:bodyPr wrap="square" rtlCol="0" anchor="ctr"/>
           <a:lstStyle/>
           <a:p>
-            <a:pPr indent="0" marL="0">
+            <a:pPr marL="0" indent="0">
               <a:buNone/>
             </a:pPr>
             <a:r>
@@ -10642,7 +10325,7 @@
             <a:prstDash val="solid"/>
           </a:ln>
           <a:effectLst>
-            <a:outerShdw sx="100000" sy="100000" kx="0" ky="0" algn="bl" rotWithShape="0" blurRad="88900" dist="38100" dir="5400000">
+            <a:outerShdw blurRad="88900" dist="38100" dir="5400000" algn="bl" rotWithShape="0">
               <a:srgbClr val="8494A8">
                 <a:alpha val="28000"/>
               </a:srgbClr>
@@ -10691,7 +10374,7 @@
           <a:bodyPr wrap="square" rtlCol="0" anchor="ctr"/>
           <a:lstStyle/>
           <a:p>
-            <a:pPr algn="ctr" indent="0" marL="0">
+            <a:pPr marL="0" indent="0" algn="ctr">
               <a:buNone/>
             </a:pPr>
             <a:r>
@@ -10730,7 +10413,7 @@
           <a:bodyPr wrap="square" rtlCol="0" anchor="ctr"/>
           <a:lstStyle/>
           <a:p>
-            <a:pPr indent="0" marL="0">
+            <a:pPr marL="0" indent="0">
               <a:buNone/>
             </a:pPr>
             <a:r>
@@ -10764,6 +10447,7 @@
         <a:solidFill>
           <a:srgbClr val="FFFFFF"/>
         </a:solidFill>
+        <a:effectLst/>
       </p:bgPr>
     </p:bg>
     <p:spTree>
@@ -10801,7 +10485,7 @@
           <a:bodyPr wrap="square" rtlCol="0" anchor="ctr"/>
           <a:lstStyle/>
           <a:p>
-            <a:pPr indent="0" marL="0">
+            <a:pPr marL="0" indent="0">
               <a:buNone/>
             </a:pPr>
             <a:r>
@@ -10815,9 +10499,6 @@
               </a:rPr>
               <a:t>SecurityOps Assistant</a:t>
             </a:r>
-            <a:pPr indent="0" marL="0">
-              <a:buNone/>
-            </a:pPr>
             <a:r>
               <a:rPr lang="en-US" sz="900" dirty="0">
                 <a:solidFill>
@@ -10854,7 +10535,7 @@
           <a:bodyPr wrap="square" rtlCol="0" anchor="ctr"/>
           <a:lstStyle/>
           <a:p>
-            <a:pPr algn="r" indent="0" marL="0">
+            <a:pPr marL="0" indent="0" algn="r">
               <a:buNone/>
             </a:pPr>
             <a:r>
@@ -10893,7 +10574,7 @@
           <a:bodyPr wrap="square" rtlCol="0" anchor="ctr"/>
           <a:lstStyle/>
           <a:p>
-            <a:pPr indent="0" marL="0">
+            <a:pPr marL="0" indent="0">
               <a:buNone/>
             </a:pPr>
             <a:r>
@@ -10937,7 +10618,7 @@
             <a:prstDash val="solid"/>
           </a:ln>
           <a:effectLst>
-            <a:outerShdw sx="100000" sy="100000" kx="0" ky="0" algn="bl" rotWithShape="0" blurRad="88900" dist="38100" dir="5400000">
+            <a:outerShdw blurRad="88900" dist="38100" dir="5400000" algn="bl" rotWithShape="0">
               <a:srgbClr val="8494A8">
                 <a:alpha val="28000"/>
               </a:srgbClr>
@@ -10986,7 +10667,7 @@
           <a:bodyPr wrap="square" rtlCol="0" anchor="ctr"/>
           <a:lstStyle/>
           <a:p>
-            <a:pPr algn="ctr" indent="0" marL="0">
+            <a:pPr marL="0" indent="0" algn="ctr">
               <a:buNone/>
             </a:pPr>
             <a:r>
@@ -11025,7 +10706,7 @@
           <a:bodyPr wrap="square" rtlCol="0" anchor="ctr"/>
           <a:lstStyle/>
           <a:p>
-            <a:pPr indent="0" marL="0">
+            <a:pPr marL="0" indent="0">
               <a:buNone/>
             </a:pPr>
             <a:r>
@@ -11069,7 +10750,7 @@
             <a:prstDash val="solid"/>
           </a:ln>
           <a:effectLst>
-            <a:outerShdw sx="100000" sy="100000" kx="0" ky="0" algn="bl" rotWithShape="0" blurRad="88900" dist="38100" dir="5400000">
+            <a:outerShdw blurRad="88900" dist="38100" dir="5400000" algn="bl" rotWithShape="0">
               <a:srgbClr val="8494A8">
                 <a:alpha val="28000"/>
               </a:srgbClr>
@@ -11118,7 +10799,7 @@
           <a:bodyPr wrap="square" rtlCol="0" anchor="ctr"/>
           <a:lstStyle/>
           <a:p>
-            <a:pPr algn="ctr" indent="0" marL="0">
+            <a:pPr marL="0" indent="0" algn="ctr">
               <a:buNone/>
             </a:pPr>
             <a:r>
@@ -11157,7 +10838,7 @@
           <a:bodyPr wrap="square" rtlCol="0" anchor="ctr"/>
           <a:lstStyle/>
           <a:p>
-            <a:pPr indent="0" marL="0">
+            <a:pPr marL="0" indent="0">
               <a:buNone/>
             </a:pPr>
             <a:r>
@@ -11201,7 +10882,7 @@
             <a:prstDash val="solid"/>
           </a:ln>
           <a:effectLst>
-            <a:outerShdw sx="100000" sy="100000" kx="0" ky="0" algn="bl" rotWithShape="0" blurRad="88900" dist="38100" dir="5400000">
+            <a:outerShdw blurRad="88900" dist="38100" dir="5400000" algn="bl" rotWithShape="0">
               <a:srgbClr val="8494A8">
                 <a:alpha val="28000"/>
               </a:srgbClr>
@@ -11250,7 +10931,7 @@
           <a:bodyPr wrap="square" rtlCol="0" anchor="ctr"/>
           <a:lstStyle/>
           <a:p>
-            <a:pPr algn="ctr" indent="0" marL="0">
+            <a:pPr marL="0" indent="0" algn="ctr">
               <a:buNone/>
             </a:pPr>
             <a:r>
@@ -11289,7 +10970,7 @@
           <a:bodyPr wrap="square" rtlCol="0" anchor="ctr"/>
           <a:lstStyle/>
           <a:p>
-            <a:pPr indent="0" marL="0">
+            <a:pPr marL="0" indent="0">
               <a:buNone/>
             </a:pPr>
             <a:r>
@@ -11333,7 +11014,7 @@
             <a:prstDash val="solid"/>
           </a:ln>
           <a:effectLst>
-            <a:outerShdw sx="100000" sy="100000" kx="0" ky="0" algn="bl" rotWithShape="0" blurRad="88900" dist="38100" dir="5400000">
+            <a:outerShdw blurRad="88900" dist="38100" dir="5400000" algn="bl" rotWithShape="0">
               <a:srgbClr val="8494A8">
                 <a:alpha val="28000"/>
               </a:srgbClr>
@@ -11382,7 +11063,7 @@
           <a:bodyPr wrap="square" rtlCol="0" anchor="ctr"/>
           <a:lstStyle/>
           <a:p>
-            <a:pPr algn="ctr" indent="0" marL="0">
+            <a:pPr marL="0" indent="0" algn="ctr">
               <a:buNone/>
             </a:pPr>
             <a:r>
@@ -11421,7 +11102,7 @@
           <a:bodyPr wrap="square" rtlCol="0" anchor="ctr"/>
           <a:lstStyle/>
           <a:p>
-            <a:pPr indent="0" marL="0">
+            <a:pPr marL="0" indent="0">
               <a:buNone/>
             </a:pPr>
             <a:r>
@@ -11465,7 +11146,7 @@
             <a:prstDash val="solid"/>
           </a:ln>
           <a:effectLst>
-            <a:outerShdw sx="100000" sy="100000" kx="0" ky="0" algn="bl" rotWithShape="0" blurRad="88900" dist="38100" dir="5400000">
+            <a:outerShdw blurRad="88900" dist="38100" dir="5400000" algn="bl" rotWithShape="0">
               <a:srgbClr val="8494A8">
                 <a:alpha val="28000"/>
               </a:srgbClr>
@@ -11514,7 +11195,7 @@
           <a:bodyPr wrap="square" rtlCol="0" anchor="ctr"/>
           <a:lstStyle/>
           <a:p>
-            <a:pPr algn="ctr" indent="0" marL="0">
+            <a:pPr marL="0" indent="0" algn="ctr">
               <a:buNone/>
             </a:pPr>
             <a:r>
@@ -11553,7 +11234,7 @@
           <a:bodyPr wrap="square" rtlCol="0" anchor="ctr"/>
           <a:lstStyle/>
           <a:p>
-            <a:pPr indent="0" marL="0">
+            <a:pPr marL="0" indent="0">
               <a:buNone/>
             </a:pPr>
             <a:r>
@@ -11587,6 +11268,7 @@
         <a:solidFill>
           <a:srgbClr val="FFFFFF"/>
         </a:solidFill>
+        <a:effectLst/>
       </p:bgPr>
     </p:bg>
     <p:spTree>
@@ -11624,7 +11306,7 @@
           <a:bodyPr wrap="square" rtlCol="0" anchor="ctr"/>
           <a:lstStyle/>
           <a:p>
-            <a:pPr indent="0" marL="0">
+            <a:pPr marL="0" indent="0">
               <a:buNone/>
             </a:pPr>
             <a:r>
@@ -11638,9 +11320,6 @@
               </a:rPr>
               <a:t>SecurityOps Assistant</a:t>
             </a:r>
-            <a:pPr indent="0" marL="0">
-              <a:buNone/>
-            </a:pPr>
             <a:r>
               <a:rPr lang="en-US" sz="900" dirty="0">
                 <a:solidFill>
@@ -11677,7 +11356,7 @@
           <a:bodyPr wrap="square" rtlCol="0" anchor="ctr"/>
           <a:lstStyle/>
           <a:p>
-            <a:pPr algn="r" indent="0" marL="0">
+            <a:pPr marL="0" indent="0" algn="r">
               <a:buNone/>
             </a:pPr>
             <a:r>
@@ -11716,7 +11395,7 @@
           <a:bodyPr wrap="square" rtlCol="0" anchor="ctr"/>
           <a:lstStyle/>
           <a:p>
-            <a:pPr indent="0" marL="0">
+            <a:pPr marL="0" indent="0">
               <a:buNone/>
             </a:pPr>
             <a:r>
@@ -11760,7 +11439,7 @@
             <a:prstDash val="solid"/>
           </a:ln>
           <a:effectLst>
-            <a:outerShdw sx="100000" sy="100000" kx="0" ky="0" algn="bl" rotWithShape="0" blurRad="88900" dist="38100" dir="5400000">
+            <a:outerShdw blurRad="88900" dist="38100" dir="5400000" algn="bl" rotWithShape="0">
               <a:srgbClr val="8494A8">
                 <a:alpha val="28000"/>
               </a:srgbClr>
@@ -11809,7 +11488,7 @@
           <a:bodyPr wrap="square" rtlCol="0" anchor="ctr"/>
           <a:lstStyle/>
           <a:p>
-            <a:pPr algn="ctr" indent="0" marL="0">
+            <a:pPr marL="0" indent="0" algn="ctr">
               <a:buNone/>
             </a:pPr>
             <a:r>
@@ -11848,7 +11527,7 @@
           <a:bodyPr wrap="square" rtlCol="0" anchor="ctr"/>
           <a:lstStyle/>
           <a:p>
-            <a:pPr indent="0" marL="0">
+            <a:pPr marL="0" indent="0">
               <a:buNone/>
             </a:pPr>
             <a:r>
@@ -11892,7 +11571,7 @@
             <a:prstDash val="solid"/>
           </a:ln>
           <a:effectLst>
-            <a:outerShdw sx="100000" sy="100000" kx="0" ky="0" algn="bl" rotWithShape="0" blurRad="88900" dist="38100" dir="5400000">
+            <a:outerShdw blurRad="88900" dist="38100" dir="5400000" algn="bl" rotWithShape="0">
               <a:srgbClr val="8494A8">
                 <a:alpha val="28000"/>
               </a:srgbClr>
@@ -11941,7 +11620,7 @@
           <a:bodyPr wrap="square" rtlCol="0" anchor="ctr"/>
           <a:lstStyle/>
           <a:p>
-            <a:pPr algn="ctr" indent="0" marL="0">
+            <a:pPr marL="0" indent="0" algn="ctr">
               <a:buNone/>
             </a:pPr>
             <a:r>
@@ -11980,7 +11659,7 @@
           <a:bodyPr wrap="square" rtlCol="0" anchor="ctr"/>
           <a:lstStyle/>
           <a:p>
-            <a:pPr indent="0" marL="0">
+            <a:pPr marL="0" indent="0">
               <a:buNone/>
             </a:pPr>
             <a:r>
@@ -12024,7 +11703,7 @@
             <a:prstDash val="solid"/>
           </a:ln>
           <a:effectLst>
-            <a:outerShdw sx="100000" sy="100000" kx="0" ky="0" algn="bl" rotWithShape="0" blurRad="88900" dist="38100" dir="5400000">
+            <a:outerShdw blurRad="88900" dist="38100" dir="5400000" algn="bl" rotWithShape="0">
               <a:srgbClr val="8494A8">
                 <a:alpha val="28000"/>
               </a:srgbClr>
@@ -12073,7 +11752,7 @@
           <a:bodyPr wrap="square" rtlCol="0" anchor="ctr"/>
           <a:lstStyle/>
           <a:p>
-            <a:pPr algn="ctr" indent="0" marL="0">
+            <a:pPr marL="0" indent="0" algn="ctr">
               <a:buNone/>
             </a:pPr>
             <a:r>
@@ -12112,7 +11791,7 @@
           <a:bodyPr wrap="square" rtlCol="0" anchor="ctr"/>
           <a:lstStyle/>
           <a:p>
-            <a:pPr indent="0" marL="0">
+            <a:pPr marL="0" indent="0">
               <a:buNone/>
             </a:pPr>
             <a:r>
@@ -12156,7 +11835,7 @@
             <a:prstDash val="solid"/>
           </a:ln>
           <a:effectLst>
-            <a:outerShdw sx="100000" sy="100000" kx="0" ky="0" algn="bl" rotWithShape="0" blurRad="88900" dist="38100" dir="5400000">
+            <a:outerShdw blurRad="88900" dist="38100" dir="5400000" algn="bl" rotWithShape="0">
               <a:srgbClr val="8494A8">
                 <a:alpha val="28000"/>
               </a:srgbClr>
@@ -12205,7 +11884,7 @@
           <a:bodyPr wrap="square" rtlCol="0" anchor="ctr"/>
           <a:lstStyle/>
           <a:p>
-            <a:pPr algn="ctr" indent="0" marL="0">
+            <a:pPr marL="0" indent="0" algn="ctr">
               <a:buNone/>
             </a:pPr>
             <a:r>
@@ -12244,7 +11923,7 @@
           <a:bodyPr wrap="square" rtlCol="0" anchor="ctr"/>
           <a:lstStyle/>
           <a:p>
-            <a:pPr indent="0" marL="0">
+            <a:pPr marL="0" indent="0">
               <a:buNone/>
             </a:pPr>
             <a:r>
@@ -12288,7 +11967,7 @@
             <a:prstDash val="solid"/>
           </a:ln>
           <a:effectLst>
-            <a:outerShdw sx="100000" sy="100000" kx="0" ky="0" algn="bl" rotWithShape="0" blurRad="88900" dist="38100" dir="5400000">
+            <a:outerShdw blurRad="88900" dist="38100" dir="5400000" algn="bl" rotWithShape="0">
               <a:srgbClr val="8494A8">
                 <a:alpha val="28000"/>
               </a:srgbClr>
@@ -12337,7 +12016,7 @@
           <a:bodyPr wrap="square" rtlCol="0" anchor="ctr"/>
           <a:lstStyle/>
           <a:p>
-            <a:pPr algn="ctr" indent="0" marL="0">
+            <a:pPr marL="0" indent="0" algn="ctr">
               <a:buNone/>
             </a:pPr>
             <a:r>
@@ -12376,7 +12055,7 @@
           <a:bodyPr wrap="square" rtlCol="0" anchor="ctr"/>
           <a:lstStyle/>
           <a:p>
-            <a:pPr indent="0" marL="0">
+            <a:pPr marL="0" indent="0">
               <a:buNone/>
             </a:pPr>
             <a:r>
@@ -12420,7 +12099,7 @@
             <a:prstDash val="solid"/>
           </a:ln>
           <a:effectLst>
-            <a:outerShdw sx="100000" sy="100000" kx="0" ky="0" algn="bl" rotWithShape="0" blurRad="88900" dist="38100" dir="5400000">
+            <a:outerShdw blurRad="88900" dist="38100" dir="5400000" algn="bl" rotWithShape="0">
               <a:srgbClr val="8494A8">
                 <a:alpha val="28000"/>
               </a:srgbClr>
@@ -12469,7 +12148,7 @@
           <a:bodyPr wrap="square" rtlCol="0" anchor="ctr"/>
           <a:lstStyle/>
           <a:p>
-            <a:pPr algn="ctr" indent="0" marL="0">
+            <a:pPr marL="0" indent="0" algn="ctr">
               <a:buNone/>
             </a:pPr>
             <a:r>
@@ -12508,7 +12187,7 @@
           <a:bodyPr wrap="square" rtlCol="0" anchor="ctr"/>
           <a:lstStyle/>
           <a:p>
-            <a:pPr indent="0" marL="0">
+            <a:pPr marL="0" indent="0">
               <a:buNone/>
             </a:pPr>
             <a:r>
@@ -12542,6 +12221,7 @@
         <a:solidFill>
           <a:srgbClr val="FFFFFF"/>
         </a:solidFill>
+        <a:effectLst/>
       </p:bgPr>
     </p:bg>
     <p:spTree>
@@ -12579,7 +12259,7 @@
           <a:bodyPr wrap="square" rtlCol="0" anchor="ctr"/>
           <a:lstStyle/>
           <a:p>
-            <a:pPr indent="0" marL="0">
+            <a:pPr marL="0" indent="0">
               <a:buNone/>
             </a:pPr>
             <a:r>
@@ -12593,9 +12273,6 @@
               </a:rPr>
               <a:t>SecurityOps Assistant</a:t>
             </a:r>
-            <a:pPr indent="0" marL="0">
-              <a:buNone/>
-            </a:pPr>
             <a:r>
               <a:rPr lang="en-US" sz="900" dirty="0">
                 <a:solidFill>
@@ -12632,7 +12309,7 @@
           <a:bodyPr wrap="square" rtlCol="0" anchor="ctr"/>
           <a:lstStyle/>
           <a:p>
-            <a:pPr algn="r" indent="0" marL="0">
+            <a:pPr marL="0" indent="0" algn="r">
               <a:buNone/>
             </a:pPr>
             <a:r>
@@ -12671,7 +12348,7 @@
           <a:bodyPr wrap="square" rtlCol="0" anchor="ctr"/>
           <a:lstStyle/>
           <a:p>
-            <a:pPr indent="0" marL="0">
+            <a:pPr marL="0" indent="0">
               <a:buNone/>
             </a:pPr>
             <a:r>
@@ -12715,7 +12392,7 @@
             <a:prstDash val="solid"/>
           </a:ln>
           <a:effectLst>
-            <a:outerShdw sx="100000" sy="100000" kx="0" ky="0" algn="bl" rotWithShape="0" blurRad="88900" dist="38100" dir="5400000">
+            <a:outerShdw blurRad="88900" dist="38100" dir="5400000" algn="bl" rotWithShape="0">
               <a:srgbClr val="8494A8">
                 <a:alpha val="28000"/>
               </a:srgbClr>
@@ -12749,7 +12426,7 @@
             <a:prstDash val="solid"/>
           </a:ln>
           <a:effectLst>
-            <a:outerShdw sx="100000" sy="100000" kx="0" ky="0" algn="bl" rotWithShape="0" blurRad="88900" dist="38100" dir="5400000">
+            <a:outerShdw blurRad="88900" dist="38100" dir="5400000" algn="bl" rotWithShape="0">
               <a:srgbClr val="8494A8">
                 <a:alpha val="28000"/>
               </a:srgbClr>
@@ -12778,7 +12455,7 @@
           <a:bodyPr wrap="square" rtlCol="0" anchor="ctr"/>
           <a:lstStyle/>
           <a:p>
-            <a:pPr indent="0" marL="0">
+            <a:pPr marL="0" indent="0">
               <a:buNone/>
             </a:pPr>
             <a:r>
@@ -12817,7 +12494,7 @@
           <a:bodyPr wrap="square" rtlCol="0" anchor="ctr"/>
           <a:lstStyle/>
           <a:p>
-            <a:pPr indent="0" marL="0">
+            <a:pPr marL="0" indent="0">
               <a:buNone/>
             </a:pPr>
             <a:r>
@@ -13147,6 +12824,7 @@
         <a:solidFill>
           <a:srgbClr val="FFFFFF"/>
         </a:solidFill>
+        <a:effectLst/>
       </p:bgPr>
     </p:bg>
     <p:spTree>
@@ -13184,7 +12862,7 @@
           <a:bodyPr wrap="square" rtlCol="0" anchor="ctr"/>
           <a:lstStyle/>
           <a:p>
-            <a:pPr indent="0" marL="0">
+            <a:pPr marL="0" indent="0">
               <a:buNone/>
             </a:pPr>
             <a:r>
@@ -13198,9 +12876,6 @@
               </a:rPr>
               <a:t>SecurityOps Assistant</a:t>
             </a:r>
-            <a:pPr indent="0" marL="0">
-              <a:buNone/>
-            </a:pPr>
             <a:r>
               <a:rPr lang="en-US" sz="900" dirty="0">
                 <a:solidFill>
@@ -13237,7 +12912,7 @@
           <a:bodyPr wrap="square" rtlCol="0" anchor="ctr"/>
           <a:lstStyle/>
           <a:p>
-            <a:pPr algn="r" indent="0" marL="0">
+            <a:pPr marL="0" indent="0" algn="r">
               <a:buNone/>
             </a:pPr>
             <a:r>
@@ -13276,7 +12951,7 @@
           <a:bodyPr wrap="square" rtlCol="0" anchor="ctr"/>
           <a:lstStyle/>
           <a:p>
-            <a:pPr indent="0" marL="0">
+            <a:pPr marL="0" indent="0">
               <a:buNone/>
             </a:pPr>
             <a:r>
@@ -13320,7 +12995,7 @@
             <a:prstDash val="solid"/>
           </a:ln>
           <a:effectLst>
-            <a:outerShdw sx="100000" sy="100000" kx="0" ky="0" algn="bl" rotWithShape="0" blurRad="88900" dist="38100" dir="5400000">
+            <a:outerShdw blurRad="88900" dist="38100" dir="5400000" algn="bl" rotWithShape="0">
               <a:srgbClr val="8494A8">
                 <a:alpha val="28000"/>
               </a:srgbClr>
@@ -13369,7 +13044,7 @@
           <a:bodyPr wrap="square" rtlCol="0" anchor="ctr"/>
           <a:lstStyle/>
           <a:p>
-            <a:pPr algn="ctr" indent="0" marL="0">
+            <a:pPr marL="0" indent="0" algn="ctr">
               <a:buNone/>
             </a:pPr>
             <a:r>
@@ -13408,7 +13083,7 @@
           <a:bodyPr wrap="square" rtlCol="0" anchor="ctr"/>
           <a:lstStyle/>
           <a:p>
-            <a:pPr indent="0" marL="0">
+            <a:pPr marL="0" indent="0">
               <a:buNone/>
             </a:pPr>
             <a:r>
@@ -13452,7 +13127,7 @@
             <a:prstDash val="solid"/>
           </a:ln>
           <a:effectLst>
-            <a:outerShdw sx="100000" sy="100000" kx="0" ky="0" algn="bl" rotWithShape="0" blurRad="88900" dist="38100" dir="5400000">
+            <a:outerShdw blurRad="88900" dist="38100" dir="5400000" algn="bl" rotWithShape="0">
               <a:srgbClr val="8494A8">
                 <a:alpha val="28000"/>
               </a:srgbClr>
@@ -13501,7 +13176,7 @@
           <a:bodyPr wrap="square" rtlCol="0" anchor="ctr"/>
           <a:lstStyle/>
           <a:p>
-            <a:pPr algn="ctr" indent="0" marL="0">
+            <a:pPr marL="0" indent="0" algn="ctr">
               <a:buNone/>
             </a:pPr>
             <a:r>
@@ -13540,7 +13215,7 @@
           <a:bodyPr wrap="square" rtlCol="0" anchor="ctr"/>
           <a:lstStyle/>
           <a:p>
-            <a:pPr indent="0" marL="0">
+            <a:pPr marL="0" indent="0">
               <a:buNone/>
             </a:pPr>
             <a:r>
@@ -13584,7 +13259,7 @@
             <a:prstDash val="solid"/>
           </a:ln>
           <a:effectLst>
-            <a:outerShdw sx="100000" sy="100000" kx="0" ky="0" algn="bl" rotWithShape="0" blurRad="88900" dist="38100" dir="5400000">
+            <a:outerShdw blurRad="88900" dist="38100" dir="5400000" algn="bl" rotWithShape="0">
               <a:srgbClr val="8494A8">
                 <a:alpha val="28000"/>
               </a:srgbClr>
@@ -13633,7 +13308,7 @@
           <a:bodyPr wrap="square" rtlCol="0" anchor="ctr"/>
           <a:lstStyle/>
           <a:p>
-            <a:pPr algn="ctr" indent="0" marL="0">
+            <a:pPr marL="0" indent="0" algn="ctr">
               <a:buNone/>
             </a:pPr>
             <a:r>
@@ -13672,7 +13347,7 @@
           <a:bodyPr wrap="square" rtlCol="0" anchor="ctr"/>
           <a:lstStyle/>
           <a:p>
-            <a:pPr indent="0" marL="0">
+            <a:pPr marL="0" indent="0">
               <a:buNone/>
             </a:pPr>
             <a:r>
@@ -13716,7 +13391,7 @@
             <a:prstDash val="solid"/>
           </a:ln>
           <a:effectLst>
-            <a:outerShdw sx="100000" sy="100000" kx="0" ky="0" algn="bl" rotWithShape="0" blurRad="88900" dist="38100" dir="5400000">
+            <a:outerShdw blurRad="88900" dist="38100" dir="5400000" algn="bl" rotWithShape="0">
               <a:srgbClr val="8494A8">
                 <a:alpha val="28000"/>
               </a:srgbClr>
@@ -13765,7 +13440,7 @@
           <a:bodyPr wrap="square" rtlCol="0" anchor="ctr"/>
           <a:lstStyle/>
           <a:p>
-            <a:pPr algn="ctr" indent="0" marL="0">
+            <a:pPr marL="0" indent="0" algn="ctr">
               <a:buNone/>
             </a:pPr>
             <a:r>
@@ -13804,7 +13479,7 @@
           <a:bodyPr wrap="square" rtlCol="0" anchor="ctr"/>
           <a:lstStyle/>
           <a:p>
-            <a:pPr indent="0" marL="0">
+            <a:pPr marL="0" indent="0">
               <a:buNone/>
             </a:pPr>
             <a:r>
@@ -13848,7 +13523,7 @@
             <a:prstDash val="solid"/>
           </a:ln>
           <a:effectLst>
-            <a:outerShdw sx="100000" sy="100000" kx="0" ky="0" algn="bl" rotWithShape="0" blurRad="88900" dist="38100" dir="5400000">
+            <a:outerShdw blurRad="88900" dist="38100" dir="5400000" algn="bl" rotWithShape="0">
               <a:srgbClr val="8494A8">
                 <a:alpha val="28000"/>
               </a:srgbClr>
@@ -13897,7 +13572,7 @@
           <a:bodyPr wrap="square" rtlCol="0" anchor="ctr"/>
           <a:lstStyle/>
           <a:p>
-            <a:pPr algn="ctr" indent="0" marL="0">
+            <a:pPr marL="0" indent="0" algn="ctr">
               <a:buNone/>
             </a:pPr>
             <a:r>
@@ -13936,7 +13611,7 @@
           <a:bodyPr wrap="square" rtlCol="0" anchor="ctr"/>
           <a:lstStyle/>
           <a:p>
-            <a:pPr indent="0" marL="0">
+            <a:pPr marL="0" indent="0">
               <a:buNone/>
             </a:pPr>
             <a:r>
@@ -13980,7 +13655,7 @@
             <a:prstDash val="solid"/>
           </a:ln>
           <a:effectLst>
-            <a:outerShdw sx="100000" sy="100000" kx="0" ky="0" algn="bl" rotWithShape="0" blurRad="88900" dist="38100" dir="5400000">
+            <a:outerShdw blurRad="88900" dist="38100" dir="5400000" algn="bl" rotWithShape="0">
               <a:srgbClr val="8494A8">
                 <a:alpha val="28000"/>
               </a:srgbClr>
@@ -14029,7 +13704,7 @@
           <a:bodyPr wrap="square" rtlCol="0" anchor="ctr"/>
           <a:lstStyle/>
           <a:p>
-            <a:pPr algn="ctr" indent="0" marL="0">
+            <a:pPr marL="0" indent="0" algn="ctr">
               <a:buNone/>
             </a:pPr>
             <a:r>
@@ -14068,7 +13743,7 @@
           <a:bodyPr wrap="square" rtlCol="0" anchor="ctr"/>
           <a:lstStyle/>
           <a:p>
-            <a:pPr indent="0" marL="0">
+            <a:pPr marL="0" indent="0">
               <a:buNone/>
             </a:pPr>
             <a:r>
@@ -14102,6 +13777,7 @@
         <a:solidFill>
           <a:srgbClr val="FFFFFF"/>
         </a:solidFill>
+        <a:effectLst/>
       </p:bgPr>
     </p:bg>
     <p:spTree>
@@ -14139,7 +13815,7 @@
           <a:bodyPr wrap="square" rtlCol="0" anchor="ctr"/>
           <a:lstStyle/>
           <a:p>
-            <a:pPr indent="0" marL="0">
+            <a:pPr marL="0" indent="0">
               <a:buNone/>
             </a:pPr>
             <a:r>
@@ -14153,9 +13829,6 @@
               </a:rPr>
               <a:t>SecurityOps Assistant</a:t>
             </a:r>
-            <a:pPr indent="0" marL="0">
-              <a:buNone/>
-            </a:pPr>
             <a:r>
               <a:rPr lang="en-US" sz="900" dirty="0">
                 <a:solidFill>
@@ -14192,7 +13865,7 @@
           <a:bodyPr wrap="square" rtlCol="0" anchor="ctr"/>
           <a:lstStyle/>
           <a:p>
-            <a:pPr algn="r" indent="0" marL="0">
+            <a:pPr marL="0" indent="0" algn="r">
               <a:buNone/>
             </a:pPr>
             <a:r>
@@ -14231,7 +13904,7 @@
           <a:bodyPr wrap="square" rtlCol="0" anchor="ctr"/>
           <a:lstStyle/>
           <a:p>
-            <a:pPr indent="0" marL="0">
+            <a:pPr marL="0" indent="0">
               <a:buNone/>
             </a:pPr>
             <a:r>
@@ -14275,7 +13948,7 @@
             <a:prstDash val="solid"/>
           </a:ln>
           <a:effectLst>
-            <a:outerShdw sx="100000" sy="100000" kx="0" ky="0" algn="bl" rotWithShape="0" blurRad="88900" dist="38100" dir="5400000">
+            <a:outerShdw blurRad="88900" dist="38100" dir="5400000" algn="bl" rotWithShape="0">
               <a:srgbClr val="8494A8">
                 <a:alpha val="28000"/>
               </a:srgbClr>
@@ -14324,7 +13997,7 @@
           <a:bodyPr wrap="square" rtlCol="0" anchor="ctr"/>
           <a:lstStyle/>
           <a:p>
-            <a:pPr indent="0" marL="0">
+            <a:pPr marL="0" indent="0">
               <a:buNone/>
             </a:pPr>
             <a:r>
@@ -14363,7 +14036,7 @@
           <a:bodyPr wrap="square" rtlCol="0" anchor="ctr"/>
           <a:lstStyle/>
           <a:p>
-            <a:pPr indent="0" marL="0">
+            <a:pPr marL="0" indent="0">
               <a:buNone/>
             </a:pPr>
             <a:r>
@@ -14402,7 +14075,7 @@
           <a:bodyPr wrap="square" rtlCol="0" anchor="ctr"/>
           <a:lstStyle/>
           <a:p>
-            <a:pPr algn="ctr" indent="0" marL="0">
+            <a:pPr marL="0" indent="0" algn="ctr">
               <a:buNone/>
             </a:pPr>
             <a:r>
@@ -14446,7 +14119,7 @@
             <a:prstDash val="solid"/>
           </a:ln>
           <a:effectLst>
-            <a:outerShdw sx="100000" sy="100000" kx="0" ky="0" algn="bl" rotWithShape="0" blurRad="88900" dist="38100" dir="5400000">
+            <a:outerShdw blurRad="88900" dist="38100" dir="5400000" algn="bl" rotWithShape="0">
               <a:srgbClr val="8494A8">
                 <a:alpha val="28000"/>
               </a:srgbClr>
@@ -14495,7 +14168,7 @@
           <a:bodyPr wrap="square" rtlCol="0" anchor="ctr"/>
           <a:lstStyle/>
           <a:p>
-            <a:pPr indent="0" marL="0">
+            <a:pPr marL="0" indent="0">
               <a:buNone/>
             </a:pPr>
             <a:r>
@@ -14534,7 +14207,7 @@
           <a:bodyPr wrap="square" rtlCol="0" anchor="ctr"/>
           <a:lstStyle/>
           <a:p>
-            <a:pPr indent="0" marL="0">
+            <a:pPr marL="0" indent="0">
               <a:buNone/>
             </a:pPr>
             <a:r>
@@ -14573,7 +14246,7 @@
           <a:bodyPr wrap="square" rtlCol="0" anchor="ctr"/>
           <a:lstStyle/>
           <a:p>
-            <a:pPr algn="ctr" indent="0" marL="0">
+            <a:pPr marL="0" indent="0" algn="ctr">
               <a:buNone/>
             </a:pPr>
             <a:r>
@@ -14617,7 +14290,7 @@
             <a:prstDash val="solid"/>
           </a:ln>
           <a:effectLst>
-            <a:outerShdw sx="100000" sy="100000" kx="0" ky="0" algn="bl" rotWithShape="0" blurRad="88900" dist="38100" dir="5400000">
+            <a:outerShdw blurRad="88900" dist="38100" dir="5400000" algn="bl" rotWithShape="0">
               <a:srgbClr val="8494A8">
                 <a:alpha val="28000"/>
               </a:srgbClr>
@@ -14666,7 +14339,7 @@
           <a:bodyPr wrap="square" rtlCol="0" anchor="ctr"/>
           <a:lstStyle/>
           <a:p>
-            <a:pPr indent="0" marL="0">
+            <a:pPr marL="0" indent="0">
               <a:buNone/>
             </a:pPr>
             <a:r>
@@ -14705,7 +14378,7 @@
           <a:bodyPr wrap="square" rtlCol="0" anchor="ctr"/>
           <a:lstStyle/>
           <a:p>
-            <a:pPr indent="0" marL="0">
+            <a:pPr marL="0" indent="0">
               <a:buNone/>
             </a:pPr>
             <a:r>
@@ -14744,7 +14417,7 @@
           <a:bodyPr wrap="square" rtlCol="0" anchor="ctr"/>
           <a:lstStyle/>
           <a:p>
-            <a:pPr algn="ctr" indent="0" marL="0">
+            <a:pPr marL="0" indent="0" algn="ctr">
               <a:buNone/>
             </a:pPr>
             <a:r>
@@ -14788,7 +14461,7 @@
             <a:prstDash val="solid"/>
           </a:ln>
           <a:effectLst>
-            <a:outerShdw sx="100000" sy="100000" kx="0" ky="0" algn="bl" rotWithShape="0" blurRad="88900" dist="38100" dir="5400000">
+            <a:outerShdw blurRad="88900" dist="38100" dir="5400000" algn="bl" rotWithShape="0">
               <a:srgbClr val="8494A8">
                 <a:alpha val="28000"/>
               </a:srgbClr>
@@ -14837,7 +14510,7 @@
           <a:bodyPr wrap="square" rtlCol="0" anchor="ctr"/>
           <a:lstStyle/>
           <a:p>
-            <a:pPr indent="0" marL="0">
+            <a:pPr marL="0" indent="0">
               <a:buNone/>
             </a:pPr>
             <a:r>
@@ -14876,7 +14549,7 @@
           <a:bodyPr wrap="square" rtlCol="0" anchor="ctr"/>
           <a:lstStyle/>
           <a:p>
-            <a:pPr indent="0" marL="0">
+            <a:pPr marL="0" indent="0">
               <a:buNone/>
             </a:pPr>
             <a:r>
@@ -14920,7 +14593,7 @@
             <a:prstDash val="solid"/>
           </a:ln>
           <a:effectLst>
-            <a:outerShdw sx="100000" sy="100000" kx="0" ky="0" algn="bl" rotWithShape="0" blurRad="88900" dist="38100" dir="5400000">
+            <a:outerShdw blurRad="88900" dist="38100" dir="5400000" algn="bl" rotWithShape="0">
               <a:srgbClr val="8494A8">
                 <a:alpha val="28000"/>
               </a:srgbClr>
@@ -14949,7 +14622,7 @@
           <a:bodyPr wrap="square" rtlCol="0" anchor="ctr"/>
           <a:lstStyle/>
           <a:p>
-            <a:pPr indent="0" marL="0">
+            <a:pPr marL="0" indent="0">
               <a:buNone/>
             </a:pPr>
             <a:r>
@@ -15015,7 +14688,7 @@
           <a:bodyPr wrap="square" rtlCol="0" anchor="ctr"/>
           <a:lstStyle/>
           <a:p>
-            <a:pPr algn="ctr" indent="0" marL="0">
+            <a:pPr marL="0" indent="0" algn="ctr">
               <a:buNone/>
             </a:pPr>
             <a:r>
@@ -15081,7 +14754,7 @@
           <a:bodyPr wrap="square" rtlCol="0" anchor="ctr"/>
           <a:lstStyle/>
           <a:p>
-            <a:pPr algn="ctr" indent="0" marL="0">
+            <a:pPr marL="0" indent="0" algn="ctr">
               <a:buNone/>
             </a:pPr>
             <a:r>
@@ -15147,7 +14820,7 @@
           <a:bodyPr wrap="square" rtlCol="0" anchor="ctr"/>
           <a:lstStyle/>
           <a:p>
-            <a:pPr algn="ctr" indent="0" marL="0">
+            <a:pPr marL="0" indent="0" algn="ctr">
               <a:buNone/>
             </a:pPr>
             <a:r>
@@ -15213,7 +14886,7 @@
           <a:bodyPr wrap="square" rtlCol="0" anchor="ctr"/>
           <a:lstStyle/>
           <a:p>
-            <a:pPr algn="ctr" indent="0" marL="0">
+            <a:pPr marL="0" indent="0" algn="ctr">
               <a:buNone/>
             </a:pPr>
             <a:r>
@@ -15279,7 +14952,7 @@
           <a:bodyPr wrap="square" rtlCol="0" anchor="ctr"/>
           <a:lstStyle/>
           <a:p>
-            <a:pPr algn="ctr" indent="0" marL="0">
+            <a:pPr marL="0" indent="0" algn="ctr">
               <a:buNone/>
             </a:pPr>
             <a:r>
@@ -15345,7 +15018,7 @@
           <a:bodyPr wrap="square" rtlCol="0" anchor="ctr"/>
           <a:lstStyle/>
           <a:p>
-            <a:pPr algn="ctr" indent="0" marL="0">
+            <a:pPr marL="0" indent="0" algn="ctr">
               <a:buNone/>
             </a:pPr>
             <a:r>
@@ -15411,7 +15084,7 @@
           <a:bodyPr wrap="square" rtlCol="0" anchor="ctr"/>
           <a:lstStyle/>
           <a:p>
-            <a:pPr algn="ctr" indent="0" marL="0">
+            <a:pPr marL="0" indent="0" algn="ctr">
               <a:buNone/>
             </a:pPr>
             <a:r>
@@ -15477,7 +15150,7 @@
           <a:bodyPr wrap="square" rtlCol="0" anchor="ctr"/>
           <a:lstStyle/>
           <a:p>
-            <a:pPr algn="ctr" indent="0" marL="0">
+            <a:pPr marL="0" indent="0" algn="ctr">
               <a:buNone/>
             </a:pPr>
             <a:r>
@@ -15511,6 +15184,7 @@
         <a:solidFill>
           <a:srgbClr val="FFFFFF"/>
         </a:solidFill>
+        <a:effectLst/>
       </p:bgPr>
     </p:bg>
     <p:spTree>
@@ -15548,7 +15222,7 @@
           <a:bodyPr wrap="square" rtlCol="0" anchor="ctr"/>
           <a:lstStyle/>
           <a:p>
-            <a:pPr indent="0" marL="0">
+            <a:pPr marL="0" indent="0">
               <a:buNone/>
             </a:pPr>
             <a:r>
@@ -15562,9 +15236,6 @@
               </a:rPr>
               <a:t>SecurityOps Assistant</a:t>
             </a:r>
-            <a:pPr indent="0" marL="0">
-              <a:buNone/>
-            </a:pPr>
             <a:r>
               <a:rPr lang="en-US" sz="900" dirty="0">
                 <a:solidFill>
@@ -15601,7 +15272,7 @@
           <a:bodyPr wrap="square" rtlCol="0" anchor="ctr"/>
           <a:lstStyle/>
           <a:p>
-            <a:pPr algn="r" indent="0" marL="0">
+            <a:pPr marL="0" indent="0" algn="r">
               <a:buNone/>
             </a:pPr>
             <a:r>
@@ -15640,7 +15311,7 @@
           <a:bodyPr wrap="square" rtlCol="0" anchor="ctr"/>
           <a:lstStyle/>
           <a:p>
-            <a:pPr indent="0" marL="0">
+            <a:pPr marL="0" indent="0">
               <a:buNone/>
             </a:pPr>
             <a:r>
@@ -15674,16 +15345,34 @@
         </p:nvGraphicFramePr>
         <p:xfrm>
           <a:off x="502920" y="1554480"/>
-          <a:ext cx="11201400" cy="914400"/>
+          <a:ext cx="11201400" cy="4608576"/>
         </p:xfrm>
         <a:graphic>
           <a:graphicData uri="http://schemas.openxmlformats.org/drawingml/2006/table">
             <a:tbl>
               <a:tblPr/>
               <a:tblGrid>
-                <a:gridCol w="2103120"/>
-                <a:gridCol w="2743200"/>
-                <a:gridCol w="6355080"/>
+                <a:gridCol w="2103120">
+                  <a:extLst>
+                    <a:ext uri="{9D8B030D-6E8A-4147-A177-3AD203B41FA5}">
+                      <a16:colId xmlns:a16="http://schemas.microsoft.com/office/drawing/2014/main" val="20000"/>
+                    </a:ext>
+                  </a:extLst>
+                </a:gridCol>
+                <a:gridCol w="2743200">
+                  <a:extLst>
+                    <a:ext uri="{9D8B030D-6E8A-4147-A177-3AD203B41FA5}">
+                      <a16:colId xmlns:a16="http://schemas.microsoft.com/office/drawing/2014/main" val="20001"/>
+                    </a:ext>
+                  </a:extLst>
+                </a:gridCol>
+                <a:gridCol w="6355080">
+                  <a:extLst>
+                    <a:ext uri="{9D8B030D-6E8A-4147-A177-3AD203B41FA5}">
+                      <a16:colId xmlns:a16="http://schemas.microsoft.com/office/drawing/2014/main" val="20002"/>
+                    </a:ext>
+                  </a:extLst>
+                </a:gridCol>
               </a:tblGrid>
               <a:tr h="658368">
                 <a:tc>
@@ -15691,7 +15380,7 @@
                     <a:bodyPr/>
                     <a:lstStyle/>
                     <a:p>
-                      <a:pPr algn="l" indent="0" marL="0">
+                      <a:pPr marL="0" indent="0" algn="l">
                         <a:buNone/>
                       </a:pPr>
                       <a:r>
@@ -15712,7 +15401,7 @@
                       </a:endParaRPr>
                     </a:p>
                   </a:txBody>
-                  <a:tcPr marL="91440" marR="91440" marT="45720" marB="45720" anchor="ctr">
+                  <a:tcPr anchor="ctr">
                     <a:lnL w="12700" cap="flat" cmpd="sng" algn="ctr">
                       <a:solidFill>
                         <a:srgbClr val="D9E1EC"/>
@@ -15759,7 +15448,7 @@
                     <a:bodyPr/>
                     <a:lstStyle/>
                     <a:p>
-                      <a:pPr algn="l" indent="0" marL="0">
+                      <a:pPr marL="0" indent="0" algn="l">
                         <a:buNone/>
                       </a:pPr>
                       <a:r>
@@ -15780,7 +15469,7 @@
                       </a:endParaRPr>
                     </a:p>
                   </a:txBody>
-                  <a:tcPr marL="91440" marR="91440" marT="45720" marB="45720" anchor="ctr">
+                  <a:tcPr anchor="ctr">
                     <a:lnL w="12700" cap="flat" cmpd="sng" algn="ctr">
                       <a:solidFill>
                         <a:srgbClr val="D9E1EC"/>
@@ -15827,7 +15516,7 @@
                     <a:bodyPr/>
                     <a:lstStyle/>
                     <a:p>
-                      <a:pPr algn="l" indent="0" marL="0">
+                      <a:pPr marL="0" indent="0" algn="l">
                         <a:buNone/>
                       </a:pPr>
                       <a:r>
@@ -15848,7 +15537,7 @@
                       </a:endParaRPr>
                     </a:p>
                   </a:txBody>
-                  <a:tcPr marL="91440" marR="91440" marT="45720" marB="45720" anchor="ctr">
+                  <a:tcPr anchor="ctr">
                     <a:lnL w="12700" cap="flat" cmpd="sng" algn="ctr">
                       <a:solidFill>
                         <a:srgbClr val="D9E1EC"/>
@@ -15890,6 +15579,11 @@
                     </a:solidFill>
                   </a:tcPr>
                 </a:tc>
+                <a:extLst>
+                  <a:ext uri="{0D108BD9-81ED-4DB2-BD59-A6C34878D82A}">
+                    <a16:rowId xmlns:a16="http://schemas.microsoft.com/office/drawing/2014/main" val="10000"/>
+                  </a:ext>
+                </a:extLst>
               </a:tr>
               <a:tr h="658368">
                 <a:tc>
@@ -15897,7 +15591,7 @@
                     <a:bodyPr/>
                     <a:lstStyle/>
                     <a:p>
-                      <a:pPr indent="0" marL="0">
+                      <a:pPr marL="0" indent="0">
                         <a:buNone/>
                       </a:pPr>
                       <a:r>
@@ -15918,7 +15612,7 @@
                       </a:endParaRPr>
                     </a:p>
                   </a:txBody>
-                  <a:tcPr marL="91440" marR="91440" marT="45720" marB="45720" anchor="ctr">
+                  <a:tcPr anchor="ctr">
                     <a:lnL w="12700" cap="flat" cmpd="sng" algn="ctr">
                       <a:solidFill>
                         <a:srgbClr val="D9E1EC"/>
@@ -15965,7 +15659,7 @@
                     <a:bodyPr/>
                     <a:lstStyle/>
                     <a:p>
-                      <a:pPr indent="0" marL="0">
+                      <a:pPr marL="0" indent="0">
                         <a:buNone/>
                       </a:pPr>
                       <a:r>
@@ -15986,7 +15680,7 @@
                       </a:endParaRPr>
                     </a:p>
                   </a:txBody>
-                  <a:tcPr marL="91440" marR="91440" marT="45720" marB="45720" anchor="ctr">
+                  <a:tcPr anchor="ctr">
                     <a:lnL w="12700" cap="flat" cmpd="sng" algn="ctr">
                       <a:solidFill>
                         <a:srgbClr val="D9E1EC"/>
@@ -16033,7 +15727,7 @@
                     <a:bodyPr/>
                     <a:lstStyle/>
                     <a:p>
-                      <a:pPr indent="0" marL="0">
+                      <a:pPr marL="0" indent="0">
                         <a:buNone/>
                       </a:pPr>
                       <a:r>
@@ -16054,7 +15748,7 @@
                       </a:endParaRPr>
                     </a:p>
                   </a:txBody>
-                  <a:tcPr marL="91440" marR="91440" marT="45720" marB="45720" anchor="ctr">
+                  <a:tcPr anchor="ctr">
                     <a:lnL w="12700" cap="flat" cmpd="sng" algn="ctr">
                       <a:solidFill>
                         <a:srgbClr val="D9E1EC"/>
@@ -16096,6 +15790,11 @@
                     </a:solidFill>
                   </a:tcPr>
                 </a:tc>
+                <a:extLst>
+                  <a:ext uri="{0D108BD9-81ED-4DB2-BD59-A6C34878D82A}">
+                    <a16:rowId xmlns:a16="http://schemas.microsoft.com/office/drawing/2014/main" val="10001"/>
+                  </a:ext>
+                </a:extLst>
               </a:tr>
               <a:tr h="658368">
                 <a:tc>
@@ -16103,7 +15802,7 @@
                     <a:bodyPr/>
                     <a:lstStyle/>
                     <a:p>
-                      <a:pPr indent="0" marL="0">
+                      <a:pPr marL="0" indent="0">
                         <a:buNone/>
                       </a:pPr>
                       <a:r>
@@ -16124,7 +15823,7 @@
                       </a:endParaRPr>
                     </a:p>
                   </a:txBody>
-                  <a:tcPr marL="91440" marR="91440" marT="45720" marB="45720" anchor="ctr">
+                  <a:tcPr anchor="ctr">
                     <a:lnL w="12700" cap="flat" cmpd="sng" algn="ctr">
                       <a:solidFill>
                         <a:srgbClr val="D9E1EC"/>
@@ -16171,7 +15870,7 @@
                     <a:bodyPr/>
                     <a:lstStyle/>
                     <a:p>
-                      <a:pPr indent="0" marL="0">
+                      <a:pPr marL="0" indent="0">
                         <a:buNone/>
                       </a:pPr>
                       <a:r>
@@ -16192,7 +15891,7 @@
                       </a:endParaRPr>
                     </a:p>
                   </a:txBody>
-                  <a:tcPr marL="91440" marR="91440" marT="45720" marB="45720" anchor="ctr">
+                  <a:tcPr anchor="ctr">
                     <a:lnL w="12700" cap="flat" cmpd="sng" algn="ctr">
                       <a:solidFill>
                         <a:srgbClr val="D9E1EC"/>
@@ -16239,7 +15938,7 @@
                     <a:bodyPr/>
                     <a:lstStyle/>
                     <a:p>
-                      <a:pPr indent="0" marL="0">
+                      <a:pPr marL="0" indent="0">
                         <a:buNone/>
                       </a:pPr>
                       <a:r>
@@ -16260,7 +15959,7 @@
                       </a:endParaRPr>
                     </a:p>
                   </a:txBody>
-                  <a:tcPr marL="91440" marR="91440" marT="45720" marB="45720" anchor="ctr">
+                  <a:tcPr anchor="ctr">
                     <a:lnL w="12700" cap="flat" cmpd="sng" algn="ctr">
                       <a:solidFill>
                         <a:srgbClr val="D9E1EC"/>
@@ -16302,6 +16001,11 @@
                     </a:solidFill>
                   </a:tcPr>
                 </a:tc>
+                <a:extLst>
+                  <a:ext uri="{0D108BD9-81ED-4DB2-BD59-A6C34878D82A}">
+                    <a16:rowId xmlns:a16="http://schemas.microsoft.com/office/drawing/2014/main" val="10002"/>
+                  </a:ext>
+                </a:extLst>
               </a:tr>
               <a:tr h="658368">
                 <a:tc>
@@ -16309,7 +16013,7 @@
                     <a:bodyPr/>
                     <a:lstStyle/>
                     <a:p>
-                      <a:pPr indent="0" marL="0">
+                      <a:pPr marL="0" indent="0">
                         <a:buNone/>
                       </a:pPr>
                       <a:r>
@@ -16330,7 +16034,7 @@
                       </a:endParaRPr>
                     </a:p>
                   </a:txBody>
-                  <a:tcPr marL="91440" marR="91440" marT="45720" marB="45720" anchor="ctr">
+                  <a:tcPr anchor="ctr">
                     <a:lnL w="12700" cap="flat" cmpd="sng" algn="ctr">
                       <a:solidFill>
                         <a:srgbClr val="D9E1EC"/>
@@ -16377,7 +16081,7 @@
                     <a:bodyPr/>
                     <a:lstStyle/>
                     <a:p>
-                      <a:pPr indent="0" marL="0">
+                      <a:pPr marL="0" indent="0">
                         <a:buNone/>
                       </a:pPr>
                       <a:r>
@@ -16398,7 +16102,7 @@
                       </a:endParaRPr>
                     </a:p>
                   </a:txBody>
-                  <a:tcPr marL="91440" marR="91440" marT="45720" marB="45720" anchor="ctr">
+                  <a:tcPr anchor="ctr">
                     <a:lnL w="12700" cap="flat" cmpd="sng" algn="ctr">
                       <a:solidFill>
                         <a:srgbClr val="D9E1EC"/>
@@ -16445,7 +16149,7 @@
                     <a:bodyPr/>
                     <a:lstStyle/>
                     <a:p>
-                      <a:pPr indent="0" marL="0">
+                      <a:pPr marL="0" indent="0">
                         <a:buNone/>
                       </a:pPr>
                       <a:r>
@@ -16466,7 +16170,7 @@
                       </a:endParaRPr>
                     </a:p>
                   </a:txBody>
-                  <a:tcPr marL="91440" marR="91440" marT="45720" marB="45720" anchor="ctr">
+                  <a:tcPr anchor="ctr">
                     <a:lnL w="12700" cap="flat" cmpd="sng" algn="ctr">
                       <a:solidFill>
                         <a:srgbClr val="D9E1EC"/>
@@ -16508,6 +16212,11 @@
                     </a:solidFill>
                   </a:tcPr>
                 </a:tc>
+                <a:extLst>
+                  <a:ext uri="{0D108BD9-81ED-4DB2-BD59-A6C34878D82A}">
+                    <a16:rowId xmlns:a16="http://schemas.microsoft.com/office/drawing/2014/main" val="10003"/>
+                  </a:ext>
+                </a:extLst>
               </a:tr>
               <a:tr h="658368">
                 <a:tc>
@@ -16515,7 +16224,7 @@
                     <a:bodyPr/>
                     <a:lstStyle/>
                     <a:p>
-                      <a:pPr indent="0" marL="0">
+                      <a:pPr marL="0" indent="0">
                         <a:buNone/>
                       </a:pPr>
                       <a:r>
@@ -16536,7 +16245,7 @@
                       </a:endParaRPr>
                     </a:p>
                   </a:txBody>
-                  <a:tcPr marL="91440" marR="91440" marT="45720" marB="45720" anchor="ctr">
+                  <a:tcPr anchor="ctr">
                     <a:lnL w="12700" cap="flat" cmpd="sng" algn="ctr">
                       <a:solidFill>
                         <a:srgbClr val="D9E1EC"/>
@@ -16583,7 +16292,7 @@
                     <a:bodyPr/>
                     <a:lstStyle/>
                     <a:p>
-                      <a:pPr indent="0" marL="0">
+                      <a:pPr marL="0" indent="0">
                         <a:buNone/>
                       </a:pPr>
                       <a:r>
@@ -16604,7 +16313,7 @@
                       </a:endParaRPr>
                     </a:p>
                   </a:txBody>
-                  <a:tcPr marL="91440" marR="91440" marT="45720" marB="45720" anchor="ctr">
+                  <a:tcPr anchor="ctr">
                     <a:lnL w="12700" cap="flat" cmpd="sng" algn="ctr">
                       <a:solidFill>
                         <a:srgbClr val="D9E1EC"/>
@@ -16651,7 +16360,7 @@
                     <a:bodyPr/>
                     <a:lstStyle/>
                     <a:p>
-                      <a:pPr indent="0" marL="0">
+                      <a:pPr marL="0" indent="0">
                         <a:buNone/>
                       </a:pPr>
                       <a:r>
@@ -16672,7 +16381,7 @@
                       </a:endParaRPr>
                     </a:p>
                   </a:txBody>
-                  <a:tcPr marL="91440" marR="91440" marT="45720" marB="45720" anchor="ctr">
+                  <a:tcPr anchor="ctr">
                     <a:lnL w="12700" cap="flat" cmpd="sng" algn="ctr">
                       <a:solidFill>
                         <a:srgbClr val="D9E1EC"/>
@@ -16714,6 +16423,11 @@
                     </a:solidFill>
                   </a:tcPr>
                 </a:tc>
+                <a:extLst>
+                  <a:ext uri="{0D108BD9-81ED-4DB2-BD59-A6C34878D82A}">
+                    <a16:rowId xmlns:a16="http://schemas.microsoft.com/office/drawing/2014/main" val="10004"/>
+                  </a:ext>
+                </a:extLst>
               </a:tr>
               <a:tr h="658368">
                 <a:tc>
@@ -16721,7 +16435,7 @@
                     <a:bodyPr/>
                     <a:lstStyle/>
                     <a:p>
-                      <a:pPr indent="0" marL="0">
+                      <a:pPr marL="0" indent="0">
                         <a:buNone/>
                       </a:pPr>
                       <a:r>
@@ -16742,7 +16456,7 @@
                       </a:endParaRPr>
                     </a:p>
                   </a:txBody>
-                  <a:tcPr marL="91440" marR="91440" marT="45720" marB="45720" anchor="ctr">
+                  <a:tcPr anchor="ctr">
                     <a:lnL w="12700" cap="flat" cmpd="sng" algn="ctr">
                       <a:solidFill>
                         <a:srgbClr val="D9E1EC"/>
@@ -16789,7 +16503,7 @@
                     <a:bodyPr/>
                     <a:lstStyle/>
                     <a:p>
-                      <a:pPr indent="0" marL="0">
+                      <a:pPr marL="0" indent="0">
                         <a:buNone/>
                       </a:pPr>
                       <a:r>
@@ -16810,7 +16524,7 @@
                       </a:endParaRPr>
                     </a:p>
                   </a:txBody>
-                  <a:tcPr marL="91440" marR="91440" marT="45720" marB="45720" anchor="ctr">
+                  <a:tcPr anchor="ctr">
                     <a:lnL w="12700" cap="flat" cmpd="sng" algn="ctr">
                       <a:solidFill>
                         <a:srgbClr val="D9E1EC"/>
@@ -16857,7 +16571,7 @@
                     <a:bodyPr/>
                     <a:lstStyle/>
                     <a:p>
-                      <a:pPr indent="0" marL="0">
+                      <a:pPr marL="0" indent="0">
                         <a:buNone/>
                       </a:pPr>
                       <a:r>
@@ -16878,7 +16592,7 @@
                       </a:endParaRPr>
                     </a:p>
                   </a:txBody>
-                  <a:tcPr marL="91440" marR="91440" marT="45720" marB="45720" anchor="ctr">
+                  <a:tcPr anchor="ctr">
                     <a:lnL w="12700" cap="flat" cmpd="sng" algn="ctr">
                       <a:solidFill>
                         <a:srgbClr val="D9E1EC"/>
@@ -16920,6 +16634,11 @@
                     </a:solidFill>
                   </a:tcPr>
                 </a:tc>
+                <a:extLst>
+                  <a:ext uri="{0D108BD9-81ED-4DB2-BD59-A6C34878D82A}">
+                    <a16:rowId xmlns:a16="http://schemas.microsoft.com/office/drawing/2014/main" val="10005"/>
+                  </a:ext>
+                </a:extLst>
               </a:tr>
               <a:tr h="658368">
                 <a:tc>
@@ -16927,7 +16646,7 @@
                     <a:bodyPr/>
                     <a:lstStyle/>
                     <a:p>
-                      <a:pPr indent="0" marL="0">
+                      <a:pPr marL="0" indent="0">
                         <a:buNone/>
                       </a:pPr>
                       <a:r>
@@ -16948,7 +16667,7 @@
                       </a:endParaRPr>
                     </a:p>
                   </a:txBody>
-                  <a:tcPr marL="91440" marR="91440" marT="45720" marB="45720" anchor="ctr">
+                  <a:tcPr anchor="ctr">
                     <a:lnL w="12700" cap="flat" cmpd="sng" algn="ctr">
                       <a:solidFill>
                         <a:srgbClr val="D9E1EC"/>
@@ -16995,7 +16714,7 @@
                     <a:bodyPr/>
                     <a:lstStyle/>
                     <a:p>
-                      <a:pPr indent="0" marL="0">
+                      <a:pPr marL="0" indent="0">
                         <a:buNone/>
                       </a:pPr>
                       <a:r>
@@ -17016,7 +16735,7 @@
                       </a:endParaRPr>
                     </a:p>
                   </a:txBody>
-                  <a:tcPr marL="91440" marR="91440" marT="45720" marB="45720" anchor="ctr">
+                  <a:tcPr anchor="ctr">
                     <a:lnL w="12700" cap="flat" cmpd="sng" algn="ctr">
                       <a:solidFill>
                         <a:srgbClr val="D9E1EC"/>
@@ -17063,7 +16782,7 @@
                     <a:bodyPr/>
                     <a:lstStyle/>
                     <a:p>
-                      <a:pPr indent="0" marL="0">
+                      <a:pPr marL="0" indent="0">
                         <a:buNone/>
                       </a:pPr>
                       <a:r>
@@ -17084,7 +16803,7 @@
                       </a:endParaRPr>
                     </a:p>
                   </a:txBody>
-                  <a:tcPr marL="91440" marR="91440" marT="45720" marB="45720" anchor="ctr">
+                  <a:tcPr anchor="ctr">
                     <a:lnL w="12700" cap="flat" cmpd="sng" algn="ctr">
                       <a:solidFill>
                         <a:srgbClr val="D9E1EC"/>
@@ -17126,6 +16845,11 @@
                     </a:solidFill>
                   </a:tcPr>
                 </a:tc>
+                <a:extLst>
+                  <a:ext uri="{0D108BD9-81ED-4DB2-BD59-A6C34878D82A}">
+                    <a16:rowId xmlns:a16="http://schemas.microsoft.com/office/drawing/2014/main" val="10006"/>
+                  </a:ext>
+                </a:extLst>
               </a:tr>
             </a:tbl>
           </a:graphicData>
@@ -17432,4 +17156,299 @@
     </a:ext>
   </a:extLst>
 </a:theme>
+</file>
+
+<file path=ppt/theme/theme2.xml><?xml version="1.0" encoding="utf-8"?>
+<a:theme xmlns:a="http://schemas.openxmlformats.org/drawingml/2006/main" name="Office Theme">
+  <a:themeElements>
+    <a:clrScheme name="Office">
+      <a:dk1>
+        <a:sysClr val="windowText" lastClr="000000"/>
+      </a:dk1>
+      <a:lt1>
+        <a:sysClr val="window" lastClr="FFFFFF"/>
+      </a:lt1>
+      <a:dk2>
+        <a:srgbClr val="44546A"/>
+      </a:dk2>
+      <a:lt2>
+        <a:srgbClr val="E7E6E6"/>
+      </a:lt2>
+      <a:accent1>
+        <a:srgbClr val="4472C4"/>
+      </a:accent1>
+      <a:accent2>
+        <a:srgbClr val="ED7D31"/>
+      </a:accent2>
+      <a:accent3>
+        <a:srgbClr val="A5A5A5"/>
+      </a:accent3>
+      <a:accent4>
+        <a:srgbClr val="FFC000"/>
+      </a:accent4>
+      <a:accent5>
+        <a:srgbClr val="5B9BD5"/>
+      </a:accent5>
+      <a:accent6>
+        <a:srgbClr val="70AD47"/>
+      </a:accent6>
+      <a:hlink>
+        <a:srgbClr val="0563C1"/>
+      </a:hlink>
+      <a:folHlink>
+        <a:srgbClr val="954F72"/>
+      </a:folHlink>
+    </a:clrScheme>
+    <a:fontScheme name="Office">
+      <a:majorFont>
+        <a:latin typeface="Calibri Light" panose="020F0302020204030204"/>
+        <a:ea typeface=""/>
+        <a:cs typeface=""/>
+        <a:font script="Jpan" typeface="游ゴシック Light"/>
+        <a:font script="Hang" typeface="맑은 고딕"/>
+        <a:font script="Hans" typeface="等线 Light"/>
+        <a:font script="Hant" typeface="新細明體"/>
+        <a:font script="Arab" typeface="Times New Roman"/>
+        <a:font script="Hebr" typeface="Times New Roman"/>
+        <a:font script="Thai" typeface="Angsana New"/>
+        <a:font script="Ethi" typeface="Nyala"/>
+        <a:font script="Beng" typeface="Vrinda"/>
+        <a:font script="Gujr" typeface="Shruti"/>
+        <a:font script="Khmr" typeface="MoolBoran"/>
+        <a:font script="Knda" typeface="Tunga"/>
+        <a:font script="Guru" typeface="Raavi"/>
+        <a:font script="Cans" typeface="Euphemia"/>
+        <a:font script="Cher" typeface="Plantagenet Cherokee"/>
+        <a:font script="Yiii" typeface="Microsoft Yi Baiti"/>
+        <a:font script="Tibt" typeface="Microsoft Himalaya"/>
+        <a:font script="Thaa" typeface="MV Boli"/>
+        <a:font script="Deva" typeface="Mangal"/>
+        <a:font script="Telu" typeface="Gautami"/>
+        <a:font script="Taml" typeface="Latha"/>
+        <a:font script="Syrc" typeface="Estrangelo Edessa"/>
+        <a:font script="Orya" typeface="Kalinga"/>
+        <a:font script="Mlym" typeface="Kartika"/>
+        <a:font script="Laoo" typeface="DokChampa"/>
+        <a:font script="Sinh" typeface="Iskoola Pota"/>
+        <a:font script="Mong" typeface="Mongolian Baiti"/>
+        <a:font script="Viet" typeface="Times New Roman"/>
+        <a:font script="Uigh" typeface="Microsoft Uighur"/>
+        <a:font script="Geor" typeface="Sylfaen"/>
+        <a:font script="Armn" typeface="Arial"/>
+        <a:font script="Bugi" typeface="Leelawadee UI"/>
+        <a:font script="Bopo" typeface="Microsoft JhengHei"/>
+        <a:font script="Java" typeface="Javanese Text"/>
+        <a:font script="Lisu" typeface="Segoe UI"/>
+        <a:font script="Mymr" typeface="Myanmar Text"/>
+        <a:font script="Nkoo" typeface="Ebrima"/>
+        <a:font script="Olck" typeface="Nirmala UI"/>
+        <a:font script="Osma" typeface="Ebrima"/>
+        <a:font script="Phag" typeface="Phagspa"/>
+        <a:font script="Syrn" typeface="Estrangelo Edessa"/>
+        <a:font script="Syrj" typeface="Estrangelo Edessa"/>
+        <a:font script="Syre" typeface="Estrangelo Edessa"/>
+        <a:font script="Sora" typeface="Nirmala UI"/>
+        <a:font script="Tale" typeface="Microsoft Tai Le"/>
+        <a:font script="Talu" typeface="Microsoft New Tai Lue"/>
+        <a:font script="Tfng" typeface="Ebrima"/>
+      </a:majorFont>
+      <a:minorFont>
+        <a:latin typeface="Calibri" panose="020F0502020204030204"/>
+        <a:ea typeface=""/>
+        <a:cs typeface=""/>
+        <a:font script="Jpan" typeface="游ゴシック"/>
+        <a:font script="Hang" typeface="맑은 고딕"/>
+        <a:font script="Hans" typeface="等线"/>
+        <a:font script="Hant" typeface="新細明體"/>
+        <a:font script="Arab" typeface="Arial"/>
+        <a:font script="Hebr" typeface="Arial"/>
+        <a:font script="Thai" typeface="Cordia New"/>
+        <a:font script="Ethi" typeface="Nyala"/>
+        <a:font script="Beng" typeface="Vrinda"/>
+        <a:font script="Gujr" typeface="Shruti"/>
+        <a:font script="Khmr" typeface="DaunPenh"/>
+        <a:font script="Knda" typeface="Tunga"/>
+        <a:font script="Guru" typeface="Raavi"/>
+        <a:font script="Cans" typeface="Euphemia"/>
+        <a:font script="Cher" typeface="Plantagenet Cherokee"/>
+        <a:font script="Yiii" typeface="Microsoft Yi Baiti"/>
+        <a:font script="Tibt" typeface="Microsoft Himalaya"/>
+        <a:font script="Thaa" typeface="MV Boli"/>
+        <a:font script="Deva" typeface="Mangal"/>
+        <a:font script="Telu" typeface="Gautami"/>
+        <a:font script="Taml" typeface="Latha"/>
+        <a:font script="Syrc" typeface="Estrangelo Edessa"/>
+        <a:font script="Orya" typeface="Kalinga"/>
+        <a:font script="Mlym" typeface="Kartika"/>
+        <a:font script="Laoo" typeface="DokChampa"/>
+        <a:font script="Sinh" typeface="Iskoola Pota"/>
+        <a:font script="Mong" typeface="Mongolian Baiti"/>
+        <a:font script="Viet" typeface="Arial"/>
+        <a:font script="Uigh" typeface="Microsoft Uighur"/>
+        <a:font script="Geor" typeface="Sylfaen"/>
+        <a:font script="Armn" typeface="Arial"/>
+        <a:font script="Bugi" typeface="Leelawadee UI"/>
+        <a:font script="Bopo" typeface="Microsoft JhengHei"/>
+        <a:font script="Java" typeface="Javanese Text"/>
+        <a:font script="Lisu" typeface="Segoe UI"/>
+        <a:font script="Mymr" typeface="Myanmar Text"/>
+        <a:font script="Nkoo" typeface="Ebrima"/>
+        <a:font script="Olck" typeface="Nirmala UI"/>
+        <a:font script="Osma" typeface="Ebrima"/>
+        <a:font script="Phag" typeface="Phagspa"/>
+        <a:font script="Syrn" typeface="Estrangelo Edessa"/>
+        <a:font script="Syrj" typeface="Estrangelo Edessa"/>
+        <a:font script="Syre" typeface="Estrangelo Edessa"/>
+        <a:font script="Sora" typeface="Nirmala UI"/>
+        <a:font script="Tale" typeface="Microsoft Tai Le"/>
+        <a:font script="Talu" typeface="Microsoft New Tai Lue"/>
+        <a:font script="Tfng" typeface="Ebrima"/>
+      </a:minorFont>
+    </a:fontScheme>
+    <a:fmtScheme name="Office">
+      <a:fillStyleLst>
+        <a:solidFill>
+          <a:schemeClr val="phClr"/>
+        </a:solidFill>
+        <a:gradFill rotWithShape="1">
+          <a:gsLst>
+            <a:gs pos="0">
+              <a:schemeClr val="phClr">
+                <a:lumMod val="110000"/>
+                <a:satMod val="105000"/>
+                <a:tint val="67000"/>
+              </a:schemeClr>
+            </a:gs>
+            <a:gs pos="50000">
+              <a:schemeClr val="phClr">
+                <a:lumMod val="105000"/>
+                <a:satMod val="103000"/>
+                <a:tint val="73000"/>
+              </a:schemeClr>
+            </a:gs>
+            <a:gs pos="100000">
+              <a:schemeClr val="phClr">
+                <a:lumMod val="105000"/>
+                <a:satMod val="109000"/>
+                <a:tint val="81000"/>
+              </a:schemeClr>
+            </a:gs>
+          </a:gsLst>
+          <a:lin ang="5400000" scaled="0"/>
+        </a:gradFill>
+        <a:gradFill rotWithShape="1">
+          <a:gsLst>
+            <a:gs pos="0">
+              <a:schemeClr val="phClr">
+                <a:satMod val="103000"/>
+                <a:lumMod val="102000"/>
+                <a:tint val="94000"/>
+              </a:schemeClr>
+            </a:gs>
+            <a:gs pos="50000">
+              <a:schemeClr val="phClr">
+                <a:satMod val="110000"/>
+                <a:lumMod val="100000"/>
+                <a:shade val="100000"/>
+              </a:schemeClr>
+            </a:gs>
+            <a:gs pos="100000">
+              <a:schemeClr val="phClr">
+                <a:lumMod val="99000"/>
+                <a:satMod val="120000"/>
+                <a:shade val="78000"/>
+              </a:schemeClr>
+            </a:gs>
+          </a:gsLst>
+          <a:lin ang="5400000" scaled="0"/>
+        </a:gradFill>
+      </a:fillStyleLst>
+      <a:lnStyleLst>
+        <a:ln w="6350" cap="flat" cmpd="sng" algn="ctr">
+          <a:solidFill>
+            <a:schemeClr val="phClr"/>
+          </a:solidFill>
+          <a:prstDash val="solid"/>
+          <a:miter lim="800000"/>
+        </a:ln>
+        <a:ln w="12700" cap="flat" cmpd="sng" algn="ctr">
+          <a:solidFill>
+            <a:schemeClr val="phClr"/>
+          </a:solidFill>
+          <a:prstDash val="solid"/>
+          <a:miter lim="800000"/>
+        </a:ln>
+        <a:ln w="19050" cap="flat" cmpd="sng" algn="ctr">
+          <a:solidFill>
+            <a:schemeClr val="phClr"/>
+          </a:solidFill>
+          <a:prstDash val="solid"/>
+          <a:miter lim="800000"/>
+        </a:ln>
+      </a:lnStyleLst>
+      <a:effectStyleLst>
+        <a:effectStyle>
+          <a:effectLst/>
+        </a:effectStyle>
+        <a:effectStyle>
+          <a:effectLst/>
+        </a:effectStyle>
+        <a:effectStyle>
+          <a:effectLst>
+            <a:outerShdw blurRad="57150" dist="19050" dir="5400000" algn="ctr" rotWithShape="0">
+              <a:srgbClr val="000000">
+                <a:alpha val="63000"/>
+              </a:srgbClr>
+            </a:outerShdw>
+          </a:effectLst>
+        </a:effectStyle>
+      </a:effectStyleLst>
+      <a:bgFillStyleLst>
+        <a:solidFill>
+          <a:schemeClr val="phClr"/>
+        </a:solidFill>
+        <a:solidFill>
+          <a:schemeClr val="phClr">
+            <a:tint val="95000"/>
+            <a:satMod val="170000"/>
+          </a:schemeClr>
+        </a:solidFill>
+        <a:gradFill rotWithShape="1">
+          <a:gsLst>
+            <a:gs pos="0">
+              <a:schemeClr val="phClr">
+                <a:tint val="93000"/>
+                <a:satMod val="150000"/>
+                <a:shade val="98000"/>
+                <a:lumMod val="102000"/>
+              </a:schemeClr>
+            </a:gs>
+            <a:gs pos="50000">
+              <a:schemeClr val="phClr">
+                <a:tint val="98000"/>
+                <a:satMod val="130000"/>
+                <a:shade val="90000"/>
+                <a:lumMod val="103000"/>
+              </a:schemeClr>
+            </a:gs>
+            <a:gs pos="100000">
+              <a:schemeClr val="phClr">
+                <a:shade val="63000"/>
+                <a:satMod val="120000"/>
+              </a:schemeClr>
+            </a:gs>
+          </a:gsLst>
+          <a:lin ang="5400000" scaled="0"/>
+        </a:gradFill>
+      </a:bgFillStyleLst>
+    </a:fmtScheme>
+  </a:themeElements>
+  <a:objectDefaults/>
+  <a:extraClrSchemeLst/>
+  <a:extLst>
+    <a:ext uri="{05A4C25C-085E-4340-85A3-A5531E510DB2}">
+      <thm15:themeFamily xmlns:thm15="http://schemas.microsoft.com/office/thememl/2012/main" name="Office Theme" id="{62F939B6-93AF-4DB8-9C6B-D6C7DFDC589F}" vid="{4A3C46E8-61CC-4603-A589-7422A47A8E4A}"/>
+    </a:ext>
+  </a:extLst>
+</a:theme>
 </file>
</xml_diff>